<commit_message>
docs: add 'where it can be used' and status slides to the presentation
</commit_message>
<xml_diff>
--- a/docs/presentation/GymBuddy_Lab1_Presentation.pptx
+++ b/docs/presentation/GymBuddy_Lab1_Presentation.pptx
@@ -18,6 +18,8 @@
     <p:sldId id="266" r:id="rId17"/>
     <p:sldId id="267" r:id="rId18"/>
     <p:sldId id="268" r:id="rId19"/>
+    <p:sldId id="269" r:id="rId20"/>
+    <p:sldId id="270" r:id="rId21"/>
   </p:sldIdLst>
   <p:sldSz cx="12191695" cy="6858000" type="screen4x3"/>
   <p:notesSz cx="6858000" cy="9144000"/>
@@ -3293,7 +3295,7 @@
                   <a:srgbClr val="CBD5E1"/>
                 </a:solidFill>
               </a:rPr>
-              <a:t>Team Project â€“ Mobile Application in the Cloud Â· Lab 1</a:t>
+              <a:t>Team Project – Mobile Application in the Cloud · Lab 1</a:t>
             </a:r>
           </a:p>
           <a:p>
@@ -3304,7 +3306,7 @@
                   <a:srgbClr val="FFFFFF"/>
                 </a:solidFill>
               </a:rPr>
-              <a:t>Aida Ismayilova (57689)  Â·  Ozodbek Tursunaliyev (57264)  Â·  Elturan Valizada (58990)</a:t>
+              <a:t>Aida Ismayilova (57689)  ·  Ozodbek Tursunaliyev (57264)  ·  Elturan Valizada (58990)</a:t>
             </a:r>
           </a:p>
         </p:txBody>
@@ -3374,6 +3376,517 @@
                   <a:srgbClr val="FFFFFF"/>
                 </a:solidFill>
               </a:rPr>
+              <a:t>Sprint 1 backlog</a:t>
+            </a:r>
+          </a:p>
+          <a:p>
+            <a:pPr algn="l"/>
+            <a:r>
+              <a:rPr sz="1500" b="0">
+                <a:solidFill>
+                  <a:srgbClr val="FDBA74"/>
+                </a:solidFill>
+              </a:rPr>
+              <a:t>Each story has acceptance criteria and an assignee</a:t>
+            </a:r>
+          </a:p>
+        </p:txBody>
+      </p:sp>
+      <p:sp>
+        <p:nvSpPr>
+          <p:cNvPr id="3" name="Rectangle 2"/>
+          <p:cNvSpPr/>
+          <p:nvPr/>
+        </p:nvSpPr>
+        <p:spPr>
+          <a:xfrm>
+            <a:off x="0" y="1097280"/>
+            <a:ext cx="12191695" cy="64008"/>
+          </a:xfrm>
+          <a:prstGeom prst="rect">
+            <a:avLst/>
+          </a:prstGeom>
+          <a:solidFill>
+            <a:srgbClr val="F97316"/>
+          </a:solidFill>
+          <a:ln>
+            <a:noFill/>
+          </a:ln>
+          <a:effectLst/>
+        </p:spPr>
+        <p:style>
+          <a:lnRef idx="1">
+            <a:schemeClr val="accent1"/>
+          </a:lnRef>
+          <a:fillRef idx="3">
+            <a:schemeClr val="accent1"/>
+          </a:fillRef>
+          <a:effectRef idx="2">
+            <a:schemeClr val="accent1"/>
+          </a:effectRef>
+          <a:fontRef idx="minor">
+            <a:schemeClr val="lt1"/>
+          </a:fontRef>
+        </p:style>
+        <p:txBody>
+          <a:bodyPr rtlCol="0" anchor="ctr"/>
+          <a:lstStyle/>
+          <a:p>
+            <a:pPr algn="ctr"/>
+          </a:p>
+        </p:txBody>
+      </p:sp>
+      <p:graphicFrame>
+        <p:nvGraphicFramePr>
+          <p:cNvPr id="4" name="Table 3"/>
+          <p:cNvGraphicFramePr>
+            <a:graphicFrameLocks noGrp="1"/>
+          </p:cNvGraphicFramePr>
+          <p:nvPr/>
+        </p:nvGraphicFramePr>
+        <p:xfrm>
+          <a:off x="640080" y="1645920"/>
+          <a:ext cx="10881360" cy="3657600"/>
+        </p:xfrm>
+        <a:graphic>
+          <a:graphicData uri="http://schemas.openxmlformats.org/drawingml/2006/table">
+            <a:tbl>
+              <a:tblPr firstRow="1" bandRow="1">
+                <a:tableStyleId>{5C22544A-7EE6-4342-B048-85BDC9FD1C3A}</a:tableStyleId>
+              </a:tblPr>
+              <a:tblGrid>
+                <a:gridCol w="6035040"/>
+                <a:gridCol w="3566160"/>
+                <a:gridCol w="1280160"/>
+              </a:tblGrid>
+              <a:tr h="731520">
+                <a:tc>
+                  <a:txBody>
+                    <a:bodyPr/>
+                    <a:lstStyle/>
+                    <a:p>
+                      <a:r>
+                        <a:rPr sz="1600" b="1">
+                          <a:solidFill>
+                            <a:srgbClr val="FFFFFF"/>
+                          </a:solidFill>
+                        </a:rPr>
+                        <a:t>User story</a:t>
+                      </a:r>
+                    </a:p>
+                  </a:txBody>
+                  <a:tcPr>
+                    <a:solidFill>
+                      <a:srgbClr val="111827"/>
+                    </a:solidFill>
+                  </a:tcPr>
+                </a:tc>
+                <a:tc>
+                  <a:txBody>
+                    <a:bodyPr/>
+                    <a:lstStyle/>
+                    <a:p>
+                      <a:r>
+                        <a:rPr sz="1600" b="1">
+                          <a:solidFill>
+                            <a:srgbClr val="FFFFFF"/>
+                          </a:solidFill>
+                        </a:rPr>
+                        <a:t>Labels</a:t>
+                      </a:r>
+                    </a:p>
+                  </a:txBody>
+                  <a:tcPr>
+                    <a:solidFill>
+                      <a:srgbClr val="111827"/>
+                    </a:solidFill>
+                  </a:tcPr>
+                </a:tc>
+                <a:tc>
+                  <a:txBody>
+                    <a:bodyPr/>
+                    <a:lstStyle/>
+                    <a:p>
+                      <a:r>
+                        <a:rPr sz="1600" b="1">
+                          <a:solidFill>
+                            <a:srgbClr val="FFFFFF"/>
+                          </a:solidFill>
+                        </a:rPr>
+                        <a:t>Assignee</a:t>
+                      </a:r>
+                    </a:p>
+                  </a:txBody>
+                  <a:tcPr>
+                    <a:solidFill>
+                      <a:srgbClr val="111827"/>
+                    </a:solidFill>
+                  </a:tcPr>
+                </a:tc>
+              </a:tr>
+              <a:tr h="731520">
+                <a:tc>
+                  <a:txBody>
+                    <a:bodyPr/>
+                    <a:lstStyle/>
+                    <a:p>
+                      <a:r>
+                        <a:rPr sz="1600" b="0">
+                          <a:solidFill>
+                            <a:srgbClr val="0F172A"/>
+                          </a:solidFill>
+                        </a:rPr>
+                        <a:t>As a gym-goer, I want to register and log in with email and password</a:t>
+                      </a:r>
+                    </a:p>
+                  </a:txBody>
+                  <a:tcPr>
+                    <a:solidFill>
+                      <a:srgbClr val="F1F5F9"/>
+                    </a:solidFill>
+                  </a:tcPr>
+                </a:tc>
+                <a:tc>
+                  <a:txBody>
+                    <a:bodyPr/>
+                    <a:lstStyle/>
+                    <a:p>
+                      <a:r>
+                        <a:rPr sz="1600" b="0">
+                          <a:solidFill>
+                            <a:srgbClr val="0F172A"/>
+                          </a:solidFill>
+                        </a:rPr>
+                        <a:t>user-story · android · firebase</a:t>
+                      </a:r>
+                    </a:p>
+                  </a:txBody>
+                  <a:tcPr>
+                    <a:solidFill>
+                      <a:srgbClr val="F1F5F9"/>
+                    </a:solidFill>
+                  </a:tcPr>
+                </a:tc>
+                <a:tc>
+                  <a:txBody>
+                    <a:bodyPr/>
+                    <a:lstStyle/>
+                    <a:p>
+                      <a:r>
+                        <a:rPr sz="1600" b="0">
+                          <a:solidFill>
+                            <a:srgbClr val="0F172A"/>
+                          </a:solidFill>
+                        </a:rPr>
+                        <a:t>Ozodbek</a:t>
+                      </a:r>
+                    </a:p>
+                  </a:txBody>
+                  <a:tcPr>
+                    <a:solidFill>
+                      <a:srgbClr val="F1F5F9"/>
+                    </a:solidFill>
+                  </a:tcPr>
+                </a:tc>
+              </a:tr>
+              <a:tr h="731520">
+                <a:tc>
+                  <a:txBody>
+                    <a:bodyPr/>
+                    <a:lstStyle/>
+                    <a:p>
+                      <a:r>
+                        <a:rPr sz="1600" b="0">
+                          <a:solidFill>
+                            <a:srgbClr val="0F172A"/>
+                          </a:solidFill>
+                        </a:rPr>
+                        <a:t>As a gym-goer, I want to see a list of my workouts</a:t>
+                      </a:r>
+                    </a:p>
+                  </a:txBody>
+                  <a:tcPr>
+                    <a:solidFill>
+                      <a:srgbClr val="FFFFFF"/>
+                    </a:solidFill>
+                  </a:tcPr>
+                </a:tc>
+                <a:tc>
+                  <a:txBody>
+                    <a:bodyPr/>
+                    <a:lstStyle/>
+                    <a:p>
+                      <a:r>
+                        <a:rPr sz="1600" b="0">
+                          <a:solidFill>
+                            <a:srgbClr val="0F172A"/>
+                          </a:solidFill>
+                        </a:rPr>
+                        <a:t>user-story · android · ui</a:t>
+                      </a:r>
+                    </a:p>
+                  </a:txBody>
+                  <a:tcPr>
+                    <a:solidFill>
+                      <a:srgbClr val="FFFFFF"/>
+                    </a:solidFill>
+                  </a:tcPr>
+                </a:tc>
+                <a:tc>
+                  <a:txBody>
+                    <a:bodyPr/>
+                    <a:lstStyle/>
+                    <a:p>
+                      <a:r>
+                        <a:rPr sz="1600" b="0">
+                          <a:solidFill>
+                            <a:srgbClr val="0F172A"/>
+                          </a:solidFill>
+                        </a:rPr>
+                        <a:t>Elturan</a:t>
+                      </a:r>
+                    </a:p>
+                  </a:txBody>
+                  <a:tcPr>
+                    <a:solidFill>
+                      <a:srgbClr val="FFFFFF"/>
+                    </a:solidFill>
+                  </a:tcPr>
+                </a:tc>
+              </a:tr>
+              <a:tr h="731520">
+                <a:tc>
+                  <a:txBody>
+                    <a:bodyPr/>
+                    <a:lstStyle/>
+                    <a:p>
+                      <a:r>
+                        <a:rPr sz="1600" b="0">
+                          <a:solidFill>
+                            <a:srgbClr val="0F172A"/>
+                          </a:solidFill>
+                        </a:rPr>
+                        <a:t>As a gym-goer, I want to add a workout</a:t>
+                      </a:r>
+                    </a:p>
+                  </a:txBody>
+                  <a:tcPr>
+                    <a:solidFill>
+                      <a:srgbClr val="F1F5F9"/>
+                    </a:solidFill>
+                  </a:tcPr>
+                </a:tc>
+                <a:tc>
+                  <a:txBody>
+                    <a:bodyPr/>
+                    <a:lstStyle/>
+                    <a:p>
+                      <a:r>
+                        <a:rPr sz="1600" b="0">
+                          <a:solidFill>
+                            <a:srgbClr val="0F172A"/>
+                          </a:solidFill>
+                        </a:rPr>
+                        <a:t>user-story · android · firebase</a:t>
+                      </a:r>
+                    </a:p>
+                  </a:txBody>
+                  <a:tcPr>
+                    <a:solidFill>
+                      <a:srgbClr val="F1F5F9"/>
+                    </a:solidFill>
+                  </a:tcPr>
+                </a:tc>
+                <a:tc>
+                  <a:txBody>
+                    <a:bodyPr/>
+                    <a:lstStyle/>
+                    <a:p>
+                      <a:r>
+                        <a:rPr sz="1600" b="0">
+                          <a:solidFill>
+                            <a:srgbClr val="0F172A"/>
+                          </a:solidFill>
+                        </a:rPr>
+                        <a:t>Aida</a:t>
+                      </a:r>
+                    </a:p>
+                  </a:txBody>
+                  <a:tcPr>
+                    <a:solidFill>
+                      <a:srgbClr val="F1F5F9"/>
+                    </a:solidFill>
+                  </a:tcPr>
+                </a:tc>
+              </a:tr>
+              <a:tr h="731520">
+                <a:tc>
+                  <a:txBody>
+                    <a:bodyPr/>
+                    <a:lstStyle/>
+                    <a:p>
+                      <a:r>
+                        <a:rPr sz="1600" b="0">
+                          <a:solidFill>
+                            <a:srgbClr val="0F172A"/>
+                          </a:solidFill>
+                        </a:rPr>
+                        <a:t>As a gym-goer, I want to edit or delete a workout</a:t>
+                      </a:r>
+                    </a:p>
+                  </a:txBody>
+                  <a:tcPr>
+                    <a:solidFill>
+                      <a:srgbClr val="FFFFFF"/>
+                    </a:solidFill>
+                  </a:tcPr>
+                </a:tc>
+                <a:tc>
+                  <a:txBody>
+                    <a:bodyPr/>
+                    <a:lstStyle/>
+                    <a:p>
+                      <a:r>
+                        <a:rPr sz="1600" b="0">
+                          <a:solidFill>
+                            <a:srgbClr val="0F172A"/>
+                          </a:solidFill>
+                        </a:rPr>
+                        <a:t>user-story · android · firebase</a:t>
+                      </a:r>
+                    </a:p>
+                  </a:txBody>
+                  <a:tcPr>
+                    <a:solidFill>
+                      <a:srgbClr val="FFFFFF"/>
+                    </a:solidFill>
+                  </a:tcPr>
+                </a:tc>
+                <a:tc>
+                  <a:txBody>
+                    <a:bodyPr/>
+                    <a:lstStyle/>
+                    <a:p>
+                      <a:r>
+                        <a:rPr sz="1600" b="0">
+                          <a:solidFill>
+                            <a:srgbClr val="0F172A"/>
+                          </a:solidFill>
+                        </a:rPr>
+                        <a:t>Elturan</a:t>
+                      </a:r>
+                    </a:p>
+                  </a:txBody>
+                  <a:tcPr>
+                    <a:solidFill>
+                      <a:srgbClr val="FFFFFF"/>
+                    </a:solidFill>
+                  </a:tcPr>
+                </a:tc>
+              </a:tr>
+            </a:tbl>
+          </a:graphicData>
+        </a:graphic>
+      </p:graphicFrame>
+      <p:sp>
+        <p:nvSpPr>
+          <p:cNvPr id="5" name="TextBox 4"/>
+          <p:cNvSpPr txBox="1"/>
+          <p:nvPr/>
+        </p:nvSpPr>
+        <p:spPr>
+          <a:xfrm>
+            <a:off x="640080" y="5486400"/>
+            <a:ext cx="10881360" cy="914400"/>
+          </a:xfrm>
+          <a:prstGeom prst="rect">
+            <a:avLst/>
+          </a:prstGeom>
+          <a:noFill/>
+        </p:spPr>
+        <p:txBody>
+          <a:bodyPr wrap="square">
+            <a:spAutoFit/>
+          </a:bodyPr>
+          <a:lstStyle/>
+          <a:p>
+            <a:pPr algn="l"/>
+            <a:r>
+              <a:rPr sz="1700" b="0">
+                <a:solidFill>
+                  <a:srgbClr val="64748B"/>
+                </a:solidFill>
+              </a:rPr>
+              <a:t>Backlog: weekly stats Cloud Function, find a partner (sessions).</a:t>
+            </a:r>
+          </a:p>
+        </p:txBody>
+      </p:sp>
+    </p:spTree>
+  </p:cSld>
+  <p:clrMapOvr>
+    <a:masterClrMapping/>
+  </p:clrMapOvr>
+</p:sld>
+</file>
+
+<file path=ppt/slides/slide11.xml><?xml version="1.0" encoding="utf-8"?>
+<p:sld xmlns:a="http://schemas.openxmlformats.org/drawingml/2006/main" xmlns:p="http://schemas.openxmlformats.org/presentationml/2006/main" xmlns:r="http://schemas.openxmlformats.org/officeDocument/2006/relationships">
+  <p:cSld>
+    <p:spTree>
+      <p:nvGrpSpPr>
+        <p:cNvPr id="1" name=""/>
+        <p:cNvGrpSpPr/>
+        <p:nvPr/>
+      </p:nvGrpSpPr>
+      <p:grpSpPr/>
+      <p:sp>
+        <p:nvSpPr>
+          <p:cNvPr id="2" name="Rectangle 1"/>
+          <p:cNvSpPr/>
+          <p:nvPr/>
+        </p:nvSpPr>
+        <p:spPr>
+          <a:xfrm>
+            <a:off x="0" y="0"/>
+            <a:ext cx="12191695" cy="1097280"/>
+          </a:xfrm>
+          <a:prstGeom prst="rect">
+            <a:avLst/>
+          </a:prstGeom>
+          <a:solidFill>
+            <a:srgbClr val="111827"/>
+          </a:solidFill>
+          <a:ln>
+            <a:noFill/>
+          </a:ln>
+          <a:effectLst/>
+        </p:spPr>
+        <p:style>
+          <a:lnRef idx="1">
+            <a:schemeClr val="accent1"/>
+          </a:lnRef>
+          <a:fillRef idx="3">
+            <a:schemeClr val="accent1"/>
+          </a:fillRef>
+          <a:effectRef idx="2">
+            <a:schemeClr val="accent1"/>
+          </a:effectRef>
+          <a:fontRef idx="minor">
+            <a:schemeClr val="lt1"/>
+          </a:fontRef>
+        </p:style>
+        <p:txBody>
+          <a:bodyPr rtlCol="0" anchor="ctr" wrap="square" lIns="457200" rIns="457200" tIns="73152" bIns="73152"/>
+          <a:lstStyle/>
+          <a:p>
+            <a:pPr algn="ctr"/>
+            <a:r>
+              <a:rPr sz="3200" b="1">
+                <a:solidFill>
+                  <a:srgbClr val="FFFFFF"/>
+                </a:solidFill>
+              </a:rPr>
               <a:t>Team and roles</a:t>
             </a:r>
           </a:p>
@@ -3385,7 +3898,7 @@
                   <a:srgbClr val="FDBA74"/>
                 </a:solidFill>
               </a:rPr>
-              <a:t>Everyone writes code â€“ roles say who is accountable for a decision</a:t>
+              <a:t>Everyone writes code – roles say who is accountable for a decision</a:t>
             </a:r>
           </a:p>
         </p:txBody>
@@ -3761,7 +4274,7 @@
 </p:sld>
 </file>
 
-<file path=ppt/slides/slide11.xml><?xml version="1.0" encoding="utf-8"?>
+<file path=ppt/slides/slide12.xml><?xml version="1.0" encoding="utf-8"?>
 <p:sld xmlns:a="http://schemas.openxmlformats.org/drawingml/2006/main" xmlns:p="http://schemas.openxmlformats.org/presentationml/2006/main" xmlns:r="http://schemas.openxmlformats.org/officeDocument/2006/relationships">
   <p:cSld>
     <p:spTree>
@@ -4185,7 +4698,7 @@
                   <a:srgbClr val="FFFFFF"/>
                 </a:solidFill>
               </a:rPr>
-              <a:t>Squash merge â†’ Done</a:t>
+              <a:t>Squash merge → Done</a:t>
             </a:r>
           </a:p>
         </p:txBody>
@@ -4223,7 +4736,7 @@
                   <a:srgbClr val="F97316"/>
                 </a:solidFill>
               </a:rPr>
-              <a:t>â€¢  </a:t>
+              <a:t>•  </a:t>
             </a:r>
             <a:r>
               <a:rPr sz="1900" b="1">
@@ -4239,7 +4752,7 @@
                   <a:srgbClr val="64748B"/>
                 </a:solidFill>
               </a:rPr>
-              <a:t> ruleset protect-main â€“ pull request required, no force push, no deletion.</a:t>
+              <a:t> ruleset protect-main – pull request required, no force push, no deletion.</a:t>
             </a:r>
           </a:p>
           <a:p>
@@ -4254,7 +4767,7 @@
                   <a:srgbClr val="F97316"/>
                 </a:solidFill>
               </a:rPr>
-              <a:t>â€¢  </a:t>
+              <a:t>•  </a:t>
             </a:r>
             <a:r>
               <a:rPr sz="1900" b="1">
@@ -4270,7 +4783,7 @@
                   <a:srgbClr val="64748B"/>
                 </a:solidFill>
               </a:rPr>
-              <a:t> Backlog Â· Sprint 1 Â· In progress Â· In review Â· Done.</a:t>
+              <a:t> Backlog · Sprint 1 · In progress · In review · Done.</a:t>
             </a:r>
           </a:p>
           <a:p>
@@ -4285,7 +4798,7 @@
                   <a:srgbClr val="F97316"/>
                 </a:solidFill>
               </a:rPr>
-              <a:t>â€¢  </a:t>
+              <a:t>•  </a:t>
             </a:r>
             <a:r>
               <a:rPr sz="1900" b="1">
@@ -4301,7 +4814,7 @@
                   <a:srgbClr val="64748B"/>
                 </a:solidFill>
               </a:rPr>
-              <a:t> pull request template with â€œCloses #issueâ€ and a test checklist.</a:t>
+              <a:t> pull request template with “Closes #issue” and a test checklist.</a:t>
             </a:r>
           </a:p>
           <a:p>
@@ -4316,7 +4829,7 @@
                   <a:srgbClr val="F97316"/>
                 </a:solidFill>
               </a:rPr>
-              <a:t>â€¢  </a:t>
+              <a:t>•  </a:t>
             </a:r>
             <a:r>
               <a:rPr sz="1900" b="1">
@@ -4345,7 +4858,7 @@
 </p:sld>
 </file>
 
-<file path=ppt/slides/slide12.xml><?xml version="1.0" encoding="utf-8"?>
+<file path=ppt/slides/slide13.xml><?xml version="1.0" encoding="utf-8"?>
 <p:sld xmlns:a="http://schemas.openxmlformats.org/drawingml/2006/main" xmlns:p="http://schemas.openxmlformats.org/presentationml/2006/main" xmlns:r="http://schemas.openxmlformats.org/officeDocument/2006/relationships">
   <p:cSld>
     <p:spTree>
@@ -4605,7 +5118,7 @@
                             <a:srgbClr val="0F172A"/>
                           </a:solidFill>
                         </a:rPr>
-                        <a:t>Data model and architecture diagram, then the live demo: register â†’ logout â†’ login â†’ restart with auto-login</a:t>
+                        <a:t>Data model and architecture diagram, then the live demo: register → logout → login → restart with auto-login</a:t>
                       </a:r>
                     </a:p>
                   </a:txBody>
@@ -4697,7 +5210,7 @@
                   <a:srgbClr val="F97316"/>
                 </a:solidFill>
               </a:rPr>
-              <a:t>â€¢  </a:t>
+              <a:t>•  </a:t>
             </a:r>
             <a:r>
               <a:rPr sz="1800" b="0">
@@ -4705,7 +5218,7 @@
                   <a:srgbClr val="0F172A"/>
                 </a:solidFill>
               </a:rPr>
-              <a:t>Expected question: â€œWhere do you check that a user only edits their own data?â€ â†’ In Firebase Security Rules (Lab 2), not only in the app.</a:t>
+              <a:t>Expected question: “Where do you check that a user only edits their own data?” → In Firebase Security Rules (Lab 2), not only in the app.</a:t>
             </a:r>
           </a:p>
         </p:txBody>
@@ -4718,7 +5231,7 @@
 </p:sld>
 </file>
 
-<file path=ppt/slides/slide13.xml><?xml version="1.0" encoding="utf-8"?>
+<file path=ppt/slides/slide14.xml><?xml version="1.0" encoding="utf-8"?>
 <p:sld xmlns:a="http://schemas.openxmlformats.org/drawingml/2006/main" xmlns:p="http://schemas.openxmlformats.org/presentationml/2006/main" xmlns:r="http://schemas.openxmlformats.org/officeDocument/2006/relationships">
   <p:cSld>
     <p:spTree>
@@ -4775,7 +5288,7 @@
                   <a:srgbClr val="FFFFFF"/>
                 </a:solidFill>
               </a:rPr>
-              <a:t>What's next</a:t>
+              <a:t>Where we are now</a:t>
             </a:r>
           </a:p>
           <a:p>
@@ -4786,7 +5299,7 @@
                   <a:srgbClr val="FDBA74"/>
                 </a:solidFill>
               </a:rPr>
-              <a:t>Lab 1 delivers the walking skeleton</a:t>
+              <a:t>Lab 1 checklist: done and still to do</a:t>
             </a:r>
           </a:p>
         </p:txBody>
@@ -4835,6 +5348,421 @@
           </a:p>
         </p:txBody>
       </p:sp>
+      <p:graphicFrame>
+        <p:nvGraphicFramePr>
+          <p:cNvPr id="4" name="Table 3"/>
+          <p:cNvGraphicFramePr>
+            <a:graphicFrameLocks noGrp="1"/>
+          </p:cNvGraphicFramePr>
+          <p:nvPr/>
+        </p:nvGraphicFramePr>
+        <p:xfrm>
+          <a:off x="640080" y="1645920"/>
+          <a:ext cx="10881360" cy="4663440"/>
+        </p:xfrm>
+        <a:graphic>
+          <a:graphicData uri="http://schemas.openxmlformats.org/drawingml/2006/table">
+            <a:tbl>
+              <a:tblPr firstRow="1" bandRow="1">
+                <a:tableStyleId>{5C22544A-7EE6-4342-B048-85BDC9FD1C3A}</a:tableStyleId>
+              </a:tblPr>
+              <a:tblGrid>
+                <a:gridCol w="5440680"/>
+                <a:gridCol w="5440680"/>
+              </a:tblGrid>
+              <a:tr h="777240">
+                <a:tc>
+                  <a:txBody>
+                    <a:bodyPr/>
+                    <a:lstStyle/>
+                    <a:p>
+                      <a:r>
+                        <a:rPr sz="1500" b="1">
+                          <a:solidFill>
+                            <a:srgbClr val="FFFFFF"/>
+                          </a:solidFill>
+                        </a:rPr>
+                        <a:t>Done</a:t>
+                      </a:r>
+                    </a:p>
+                  </a:txBody>
+                  <a:tcPr>
+                    <a:solidFill>
+                      <a:srgbClr val="111827"/>
+                    </a:solidFill>
+                  </a:tcPr>
+                </a:tc>
+                <a:tc>
+                  <a:txBody>
+                    <a:bodyPr/>
+                    <a:lstStyle/>
+                    <a:p>
+                      <a:r>
+                        <a:rPr sz="1500" b="1">
+                          <a:solidFill>
+                            <a:srgbClr val="FFFFFF"/>
+                          </a:solidFill>
+                        </a:rPr>
+                        <a:t>Still to do</a:t>
+                      </a:r>
+                    </a:p>
+                  </a:txBody>
+                  <a:tcPr>
+                    <a:solidFill>
+                      <a:srgbClr val="111827"/>
+                    </a:solidFill>
+                  </a:tcPr>
+                </a:tc>
+              </a:tr>
+              <a:tr h="777240">
+                <a:tc>
+                  <a:txBody>
+                    <a:bodyPr/>
+                    <a:lstStyle/>
+                    <a:p>
+                      <a:r>
+                        <a:rPr sz="1500" b="0">
+                          <a:solidFill>
+                            <a:srgbClr val="0F172A"/>
+                          </a:solidFill>
+                        </a:rPr>
+                        <a:t>Problem statement, MVP, data model and architecture in the README</a:t>
+                      </a:r>
+                    </a:p>
+                  </a:txBody>
+                  <a:tcPr>
+                    <a:solidFill>
+                      <a:srgbClr val="F1F5F9"/>
+                    </a:solidFill>
+                  </a:tcPr>
+                </a:tc>
+                <a:tc>
+                  <a:txBody>
+                    <a:bodyPr/>
+                    <a:lstStyle/>
+                    <a:p>
+                      <a:r>
+                        <a:rPr sz="1500" b="0">
+                          <a:solidFill>
+                            <a:srgbClr val="0F172A"/>
+                          </a:solidFill>
+                        </a:rPr>
+                        <a:t>Sprint board with 5 columns and issues in the right columns</a:t>
+                      </a:r>
+                    </a:p>
+                  </a:txBody>
+                  <a:tcPr>
+                    <a:solidFill>
+                      <a:srgbClr val="F1F5F9"/>
+                    </a:solidFill>
+                  </a:tcPr>
+                </a:tc>
+              </a:tr>
+              <a:tr h="777240">
+                <a:tc>
+                  <a:txBody>
+                    <a:bodyPr/>
+                    <a:lstStyle/>
+                    <a:p>
+                      <a:r>
+                        <a:rPr sz="1500" b="0">
+                          <a:solidFill>
+                            <a:srgbClr val="0F172A"/>
+                          </a:solidFill>
+                        </a:rPr>
+                        <a:t>Public repo, first push to main, PR template</a:t>
+                      </a:r>
+                    </a:p>
+                  </a:txBody>
+                  <a:tcPr>
+                    <a:solidFill>
+                      <a:srgbClr val="FFFFFF"/>
+                    </a:solidFill>
+                  </a:tcPr>
+                </a:tc>
+                <a:tc>
+                  <a:txBody>
+                    <a:bodyPr/>
+                    <a:lstStyle/>
+                    <a:p>
+                      <a:r>
+                        <a:rPr sz="1500" b="0">
+                          <a:solidFill>
+                            <a:srgbClr val="0F172A"/>
+                          </a:solidFill>
+                        </a:rPr>
+                        <a:t>Ruleset protecting main (PR required, no force push)</a:t>
+                      </a:r>
+                    </a:p>
+                  </a:txBody>
+                  <a:tcPr>
+                    <a:solidFill>
+                      <a:srgbClr val="FFFFFF"/>
+                    </a:solidFill>
+                  </a:tcPr>
+                </a:tc>
+              </a:tr>
+              <a:tr h="777240">
+                <a:tc>
+                  <a:txBody>
+                    <a:bodyPr/>
+                    <a:lstStyle/>
+                    <a:p>
+                      <a:r>
+                        <a:rPr sz="1500" b="0">
+                          <a:solidFill>
+                            <a:srgbClr val="0F172A"/>
+                          </a:solidFill>
+                        </a:rPr>
+                        <a:t>Labels and 6 issues with user story and acceptance criteria</a:t>
+                      </a:r>
+                    </a:p>
+                  </a:txBody>
+                  <a:tcPr>
+                    <a:solidFill>
+                      <a:srgbClr val="F1F5F9"/>
+                    </a:solidFill>
+                  </a:tcPr>
+                </a:tc>
+                <a:tc>
+                  <a:txBody>
+                    <a:bodyPr/>
+                    <a:lstStyle/>
+                    <a:p>
+                      <a:r>
+                        <a:rPr sz="1500" b="0">
+                          <a:solidFill>
+                            <a:srgbClr val="0F172A"/>
+                          </a:solidFill>
+                        </a:rPr>
+                        <a:t>Assignees on every Sprint 1 issue (teammates must accept their invitations)</a:t>
+                      </a:r>
+                    </a:p>
+                  </a:txBody>
+                  <a:tcPr>
+                    <a:solidFill>
+                      <a:srgbClr val="F1F5F9"/>
+                    </a:solidFill>
+                  </a:tcPr>
+                </a:tc>
+              </a:tr>
+              <a:tr h="777240">
+                <a:tc>
+                  <a:txBody>
+                    <a:bodyPr/>
+                    <a:lstStyle/>
+                    <a:p>
+                      <a:r>
+                        <a:rPr sz="1500" b="0">
+                          <a:solidFill>
+                            <a:srgbClr val="0F172A"/>
+                          </a:solidFill>
+                        </a:rPr>
+                        <a:t>Authentication code: repository, validator, ViewModel, screens, navigation</a:t>
+                      </a:r>
+                    </a:p>
+                  </a:txBody>
+                  <a:tcPr>
+                    <a:solidFill>
+                      <a:srgbClr val="FFFFFF"/>
+                    </a:solidFill>
+                  </a:tcPr>
+                </a:tc>
+                <a:tc>
+                  <a:txBody>
+                    <a:bodyPr/>
+                    <a:lstStyle/>
+                    <a:p>
+                      <a:r>
+                        <a:rPr sz="1500" b="0">
+                          <a:solidFill>
+                            <a:srgbClr val="0F172A"/>
+                          </a:solidFill>
+                        </a:rPr>
+                        <a:t>Firebase project, google-services.json, Email/Password sign-in, test on the emulator</a:t>
+                      </a:r>
+                    </a:p>
+                  </a:txBody>
+                  <a:tcPr>
+                    <a:solidFill>
+                      <a:srgbClr val="FFFFFF"/>
+                    </a:solidFill>
+                  </a:tcPr>
+                </a:tc>
+              </a:tr>
+              <a:tr h="777240">
+                <a:tc>
+                  <a:txBody>
+                    <a:bodyPr/>
+                    <a:lstStyle/>
+                    <a:p>
+                      <a:r>
+                        <a:rPr sz="1500" b="0">
+                          <a:solidFill>
+                            <a:srgbClr val="0F172A"/>
+                          </a:solidFill>
+                        </a:rPr>
+                        <a:t>PR #7 merged (project overview)</a:t>
+                      </a:r>
+                    </a:p>
+                  </a:txBody>
+                  <a:tcPr>
+                    <a:solidFill>
+                      <a:srgbClr val="F1F5F9"/>
+                    </a:solidFill>
+                  </a:tcPr>
+                </a:tc>
+                <a:tc>
+                  <a:txBody>
+                    <a:bodyPr/>
+                    <a:lstStyle/>
+                    <a:p>
+                      <a:r>
+                        <a:rPr sz="1500" b="0">
+                          <a:solidFill>
+                            <a:srgbClr val="0F172A"/>
+                          </a:solidFill>
+                        </a:rPr>
+                        <a:t>At least two merged PRs, each with a teammate review; Retro – Lab 1 issue</a:t>
+                      </a:r>
+                    </a:p>
+                  </a:txBody>
+                  <a:tcPr>
+                    <a:solidFill>
+                      <a:srgbClr val="F1F5F9"/>
+                    </a:solidFill>
+                  </a:tcPr>
+                </a:tc>
+              </a:tr>
+            </a:tbl>
+          </a:graphicData>
+        </a:graphic>
+      </p:graphicFrame>
+    </p:spTree>
+  </p:cSld>
+  <p:clrMapOvr>
+    <a:masterClrMapping/>
+  </p:clrMapOvr>
+</p:sld>
+</file>
+
+<file path=ppt/slides/slide15.xml><?xml version="1.0" encoding="utf-8"?>
+<p:sld xmlns:a="http://schemas.openxmlformats.org/drawingml/2006/main" xmlns:p="http://schemas.openxmlformats.org/presentationml/2006/main" xmlns:r="http://schemas.openxmlformats.org/officeDocument/2006/relationships">
+  <p:cSld>
+    <p:spTree>
+      <p:nvGrpSpPr>
+        <p:cNvPr id="1" name=""/>
+        <p:cNvGrpSpPr/>
+        <p:nvPr/>
+      </p:nvGrpSpPr>
+      <p:grpSpPr/>
+      <p:sp>
+        <p:nvSpPr>
+          <p:cNvPr id="2" name="Rectangle 1"/>
+          <p:cNvSpPr/>
+          <p:nvPr/>
+        </p:nvSpPr>
+        <p:spPr>
+          <a:xfrm>
+            <a:off x="0" y="0"/>
+            <a:ext cx="12191695" cy="1097280"/>
+          </a:xfrm>
+          <a:prstGeom prst="rect">
+            <a:avLst/>
+          </a:prstGeom>
+          <a:solidFill>
+            <a:srgbClr val="111827"/>
+          </a:solidFill>
+          <a:ln>
+            <a:noFill/>
+          </a:ln>
+          <a:effectLst/>
+        </p:spPr>
+        <p:style>
+          <a:lnRef idx="1">
+            <a:schemeClr val="accent1"/>
+          </a:lnRef>
+          <a:fillRef idx="3">
+            <a:schemeClr val="accent1"/>
+          </a:fillRef>
+          <a:effectRef idx="2">
+            <a:schemeClr val="accent1"/>
+          </a:effectRef>
+          <a:fontRef idx="minor">
+            <a:schemeClr val="lt1"/>
+          </a:fontRef>
+        </p:style>
+        <p:txBody>
+          <a:bodyPr rtlCol="0" anchor="ctr" wrap="square" lIns="457200" rIns="457200" tIns="73152" bIns="73152"/>
+          <a:lstStyle/>
+          <a:p>
+            <a:pPr algn="ctr"/>
+            <a:r>
+              <a:rPr sz="3200" b="1">
+                <a:solidFill>
+                  <a:srgbClr val="FFFFFF"/>
+                </a:solidFill>
+              </a:rPr>
+              <a:t>What's next</a:t>
+            </a:r>
+          </a:p>
+          <a:p>
+            <a:pPr algn="l"/>
+            <a:r>
+              <a:rPr sz="1500" b="0">
+                <a:solidFill>
+                  <a:srgbClr val="FDBA74"/>
+                </a:solidFill>
+              </a:rPr>
+              <a:t>Lab 1 delivers the walking skeleton</a:t>
+            </a:r>
+          </a:p>
+        </p:txBody>
+      </p:sp>
+      <p:sp>
+        <p:nvSpPr>
+          <p:cNvPr id="3" name="Rectangle 2"/>
+          <p:cNvSpPr/>
+          <p:nvPr/>
+        </p:nvSpPr>
+        <p:spPr>
+          <a:xfrm>
+            <a:off x="0" y="1097280"/>
+            <a:ext cx="12191695" cy="64008"/>
+          </a:xfrm>
+          <a:prstGeom prst="rect">
+            <a:avLst/>
+          </a:prstGeom>
+          <a:solidFill>
+            <a:srgbClr val="F97316"/>
+          </a:solidFill>
+          <a:ln>
+            <a:noFill/>
+          </a:ln>
+          <a:effectLst/>
+        </p:spPr>
+        <p:style>
+          <a:lnRef idx="1">
+            <a:schemeClr val="accent1"/>
+          </a:lnRef>
+          <a:fillRef idx="3">
+            <a:schemeClr val="accent1"/>
+          </a:fillRef>
+          <a:effectRef idx="2">
+            <a:schemeClr val="accent1"/>
+          </a:effectRef>
+          <a:fontRef idx="minor">
+            <a:schemeClr val="lt1"/>
+          </a:fontRef>
+        </p:style>
+        <p:txBody>
+          <a:bodyPr rtlCol="0" anchor="ctr"/>
+          <a:lstStyle/>
+          <a:p>
+            <a:pPr algn="ctr"/>
+          </a:p>
+        </p:txBody>
+      </p:sp>
       <p:sp>
         <p:nvSpPr>
           <p:cNvPr id="4" name="TextBox 3"/>
@@ -4868,7 +5796,7 @@
                   <a:srgbClr val="F97316"/>
                 </a:solidFill>
               </a:rPr>
-              <a:t>â€¢  </a:t>
+              <a:t>•  </a:t>
             </a:r>
             <a:r>
               <a:rPr sz="2200" b="1">
@@ -4899,7 +5827,7 @@
                   <a:srgbClr val="F97316"/>
                 </a:solidFill>
               </a:rPr>
-              <a:t>â€¢  </a:t>
+              <a:t>•  </a:t>
             </a:r>
             <a:r>
               <a:rPr sz="2200" b="1">
@@ -4915,7 +5843,7 @@
                   <a:srgbClr val="64748B"/>
                 </a:solidFill>
               </a:rPr>
-              <a:t> workouts in Firestore â€“ list, add, edit, delete â€“ and Security Rules.</a:t>
+              <a:t> workouts in Firestore – list, add, edit, delete – and Security Rules.</a:t>
             </a:r>
           </a:p>
           <a:p>
@@ -4930,7 +5858,7 @@
                   <a:srgbClr val="F97316"/>
                 </a:solidFill>
               </a:rPr>
-              <a:t>â€¢  </a:t>
+              <a:t>•  </a:t>
             </a:r>
             <a:r>
               <a:rPr sz="2200" b="1">
@@ -4961,7 +5889,7 @@
                   <a:srgbClr val="F97316"/>
                 </a:solidFill>
               </a:rPr>
-              <a:t>â€¢  </a:t>
+              <a:t>•  </a:t>
             </a:r>
             <a:r>
               <a:rPr sz="2200" b="1">
@@ -4969,7 +5897,7 @@
                   <a:srgbClr val="0F172A"/>
                 </a:solidFill>
               </a:rPr>
-              <a:t>Retro â€“ Lab 1:</a:t>
+              <a:t>Retro – Lab 1:</a:t>
             </a:r>
             <a:r>
               <a:rPr sz="2200" b="0">
@@ -5011,7 +5939,7 @@
                   <a:srgbClr val="C2410C"/>
                 </a:solidFill>
               </a:rPr>
-              <a:t>Thank you â€“ questions?</a:t>
+              <a:t>Thank you – questions?</a:t>
             </a:r>
           </a:p>
         </p:txBody>
@@ -5174,7 +6102,7 @@
                   <a:srgbClr val="F97316"/>
                 </a:solidFill>
               </a:rPr>
-              <a:t>â€¢  </a:t>
+              <a:t>•  </a:t>
             </a:r>
             <a:r>
               <a:rPr sz="2200" b="1">
@@ -5205,7 +6133,7 @@
                   <a:srgbClr val="F97316"/>
                 </a:solidFill>
               </a:rPr>
-              <a:t>â€¢  </a:t>
+              <a:t>•  </a:t>
             </a:r>
             <a:r>
               <a:rPr sz="2200" b="1">
@@ -5236,7 +6164,7 @@
                   <a:srgbClr val="F97316"/>
                 </a:solidFill>
               </a:rPr>
-              <a:t>â€¢  </a:t>
+              <a:t>•  </a:t>
             </a:r>
             <a:r>
               <a:rPr sz="2200" b="1">
@@ -5267,7 +6195,7 @@
                   <a:srgbClr val="F97316"/>
                 </a:solidFill>
               </a:rPr>
-              <a:t>â€¢  </a:t>
+              <a:t>•  </a:t>
             </a:r>
             <a:r>
               <a:rPr sz="2200" b="1">
@@ -5350,7 +6278,7 @@
                   <a:srgbClr val="0F172A"/>
                 </a:solidFill>
               </a:rPr>
-              <a:t>â€œBuddyâ€ is the gym word for a training partner. People who train with a partner skip fewer sessions â€“ so the name says what the app is for: staying consistent, together.</a:t>
+              <a:t>“Buddy” is the gym word for a training partner. People who train with a partner skip fewer sessions – so the name says what the app is for: staying consistent, together.</a:t>
             </a:r>
           </a:p>
         </p:txBody>
@@ -5420,7 +6348,7 @@
                   <a:srgbClr val="FFFFFF"/>
                 </a:solidFill>
               </a:rPr>
-              <a:t>The problem</a:t>
+              <a:t>Where GymBuddy can be used</a:t>
             </a:r>
           </a:p>
           <a:p>
@@ -5431,7 +6359,7 @@
                   <a:srgbClr val="FDBA74"/>
                 </a:solidFill>
               </a:rPr>
-              <a:t>One sentence: who has what problem, and why it matters</a:t>
+              <a:t>The same app helps different groups</a:t>
             </a:r>
           </a:p>
         </p:txBody>
@@ -5480,6 +6408,499 @@
           </a:p>
         </p:txBody>
       </p:sp>
+      <p:graphicFrame>
+        <p:nvGraphicFramePr>
+          <p:cNvPr id="4" name="Table 3"/>
+          <p:cNvGraphicFramePr>
+            <a:graphicFrameLocks noGrp="1"/>
+          </p:cNvGraphicFramePr>
+          <p:nvPr/>
+        </p:nvGraphicFramePr>
+        <p:xfrm>
+          <a:off x="640080" y="1645920"/>
+          <a:ext cx="10881360" cy="3968496"/>
+        </p:xfrm>
+        <a:graphic>
+          <a:graphicData uri="http://schemas.openxmlformats.org/drawingml/2006/table">
+            <a:tbl>
+              <a:tblPr firstRow="1" bandRow="1">
+                <a:tableStyleId>{5C22544A-7EE6-4342-B048-85BDC9FD1C3A}</a:tableStyleId>
+              </a:tblPr>
+              <a:tblGrid>
+                <a:gridCol w="4023360"/>
+                <a:gridCol w="6858000"/>
+              </a:tblGrid>
+              <a:tr h="566928">
+                <a:tc>
+                  <a:txBody>
+                    <a:bodyPr/>
+                    <a:lstStyle/>
+                    <a:p>
+                      <a:r>
+                        <a:rPr sz="1800" b="1">
+                          <a:solidFill>
+                            <a:srgbClr val="FFFFFF"/>
+                          </a:solidFill>
+                        </a:rPr>
+                        <a:t>Who</a:t>
+                      </a:r>
+                    </a:p>
+                  </a:txBody>
+                  <a:tcPr>
+                    <a:solidFill>
+                      <a:srgbClr val="111827"/>
+                    </a:solidFill>
+                  </a:tcPr>
+                </a:tc>
+                <a:tc>
+                  <a:txBody>
+                    <a:bodyPr/>
+                    <a:lstStyle/>
+                    <a:p>
+                      <a:r>
+                        <a:rPr sz="1800" b="1">
+                          <a:solidFill>
+                            <a:srgbClr val="FFFFFF"/>
+                          </a:solidFill>
+                        </a:rPr>
+                        <a:t>How GymBuddy helps</a:t>
+                      </a:r>
+                    </a:p>
+                  </a:txBody>
+                  <a:tcPr>
+                    <a:solidFill>
+                      <a:srgbClr val="111827"/>
+                    </a:solidFill>
+                  </a:tcPr>
+                </a:tc>
+              </a:tr>
+              <a:tr h="566928">
+                <a:tc>
+                  <a:txBody>
+                    <a:bodyPr/>
+                    <a:lstStyle/>
+                    <a:p>
+                      <a:r>
+                        <a:rPr sz="1800" b="0">
+                          <a:solidFill>
+                            <a:srgbClr val="0F172A"/>
+                          </a:solidFill>
+                        </a:rPr>
+                        <a:t>Individual gym-goers</a:t>
+                      </a:r>
+                    </a:p>
+                  </a:txBody>
+                  <a:tcPr>
+                    <a:solidFill>
+                      <a:srgbClr val="F1F5F9"/>
+                    </a:solidFill>
+                  </a:tcPr>
+                </a:tc>
+                <a:tc>
+                  <a:txBody>
+                    <a:bodyPr/>
+                    <a:lstStyle/>
+                    <a:p>
+                      <a:r>
+                        <a:rPr sz="1800" b="0">
+                          <a:solidFill>
+                            <a:srgbClr val="0F172A"/>
+                          </a:solidFill>
+                        </a:rPr>
+                        <a:t>Keep a simple training history and see weekly progress</a:t>
+                      </a:r>
+                    </a:p>
+                  </a:txBody>
+                  <a:tcPr>
+                    <a:solidFill>
+                      <a:srgbClr val="F1F5F9"/>
+                    </a:solidFill>
+                  </a:tcPr>
+                </a:tc>
+              </a:tr>
+              <a:tr h="566928">
+                <a:tc>
+                  <a:txBody>
+                    <a:bodyPr/>
+                    <a:lstStyle/>
+                    <a:p>
+                      <a:r>
+                        <a:rPr sz="1800" b="0">
+                          <a:solidFill>
+                            <a:srgbClr val="0F172A"/>
+                          </a:solidFill>
+                        </a:rPr>
+                        <a:t>Friends and training groups</a:t>
+                      </a:r>
+                    </a:p>
+                  </a:txBody>
+                  <a:tcPr>
+                    <a:solidFill>
+                      <a:srgbClr val="FFFFFF"/>
+                    </a:solidFill>
+                  </a:tcPr>
+                </a:tc>
+                <a:tc>
+                  <a:txBody>
+                    <a:bodyPr/>
+                    <a:lstStyle/>
+                    <a:p>
+                      <a:r>
+                        <a:rPr sz="1800" b="0">
+                          <a:solidFill>
+                            <a:srgbClr val="0F172A"/>
+                          </a:solidFill>
+                        </a:rPr>
+                        <a:t>Plan shared sessions and see who joined</a:t>
+                      </a:r>
+                    </a:p>
+                  </a:txBody>
+                  <a:tcPr>
+                    <a:solidFill>
+                      <a:srgbClr val="FFFFFF"/>
+                    </a:solidFill>
+                  </a:tcPr>
+                </a:tc>
+              </a:tr>
+              <a:tr h="566928">
+                <a:tc>
+                  <a:txBody>
+                    <a:bodyPr/>
+                    <a:lstStyle/>
+                    <a:p>
+                      <a:r>
+                        <a:rPr sz="1800" b="0">
+                          <a:solidFill>
+                            <a:srgbClr val="0F172A"/>
+                          </a:solidFill>
+                        </a:rPr>
+                        <a:t>Newcomers to a gym</a:t>
+                      </a:r>
+                    </a:p>
+                  </a:txBody>
+                  <a:tcPr>
+                    <a:solidFill>
+                      <a:srgbClr val="F1F5F9"/>
+                    </a:solidFill>
+                  </a:tcPr>
+                </a:tc>
+                <a:tc>
+                  <a:txBody>
+                    <a:bodyPr/>
+                    <a:lstStyle/>
+                    <a:p>
+                      <a:r>
+                        <a:rPr sz="1800" b="0">
+                          <a:solidFill>
+                            <a:srgbClr val="0F172A"/>
+                          </a:solidFill>
+                        </a:rPr>
+                        <a:t>Find a partner instead of training alone</a:t>
+                      </a:r>
+                    </a:p>
+                  </a:txBody>
+                  <a:tcPr>
+                    <a:solidFill>
+                      <a:srgbClr val="F1F5F9"/>
+                    </a:solidFill>
+                  </a:tcPr>
+                </a:tc>
+              </a:tr>
+              <a:tr h="566928">
+                <a:tc>
+                  <a:txBody>
+                    <a:bodyPr/>
+                    <a:lstStyle/>
+                    <a:p>
+                      <a:r>
+                        <a:rPr sz="1800" b="0">
+                          <a:solidFill>
+                            <a:srgbClr val="0F172A"/>
+                          </a:solidFill>
+                        </a:rPr>
+                        <a:t>University sports clubs</a:t>
+                      </a:r>
+                    </a:p>
+                  </a:txBody>
+                  <a:tcPr>
+                    <a:solidFill>
+                      <a:srgbClr val="FFFFFF"/>
+                    </a:solidFill>
+                  </a:tcPr>
+                </a:tc>
+                <a:tc>
+                  <a:txBody>
+                    <a:bodyPr/>
+                    <a:lstStyle/>
+                    <a:p>
+                      <a:r>
+                        <a:rPr sz="1800" b="0">
+                          <a:solidFill>
+                            <a:srgbClr val="0F172A"/>
+                          </a:solidFill>
+                        </a:rPr>
+                        <a:t>Organise open sessions for students and staff</a:t>
+                      </a:r>
+                    </a:p>
+                  </a:txBody>
+                  <a:tcPr>
+                    <a:solidFill>
+                      <a:srgbClr val="FFFFFF"/>
+                    </a:solidFill>
+                  </a:tcPr>
+                </a:tc>
+              </a:tr>
+              <a:tr h="566928">
+                <a:tc>
+                  <a:txBody>
+                    <a:bodyPr/>
+                    <a:lstStyle/>
+                    <a:p>
+                      <a:r>
+                        <a:rPr sz="1800" b="0">
+                          <a:solidFill>
+                            <a:srgbClr val="0F172A"/>
+                          </a:solidFill>
+                        </a:rPr>
+                        <a:t>Workplace wellness programmes</a:t>
+                      </a:r>
+                    </a:p>
+                  </a:txBody>
+                  <a:tcPr>
+                    <a:solidFill>
+                      <a:srgbClr val="F1F5F9"/>
+                    </a:solidFill>
+                  </a:tcPr>
+                </a:tc>
+                <a:tc>
+                  <a:txBody>
+                    <a:bodyPr/>
+                    <a:lstStyle/>
+                    <a:p>
+                      <a:r>
+                        <a:rPr sz="1800" b="0">
+                          <a:solidFill>
+                            <a:srgbClr val="0F172A"/>
+                          </a:solidFill>
+                        </a:rPr>
+                        <a:t>Let colleagues arrange group workouts</a:t>
+                      </a:r>
+                    </a:p>
+                  </a:txBody>
+                  <a:tcPr>
+                    <a:solidFill>
+                      <a:srgbClr val="F1F5F9"/>
+                    </a:solidFill>
+                  </a:tcPr>
+                </a:tc>
+              </a:tr>
+              <a:tr h="566928">
+                <a:tc>
+                  <a:txBody>
+                    <a:bodyPr/>
+                    <a:lstStyle/>
+                    <a:p>
+                      <a:r>
+                        <a:rPr sz="1800" b="0">
+                          <a:solidFill>
+                            <a:srgbClr val="0F172A"/>
+                          </a:solidFill>
+                        </a:rPr>
+                        <a:t>Small gyms and fitness studios</a:t>
+                      </a:r>
+                    </a:p>
+                  </a:txBody>
+                  <a:tcPr>
+                    <a:solidFill>
+                      <a:srgbClr val="FFFFFF"/>
+                    </a:solidFill>
+                  </a:tcPr>
+                </a:tc>
+                <a:tc>
+                  <a:txBody>
+                    <a:bodyPr/>
+                    <a:lstStyle/>
+                    <a:p>
+                      <a:r>
+                        <a:rPr sz="1800" b="0">
+                          <a:solidFill>
+                            <a:srgbClr val="0F172A"/>
+                          </a:solidFill>
+                        </a:rPr>
+                        <a:t>Give members a free way to meet training partners</a:t>
+                      </a:r>
+                    </a:p>
+                  </a:txBody>
+                  <a:tcPr>
+                    <a:solidFill>
+                      <a:srgbClr val="FFFFFF"/>
+                    </a:solidFill>
+                  </a:tcPr>
+                </a:tc>
+              </a:tr>
+            </a:tbl>
+          </a:graphicData>
+        </a:graphic>
+      </p:graphicFrame>
+      <p:sp>
+        <p:nvSpPr>
+          <p:cNvPr id="5" name="TextBox 4"/>
+          <p:cNvSpPr txBox="1"/>
+          <p:nvPr/>
+        </p:nvSpPr>
+        <p:spPr>
+          <a:xfrm>
+            <a:off x="640080" y="5806440"/>
+            <a:ext cx="10881360" cy="731520"/>
+          </a:xfrm>
+          <a:prstGeom prst="rect">
+            <a:avLst/>
+          </a:prstGeom>
+          <a:noFill/>
+        </p:spPr>
+        <p:txBody>
+          <a:bodyPr wrap="square">
+            <a:spAutoFit/>
+          </a:bodyPr>
+          <a:lstStyle/>
+          <a:p>
+            <a:pPr algn="l"/>
+            <a:r>
+              <a:rPr sz="1600" b="0">
+                <a:solidFill>
+                  <a:srgbClr val="64748B"/>
+                </a:solidFill>
+              </a:rPr>
+              <a:t>People who track their training see progress, and people who train with a partner skip fewer sessions.</a:t>
+            </a:r>
+          </a:p>
+        </p:txBody>
+      </p:sp>
+    </p:spTree>
+  </p:cSld>
+  <p:clrMapOvr>
+    <a:masterClrMapping/>
+  </p:clrMapOvr>
+</p:sld>
+</file>
+
+<file path=ppt/slides/slide4.xml><?xml version="1.0" encoding="utf-8"?>
+<p:sld xmlns:a="http://schemas.openxmlformats.org/drawingml/2006/main" xmlns:p="http://schemas.openxmlformats.org/presentationml/2006/main" xmlns:r="http://schemas.openxmlformats.org/officeDocument/2006/relationships">
+  <p:cSld>
+    <p:spTree>
+      <p:nvGrpSpPr>
+        <p:cNvPr id="1" name=""/>
+        <p:cNvGrpSpPr/>
+        <p:nvPr/>
+      </p:nvGrpSpPr>
+      <p:grpSpPr/>
+      <p:sp>
+        <p:nvSpPr>
+          <p:cNvPr id="2" name="Rectangle 1"/>
+          <p:cNvSpPr/>
+          <p:nvPr/>
+        </p:nvSpPr>
+        <p:spPr>
+          <a:xfrm>
+            <a:off x="0" y="0"/>
+            <a:ext cx="12191695" cy="1097280"/>
+          </a:xfrm>
+          <a:prstGeom prst="rect">
+            <a:avLst/>
+          </a:prstGeom>
+          <a:solidFill>
+            <a:srgbClr val="111827"/>
+          </a:solidFill>
+          <a:ln>
+            <a:noFill/>
+          </a:ln>
+          <a:effectLst/>
+        </p:spPr>
+        <p:style>
+          <a:lnRef idx="1">
+            <a:schemeClr val="accent1"/>
+          </a:lnRef>
+          <a:fillRef idx="3">
+            <a:schemeClr val="accent1"/>
+          </a:fillRef>
+          <a:effectRef idx="2">
+            <a:schemeClr val="accent1"/>
+          </a:effectRef>
+          <a:fontRef idx="minor">
+            <a:schemeClr val="lt1"/>
+          </a:fontRef>
+        </p:style>
+        <p:txBody>
+          <a:bodyPr rtlCol="0" anchor="ctr" wrap="square" lIns="457200" rIns="457200" tIns="73152" bIns="73152"/>
+          <a:lstStyle/>
+          <a:p>
+            <a:pPr algn="ctr"/>
+            <a:r>
+              <a:rPr sz="3200" b="1">
+                <a:solidFill>
+                  <a:srgbClr val="FFFFFF"/>
+                </a:solidFill>
+              </a:rPr>
+              <a:t>The problem</a:t>
+            </a:r>
+          </a:p>
+          <a:p>
+            <a:pPr algn="l"/>
+            <a:r>
+              <a:rPr sz="1500" b="0">
+                <a:solidFill>
+                  <a:srgbClr val="FDBA74"/>
+                </a:solidFill>
+              </a:rPr>
+              <a:t>One sentence: who has what problem, and why it matters</a:t>
+            </a:r>
+          </a:p>
+        </p:txBody>
+      </p:sp>
+      <p:sp>
+        <p:nvSpPr>
+          <p:cNvPr id="3" name="Rectangle 2"/>
+          <p:cNvSpPr/>
+          <p:nvPr/>
+        </p:nvSpPr>
+        <p:spPr>
+          <a:xfrm>
+            <a:off x="0" y="1097280"/>
+            <a:ext cx="12191695" cy="64008"/>
+          </a:xfrm>
+          <a:prstGeom prst="rect">
+            <a:avLst/>
+          </a:prstGeom>
+          <a:solidFill>
+            <a:srgbClr val="F97316"/>
+          </a:solidFill>
+          <a:ln>
+            <a:noFill/>
+          </a:ln>
+          <a:effectLst/>
+        </p:spPr>
+        <p:style>
+          <a:lnRef idx="1">
+            <a:schemeClr val="accent1"/>
+          </a:lnRef>
+          <a:fillRef idx="3">
+            <a:schemeClr val="accent1"/>
+          </a:fillRef>
+          <a:effectRef idx="2">
+            <a:schemeClr val="accent1"/>
+          </a:effectRef>
+          <a:fontRef idx="minor">
+            <a:schemeClr val="lt1"/>
+          </a:fontRef>
+        </p:style>
+        <p:txBody>
+          <a:bodyPr rtlCol="0" anchor="ctr"/>
+          <a:lstStyle/>
+          <a:p>
+            <a:pPr algn="ctr"/>
+          </a:p>
+        </p:txBody>
+      </p:sp>
       <p:sp>
         <p:nvSpPr>
           <p:cNvPr id="4" name="Rounded Rectangle 3"/>
@@ -5527,7 +6948,7 @@
                   <a:srgbClr val="FFFFFF"/>
                 </a:solidFill>
               </a:rPr>
-              <a:t>â€œGym-goers forget what they trained and struggle to find training partners, so progress stalls and motivation drops.â€</a:t>
+              <a:t>“Gym-goers forget what they trained and struggle to find training partners, so progress stalls and motivation drops.”</a:t>
             </a:r>
           </a:p>
         </p:txBody>
@@ -5565,7 +6986,7 @@
                   <a:srgbClr val="F97316"/>
                 </a:solidFill>
               </a:rPr>
-              <a:t>â€¢  </a:t>
+              <a:t>•  </a:t>
             </a:r>
             <a:r>
               <a:rPr sz="2200" b="1">
@@ -5596,7 +7017,7 @@
                   <a:srgbClr val="F97316"/>
                 </a:solidFill>
               </a:rPr>
-              <a:t>â€¢  </a:t>
+              <a:t>•  </a:t>
             </a:r>
             <a:r>
               <a:rPr sz="2200" b="1">
@@ -5627,7 +7048,7 @@
                   <a:srgbClr val="F97316"/>
                 </a:solidFill>
               </a:rPr>
-              <a:t>â€¢  </a:t>
+              <a:t>•  </a:t>
             </a:r>
             <a:r>
               <a:rPr sz="2200" b="1">
@@ -5656,7 +7077,7 @@
 </p:sld>
 </file>
 
-<file path=ppt/slides/slide4.xml><?xml version="1.0" encoding="utf-8"?>
+<file path=ppt/slides/slide5.xml><?xml version="1.0" encoding="utf-8"?>
 <p:sld xmlns:a="http://schemas.openxmlformats.org/drawingml/2006/main" xmlns:p="http://schemas.openxmlformats.org/presentationml/2006/main" xmlns:r="http://schemas.openxmlformats.org/officeDocument/2006/relationships">
   <p:cSld>
     <p:spTree>
@@ -5724,7 +7145,7 @@
                   <a:srgbClr val="FDBA74"/>
                 </a:solidFill>
               </a:rPr>
-              <a:t>Sprint 1 = Labs 1â€“2, the rest is planned for later</a:t>
+              <a:t>Sprint 1 = Labs 1–2, the rest is planned for later</a:t>
             </a:r>
           </a:p>
         </p:txBody>
@@ -6232,7 +7653,7 @@
 </p:sld>
 </file>
 
-<file path=ppt/slides/slide5.xml><?xml version="1.0" encoding="utf-8"?>
+<file path=ppt/slides/slide6.xml><?xml version="1.0" encoding="utf-8"?>
 <p:sld xmlns:a="http://schemas.openxmlformats.org/drawingml/2006/main" xmlns:p="http://schemas.openxmlformats.org/presentationml/2006/main" xmlns:r="http://schemas.openxmlformats.org/officeDocument/2006/relationships">
   <p:cSld>
     <p:spTree>
@@ -6300,7 +7721,7 @@
                   <a:srgbClr val="FDBA74"/>
                 </a:solidFill>
               </a:rPr>
-              <a:t>5 screens: Login Â· Register Â· Workouts Â· Workout detail/edit Â· Partners</a:t>
+              <a:t>5 screens: Login · Register · Workouts · Workout detail/edit · Partners</a:t>
             </a:r>
           </a:p>
         </p:txBody>
@@ -6402,7 +7823,7 @@
                   <a:srgbClr val="64748B"/>
                 </a:solidFill>
               </a:rPr>
-              <a:t>Concept mockups. Login, Register and a temporary Home are built in Lab 1; the rest follow in Labs 2â€“3.</a:t>
+              <a:t>Concept mockups. Login, Register and a temporary Home are built in Lab 1; the rest follow in Labs 2–3.</a:t>
             </a:r>
           </a:p>
         </p:txBody>
@@ -6415,7 +7836,7 @@
 </p:sld>
 </file>
 
-<file path=ppt/slides/slide6.xml><?xml version="1.0" encoding="utf-8"?>
+<file path=ppt/slides/slide7.xml><?xml version="1.0" encoding="utf-8"?>
 <p:sld xmlns:a="http://schemas.openxmlformats.org/drawingml/2006/main" xmlns:p="http://schemas.openxmlformats.org/presentationml/2006/main" xmlns:r="http://schemas.openxmlformats.org/officeDocument/2006/relationships">
   <p:cSld>
     <p:spTree>
@@ -6483,7 +7904,7 @@
                   <a:srgbClr val="FDBA74"/>
                 </a:solidFill>
               </a:rPr>
-              <a:t>Cloud Firestore Â· 3 collections Â· ownerId links every document to its owner</a:t>
+              <a:t>Cloud Firestore · 3 collections · ownerId links every document to its owner</a:t>
             </a:r>
           </a:p>
         </p:txBody>
@@ -6631,7 +8052,7 @@
                             <a:srgbClr val="0F172A"/>
                           </a:solidFill>
                         </a:rPr>
-                        <a:t>uid (doc id) Â· email (string) Â· displayName (string) Â· createdAt (timestamp)</a:t>
+                        <a:t>uid (doc id) · email (string) · displayName (string) · createdAt (timestamp)</a:t>
                       </a:r>
                     </a:p>
                   </a:txBody>
@@ -6675,7 +8096,7 @@
                             <a:srgbClr val="0F172A"/>
                           </a:solidFill>
                         </a:rPr>
-                        <a:t>ownerId (string) Â· title (string) Â· type (string) Â· durationMin (number) Â· notes (string) Â· date (timestamp) Â· createdAt (timestamp)</a:t>
+                        <a:t>ownerId (string) · title (string) · type (string) · durationMin (number) · notes (string) · date (timestamp) · createdAt (timestamp)</a:t>
                       </a:r>
                     </a:p>
                   </a:txBody>
@@ -6719,7 +8140,7 @@
                             <a:srgbClr val="0F172A"/>
                           </a:solidFill>
                         </a:rPr>
-                        <a:t>ownerId (string) Â· title (string) Â· gym (string) Â· startsAt (timestamp) Â· maxPeople (number) Â· participantIds (array of string)</a:t>
+                        <a:t>ownerId (string) · title (string) · gym (string) · startsAt (timestamp) · maxPeople (number) · participantIds (array of string)</a:t>
                       </a:r>
                     </a:p>
                   </a:txBody>
@@ -6763,7 +8184,7 @@
                   <a:srgbClr val="C2410C"/>
                 </a:solidFill>
               </a:rPr>
-              <a:t>Security Rules (Lab 2) make sure users can only edit their own data â€“ enforced in Firebase, not just in the app.</a:t>
+              <a:t>Security Rules (Lab 2) make sure users can only edit their own data – enforced in Firebase, not just in the app.</a:t>
             </a:r>
           </a:p>
         </p:txBody>
@@ -6776,7 +8197,7 @@
 </p:sld>
 </file>
 
-<file path=ppt/slides/slide7.xml><?xml version="1.0" encoding="utf-8"?>
+<file path=ppt/slides/slide8.xml><?xml version="1.0" encoding="utf-8"?>
 <p:sld xmlns:a="http://schemas.openxmlformats.org/drawingml/2006/main" xmlns:p="http://schemas.openxmlformats.org/presentationml/2006/main" xmlns:r="http://schemas.openxmlformats.org/officeDocument/2006/relationships">
   <p:cSld>
     <p:spTree>
@@ -6953,7 +8374,7 @@
                   <a:srgbClr val="0F172A"/>
                 </a:solidFill>
               </a:rPr>
-              <a:t>LoginScreen Â· RegisterScreen Â· HomeScreen Â· AppNavHost</a:t>
+              <a:t>LoginScreen · RegisterScreen · HomeScreen · AppNavHost</a:t>
             </a:r>
           </a:p>
         </p:txBody>
@@ -7018,7 +8439,7 @@
                   <a:srgbClr val="0F172A"/>
                 </a:solidFill>
               </a:rPr>
-              <a:t>AuthValidator Â· AuthViewModel (StateFlow)</a:t>
+              <a:t>AuthValidator · AuthViewModel (StateFlow)</a:t>
             </a:r>
           </a:p>
         </p:txBody>
@@ -7083,7 +8504,7 @@
                   <a:srgbClr val="0F172A"/>
                 </a:solidFill>
               </a:rPr>
-              <a:t>AuthRepository â†’ FirebaseAuthRepository</a:t>
+              <a:t>AuthRepository → FirebaseAuthRepository</a:t>
             </a:r>
           </a:p>
         </p:txBody>
@@ -7423,7 +8844,7 @@
                   <a:srgbClr val="FFFFFF"/>
                 </a:solidFill>
               </a:rPr>
-              <a:t>Lab 3 â€“ weekly stats</a:t>
+              <a:t>Lab 3 – weekly stats</a:t>
             </a:r>
           </a:p>
         </p:txBody>
@@ -7470,7 +8891,7 @@
 </p:sld>
 </file>
 
-<file path=ppt/slides/slide8.xml><?xml version="1.0" encoding="utf-8"?>
+<file path=ppt/slides/slide9.xml><?xml version="1.0" encoding="utf-8"?>
 <p:sld xmlns:a="http://schemas.openxmlformats.org/drawingml/2006/main" xmlns:p="http://schemas.openxmlformats.org/presentationml/2006/main" xmlns:r="http://schemas.openxmlformats.org/officeDocument/2006/relationships">
   <p:cSld>
     <p:spTree>
@@ -7700,7 +9121,7 @@
                   <a:srgbClr val="0F172A"/>
                 </a:solidFill>
               </a:rPr>
-              <a:t>â˜ Valid credentials open the home screen</a:t>
+              <a:t>☐ Valid credentials open the home screen</a:t>
             </a:r>
           </a:p>
           <a:p>
@@ -7711,7 +9132,7 @@
                   <a:srgbClr val="0F172A"/>
                 </a:solidFill>
               </a:rPr>
-              <a:t>â˜ Wrong credentials show an error message</a:t>
+              <a:t>☐ Wrong credentials show an error message</a:t>
             </a:r>
           </a:p>
           <a:p>
@@ -7722,7 +9143,7 @@
                   <a:srgbClr val="0F172A"/>
                 </a:solidFill>
               </a:rPr>
-              <a:t>â˜ A logged-in user skips the login screen after restart</a:t>
+              <a:t>☐ A logged-in user skips the login screen after restart</a:t>
             </a:r>
           </a:p>
         </p:txBody>
@@ -7760,7 +9181,7 @@
                   <a:srgbClr val="F97316"/>
                 </a:solidFill>
               </a:rPr>
-              <a:t>â€¢  </a:t>
+              <a:t>•  </a:t>
             </a:r>
             <a:r>
               <a:rPr sz="1700" b="1">
@@ -7791,7 +9212,7 @@
                   <a:srgbClr val="F97316"/>
                 </a:solidFill>
               </a:rPr>
-              <a:t>â€¢  </a:t>
+              <a:t>•  </a:t>
             </a:r>
             <a:r>
               <a:rPr sz="1700" b="1">
@@ -7822,7 +9243,7 @@
                   <a:srgbClr val="F97316"/>
                 </a:solidFill>
               </a:rPr>
-              <a:t>â€¢  </a:t>
+              <a:t>•  </a:t>
             </a:r>
             <a:r>
               <a:rPr sz="1700" b="1">
@@ -7853,7 +9274,7 @@
                   <a:srgbClr val="F97316"/>
                 </a:solidFill>
               </a:rPr>
-              <a:t>â€¢  </a:t>
+              <a:t>•  </a:t>
             </a:r>
             <a:r>
               <a:rPr sz="1700" b="1">
@@ -7869,518 +9290,7 @@
                   <a:srgbClr val="64748B"/>
                 </a:solidFill>
               </a:rPr>
-              <a:t> the PR says â€œCloses #issueâ€, so the issue moves to Done on merge.</a:t>
-            </a:r>
-          </a:p>
-        </p:txBody>
-      </p:sp>
-    </p:spTree>
-  </p:cSld>
-  <p:clrMapOvr>
-    <a:masterClrMapping/>
-  </p:clrMapOvr>
-</p:sld>
-</file>
-
-<file path=ppt/slides/slide9.xml><?xml version="1.0" encoding="utf-8"?>
-<p:sld xmlns:a="http://schemas.openxmlformats.org/drawingml/2006/main" xmlns:p="http://schemas.openxmlformats.org/presentationml/2006/main" xmlns:r="http://schemas.openxmlformats.org/officeDocument/2006/relationships">
-  <p:cSld>
-    <p:spTree>
-      <p:nvGrpSpPr>
-        <p:cNvPr id="1" name=""/>
-        <p:cNvGrpSpPr/>
-        <p:nvPr/>
-      </p:nvGrpSpPr>
-      <p:grpSpPr/>
-      <p:sp>
-        <p:nvSpPr>
-          <p:cNvPr id="2" name="Rectangle 1"/>
-          <p:cNvSpPr/>
-          <p:nvPr/>
-        </p:nvSpPr>
-        <p:spPr>
-          <a:xfrm>
-            <a:off x="0" y="0"/>
-            <a:ext cx="12191695" cy="1097280"/>
-          </a:xfrm>
-          <a:prstGeom prst="rect">
-            <a:avLst/>
-          </a:prstGeom>
-          <a:solidFill>
-            <a:srgbClr val="111827"/>
-          </a:solidFill>
-          <a:ln>
-            <a:noFill/>
-          </a:ln>
-          <a:effectLst/>
-        </p:spPr>
-        <p:style>
-          <a:lnRef idx="1">
-            <a:schemeClr val="accent1"/>
-          </a:lnRef>
-          <a:fillRef idx="3">
-            <a:schemeClr val="accent1"/>
-          </a:fillRef>
-          <a:effectRef idx="2">
-            <a:schemeClr val="accent1"/>
-          </a:effectRef>
-          <a:fontRef idx="minor">
-            <a:schemeClr val="lt1"/>
-          </a:fontRef>
-        </p:style>
-        <p:txBody>
-          <a:bodyPr rtlCol="0" anchor="ctr" wrap="square" lIns="457200" rIns="457200" tIns="73152" bIns="73152"/>
-          <a:lstStyle/>
-          <a:p>
-            <a:pPr algn="ctr"/>
-            <a:r>
-              <a:rPr sz="3200" b="1">
-                <a:solidFill>
-                  <a:srgbClr val="FFFFFF"/>
-                </a:solidFill>
-              </a:rPr>
-              <a:t>Sprint 1 backlog</a:t>
-            </a:r>
-          </a:p>
-          <a:p>
-            <a:pPr algn="l"/>
-            <a:r>
-              <a:rPr sz="1500" b="0">
-                <a:solidFill>
-                  <a:srgbClr val="FDBA74"/>
-                </a:solidFill>
-              </a:rPr>
-              <a:t>Each story has acceptance criteria and an assignee</a:t>
-            </a:r>
-          </a:p>
-        </p:txBody>
-      </p:sp>
-      <p:sp>
-        <p:nvSpPr>
-          <p:cNvPr id="3" name="Rectangle 2"/>
-          <p:cNvSpPr/>
-          <p:nvPr/>
-        </p:nvSpPr>
-        <p:spPr>
-          <a:xfrm>
-            <a:off x="0" y="1097280"/>
-            <a:ext cx="12191695" cy="64008"/>
-          </a:xfrm>
-          <a:prstGeom prst="rect">
-            <a:avLst/>
-          </a:prstGeom>
-          <a:solidFill>
-            <a:srgbClr val="F97316"/>
-          </a:solidFill>
-          <a:ln>
-            <a:noFill/>
-          </a:ln>
-          <a:effectLst/>
-        </p:spPr>
-        <p:style>
-          <a:lnRef idx="1">
-            <a:schemeClr val="accent1"/>
-          </a:lnRef>
-          <a:fillRef idx="3">
-            <a:schemeClr val="accent1"/>
-          </a:fillRef>
-          <a:effectRef idx="2">
-            <a:schemeClr val="accent1"/>
-          </a:effectRef>
-          <a:fontRef idx="minor">
-            <a:schemeClr val="lt1"/>
-          </a:fontRef>
-        </p:style>
-        <p:txBody>
-          <a:bodyPr rtlCol="0" anchor="ctr"/>
-          <a:lstStyle/>
-          <a:p>
-            <a:pPr algn="ctr"/>
-          </a:p>
-        </p:txBody>
-      </p:sp>
-      <p:graphicFrame>
-        <p:nvGraphicFramePr>
-          <p:cNvPr id="4" name="Table 3"/>
-          <p:cNvGraphicFramePr>
-            <a:graphicFrameLocks noGrp="1"/>
-          </p:cNvGraphicFramePr>
-          <p:nvPr/>
-        </p:nvGraphicFramePr>
-        <p:xfrm>
-          <a:off x="640080" y="1645920"/>
-          <a:ext cx="10881360" cy="3657600"/>
-        </p:xfrm>
-        <a:graphic>
-          <a:graphicData uri="http://schemas.openxmlformats.org/drawingml/2006/table">
-            <a:tbl>
-              <a:tblPr firstRow="1" bandRow="1">
-                <a:tableStyleId>{5C22544A-7EE6-4342-B048-85BDC9FD1C3A}</a:tableStyleId>
-              </a:tblPr>
-              <a:tblGrid>
-                <a:gridCol w="6035040"/>
-                <a:gridCol w="3566160"/>
-                <a:gridCol w="1280160"/>
-              </a:tblGrid>
-              <a:tr h="731520">
-                <a:tc>
-                  <a:txBody>
-                    <a:bodyPr/>
-                    <a:lstStyle/>
-                    <a:p>
-                      <a:r>
-                        <a:rPr sz="1600" b="1">
-                          <a:solidFill>
-                            <a:srgbClr val="FFFFFF"/>
-                          </a:solidFill>
-                        </a:rPr>
-                        <a:t>User story</a:t>
-                      </a:r>
-                    </a:p>
-                  </a:txBody>
-                  <a:tcPr>
-                    <a:solidFill>
-                      <a:srgbClr val="111827"/>
-                    </a:solidFill>
-                  </a:tcPr>
-                </a:tc>
-                <a:tc>
-                  <a:txBody>
-                    <a:bodyPr/>
-                    <a:lstStyle/>
-                    <a:p>
-                      <a:r>
-                        <a:rPr sz="1600" b="1">
-                          <a:solidFill>
-                            <a:srgbClr val="FFFFFF"/>
-                          </a:solidFill>
-                        </a:rPr>
-                        <a:t>Labels</a:t>
-                      </a:r>
-                    </a:p>
-                  </a:txBody>
-                  <a:tcPr>
-                    <a:solidFill>
-                      <a:srgbClr val="111827"/>
-                    </a:solidFill>
-                  </a:tcPr>
-                </a:tc>
-                <a:tc>
-                  <a:txBody>
-                    <a:bodyPr/>
-                    <a:lstStyle/>
-                    <a:p>
-                      <a:r>
-                        <a:rPr sz="1600" b="1">
-                          <a:solidFill>
-                            <a:srgbClr val="FFFFFF"/>
-                          </a:solidFill>
-                        </a:rPr>
-                        <a:t>Assignee</a:t>
-                      </a:r>
-                    </a:p>
-                  </a:txBody>
-                  <a:tcPr>
-                    <a:solidFill>
-                      <a:srgbClr val="111827"/>
-                    </a:solidFill>
-                  </a:tcPr>
-                </a:tc>
-              </a:tr>
-              <a:tr h="731520">
-                <a:tc>
-                  <a:txBody>
-                    <a:bodyPr/>
-                    <a:lstStyle/>
-                    <a:p>
-                      <a:r>
-                        <a:rPr sz="1600" b="0">
-                          <a:solidFill>
-                            <a:srgbClr val="0F172A"/>
-                          </a:solidFill>
-                        </a:rPr>
-                        <a:t>As a gym-goer, I want to register and log in with email and password</a:t>
-                      </a:r>
-                    </a:p>
-                  </a:txBody>
-                  <a:tcPr>
-                    <a:solidFill>
-                      <a:srgbClr val="F1F5F9"/>
-                    </a:solidFill>
-                  </a:tcPr>
-                </a:tc>
-                <a:tc>
-                  <a:txBody>
-                    <a:bodyPr/>
-                    <a:lstStyle/>
-                    <a:p>
-                      <a:r>
-                        <a:rPr sz="1600" b="0">
-                          <a:solidFill>
-                            <a:srgbClr val="0F172A"/>
-                          </a:solidFill>
-                        </a:rPr>
-                        <a:t>user-story Â· android Â· firebase</a:t>
-                      </a:r>
-                    </a:p>
-                  </a:txBody>
-                  <a:tcPr>
-                    <a:solidFill>
-                      <a:srgbClr val="F1F5F9"/>
-                    </a:solidFill>
-                  </a:tcPr>
-                </a:tc>
-                <a:tc>
-                  <a:txBody>
-                    <a:bodyPr/>
-                    <a:lstStyle/>
-                    <a:p>
-                      <a:r>
-                        <a:rPr sz="1600" b="0">
-                          <a:solidFill>
-                            <a:srgbClr val="0F172A"/>
-                          </a:solidFill>
-                        </a:rPr>
-                        <a:t>Ozodbek</a:t>
-                      </a:r>
-                    </a:p>
-                  </a:txBody>
-                  <a:tcPr>
-                    <a:solidFill>
-                      <a:srgbClr val="F1F5F9"/>
-                    </a:solidFill>
-                  </a:tcPr>
-                </a:tc>
-              </a:tr>
-              <a:tr h="731520">
-                <a:tc>
-                  <a:txBody>
-                    <a:bodyPr/>
-                    <a:lstStyle/>
-                    <a:p>
-                      <a:r>
-                        <a:rPr sz="1600" b="0">
-                          <a:solidFill>
-                            <a:srgbClr val="0F172A"/>
-                          </a:solidFill>
-                        </a:rPr>
-                        <a:t>As a gym-goer, I want to see a list of my workouts</a:t>
-                      </a:r>
-                    </a:p>
-                  </a:txBody>
-                  <a:tcPr>
-                    <a:solidFill>
-                      <a:srgbClr val="FFFFFF"/>
-                    </a:solidFill>
-                  </a:tcPr>
-                </a:tc>
-                <a:tc>
-                  <a:txBody>
-                    <a:bodyPr/>
-                    <a:lstStyle/>
-                    <a:p>
-                      <a:r>
-                        <a:rPr sz="1600" b="0">
-                          <a:solidFill>
-                            <a:srgbClr val="0F172A"/>
-                          </a:solidFill>
-                        </a:rPr>
-                        <a:t>user-story Â· android Â· ui</a:t>
-                      </a:r>
-                    </a:p>
-                  </a:txBody>
-                  <a:tcPr>
-                    <a:solidFill>
-                      <a:srgbClr val="FFFFFF"/>
-                    </a:solidFill>
-                  </a:tcPr>
-                </a:tc>
-                <a:tc>
-                  <a:txBody>
-                    <a:bodyPr/>
-                    <a:lstStyle/>
-                    <a:p>
-                      <a:r>
-                        <a:rPr sz="1600" b="0">
-                          <a:solidFill>
-                            <a:srgbClr val="0F172A"/>
-                          </a:solidFill>
-                        </a:rPr>
-                        <a:t>Elturan</a:t>
-                      </a:r>
-                    </a:p>
-                  </a:txBody>
-                  <a:tcPr>
-                    <a:solidFill>
-                      <a:srgbClr val="FFFFFF"/>
-                    </a:solidFill>
-                  </a:tcPr>
-                </a:tc>
-              </a:tr>
-              <a:tr h="731520">
-                <a:tc>
-                  <a:txBody>
-                    <a:bodyPr/>
-                    <a:lstStyle/>
-                    <a:p>
-                      <a:r>
-                        <a:rPr sz="1600" b="0">
-                          <a:solidFill>
-                            <a:srgbClr val="0F172A"/>
-                          </a:solidFill>
-                        </a:rPr>
-                        <a:t>As a gym-goer, I want to add a workout</a:t>
-                      </a:r>
-                    </a:p>
-                  </a:txBody>
-                  <a:tcPr>
-                    <a:solidFill>
-                      <a:srgbClr val="F1F5F9"/>
-                    </a:solidFill>
-                  </a:tcPr>
-                </a:tc>
-                <a:tc>
-                  <a:txBody>
-                    <a:bodyPr/>
-                    <a:lstStyle/>
-                    <a:p>
-                      <a:r>
-                        <a:rPr sz="1600" b="0">
-                          <a:solidFill>
-                            <a:srgbClr val="0F172A"/>
-                          </a:solidFill>
-                        </a:rPr>
-                        <a:t>user-story Â· android Â· firebase</a:t>
-                      </a:r>
-                    </a:p>
-                  </a:txBody>
-                  <a:tcPr>
-                    <a:solidFill>
-                      <a:srgbClr val="F1F5F9"/>
-                    </a:solidFill>
-                  </a:tcPr>
-                </a:tc>
-                <a:tc>
-                  <a:txBody>
-                    <a:bodyPr/>
-                    <a:lstStyle/>
-                    <a:p>
-                      <a:r>
-                        <a:rPr sz="1600" b="0">
-                          <a:solidFill>
-                            <a:srgbClr val="0F172A"/>
-                          </a:solidFill>
-                        </a:rPr>
-                        <a:t>Aida</a:t>
-                      </a:r>
-                    </a:p>
-                  </a:txBody>
-                  <a:tcPr>
-                    <a:solidFill>
-                      <a:srgbClr val="F1F5F9"/>
-                    </a:solidFill>
-                  </a:tcPr>
-                </a:tc>
-              </a:tr>
-              <a:tr h="731520">
-                <a:tc>
-                  <a:txBody>
-                    <a:bodyPr/>
-                    <a:lstStyle/>
-                    <a:p>
-                      <a:r>
-                        <a:rPr sz="1600" b="0">
-                          <a:solidFill>
-                            <a:srgbClr val="0F172A"/>
-                          </a:solidFill>
-                        </a:rPr>
-                        <a:t>As a gym-goer, I want to edit or delete a workout</a:t>
-                      </a:r>
-                    </a:p>
-                  </a:txBody>
-                  <a:tcPr>
-                    <a:solidFill>
-                      <a:srgbClr val="FFFFFF"/>
-                    </a:solidFill>
-                  </a:tcPr>
-                </a:tc>
-                <a:tc>
-                  <a:txBody>
-                    <a:bodyPr/>
-                    <a:lstStyle/>
-                    <a:p>
-                      <a:r>
-                        <a:rPr sz="1600" b="0">
-                          <a:solidFill>
-                            <a:srgbClr val="0F172A"/>
-                          </a:solidFill>
-                        </a:rPr>
-                        <a:t>user-story Â· android Â· firebase</a:t>
-                      </a:r>
-                    </a:p>
-                  </a:txBody>
-                  <a:tcPr>
-                    <a:solidFill>
-                      <a:srgbClr val="FFFFFF"/>
-                    </a:solidFill>
-                  </a:tcPr>
-                </a:tc>
-                <a:tc>
-                  <a:txBody>
-                    <a:bodyPr/>
-                    <a:lstStyle/>
-                    <a:p>
-                      <a:r>
-                        <a:rPr sz="1600" b="0">
-                          <a:solidFill>
-                            <a:srgbClr val="0F172A"/>
-                          </a:solidFill>
-                        </a:rPr>
-                        <a:t>Elturan</a:t>
-                      </a:r>
-                    </a:p>
-                  </a:txBody>
-                  <a:tcPr>
-                    <a:solidFill>
-                      <a:srgbClr val="FFFFFF"/>
-                    </a:solidFill>
-                  </a:tcPr>
-                </a:tc>
-              </a:tr>
-            </a:tbl>
-          </a:graphicData>
-        </a:graphic>
-      </p:graphicFrame>
-      <p:sp>
-        <p:nvSpPr>
-          <p:cNvPr id="5" name="TextBox 4"/>
-          <p:cNvSpPr txBox="1"/>
-          <p:nvPr/>
-        </p:nvSpPr>
-        <p:spPr>
-          <a:xfrm>
-            <a:off x="640080" y="5486400"/>
-            <a:ext cx="10881360" cy="914400"/>
-          </a:xfrm>
-          <a:prstGeom prst="rect">
-            <a:avLst/>
-          </a:prstGeom>
-          <a:noFill/>
-        </p:spPr>
-        <p:txBody>
-          <a:bodyPr wrap="square">
-            <a:spAutoFit/>
-          </a:bodyPr>
-          <a:lstStyle/>
-          <a:p>
-            <a:pPr algn="l"/>
-            <a:r>
-              <a:rPr sz="1700" b="0">
-                <a:solidFill>
-                  <a:srgbClr val="64748B"/>
-                </a:solidFill>
-              </a:rPr>
-              <a:t>Backlog: weekly stats Cloud Function, find a partner (sessions).</a:t>
+              <a:t> the PR says “Closes #issue”, so the issue moves to Done on merge.</a:t>
             </a:r>
           </a:p>
         </p:txBody>

</xml_diff>

<commit_message>
docs: remove presentation changes and pictures from this PR
</commit_message>
<xml_diff>
--- a/docs/presentation/GymBuddy_Lab1_Presentation.pptx
+++ b/docs/presentation/GymBuddy_Lab1_Presentation.pptx
@@ -18,8 +18,6 @@
     <p:sldId id="266" r:id="rId17"/>
     <p:sldId id="267" r:id="rId18"/>
     <p:sldId id="268" r:id="rId19"/>
-    <p:sldId id="269" r:id="rId20"/>
-    <p:sldId id="270" r:id="rId21"/>
   </p:sldIdLst>
   <p:sldSz cx="12191695" cy="6858000" type="screen4x3"/>
   <p:notesSz cx="6858000" cy="9144000"/>
@@ -3295,7 +3293,7 @@
                   <a:srgbClr val="CBD5E1"/>
                 </a:solidFill>
               </a:rPr>
-              <a:t>Team Project – Mobile Application in the Cloud · Lab 1</a:t>
+              <a:t>Team Project â€“ Mobile Application in the Cloud Â· Lab 1</a:t>
             </a:r>
           </a:p>
           <a:p>
@@ -3306,7 +3304,7 @@
                   <a:srgbClr val="FFFFFF"/>
                 </a:solidFill>
               </a:rPr>
-              <a:t>Aida Ismayilova (57689)  ·  Ozodbek Tursunaliyev (57264)  ·  Elturan Valizada (58990)</a:t>
+              <a:t>Aida Ismayilova (57689)  Â·  Ozodbek Tursunaliyev (57264)  Â·  Elturan Valizada (58990)</a:t>
             </a:r>
           </a:p>
         </p:txBody>
@@ -3376,7 +3374,7 @@
                   <a:srgbClr val="FFFFFF"/>
                 </a:solidFill>
               </a:rPr>
-              <a:t>Sprint 1 backlog</a:t>
+              <a:t>Team and roles</a:t>
             </a:r>
           </a:p>
           <a:p>
@@ -3387,518 +3385,7 @@
                   <a:srgbClr val="FDBA74"/>
                 </a:solidFill>
               </a:rPr>
-              <a:t>Each story has acceptance criteria and an assignee</a:t>
-            </a:r>
-          </a:p>
-        </p:txBody>
-      </p:sp>
-      <p:sp>
-        <p:nvSpPr>
-          <p:cNvPr id="3" name="Rectangle 2"/>
-          <p:cNvSpPr/>
-          <p:nvPr/>
-        </p:nvSpPr>
-        <p:spPr>
-          <a:xfrm>
-            <a:off x="0" y="1097280"/>
-            <a:ext cx="12191695" cy="64008"/>
-          </a:xfrm>
-          <a:prstGeom prst="rect">
-            <a:avLst/>
-          </a:prstGeom>
-          <a:solidFill>
-            <a:srgbClr val="F97316"/>
-          </a:solidFill>
-          <a:ln>
-            <a:noFill/>
-          </a:ln>
-          <a:effectLst/>
-        </p:spPr>
-        <p:style>
-          <a:lnRef idx="1">
-            <a:schemeClr val="accent1"/>
-          </a:lnRef>
-          <a:fillRef idx="3">
-            <a:schemeClr val="accent1"/>
-          </a:fillRef>
-          <a:effectRef idx="2">
-            <a:schemeClr val="accent1"/>
-          </a:effectRef>
-          <a:fontRef idx="minor">
-            <a:schemeClr val="lt1"/>
-          </a:fontRef>
-        </p:style>
-        <p:txBody>
-          <a:bodyPr rtlCol="0" anchor="ctr"/>
-          <a:lstStyle/>
-          <a:p>
-            <a:pPr algn="ctr"/>
-          </a:p>
-        </p:txBody>
-      </p:sp>
-      <p:graphicFrame>
-        <p:nvGraphicFramePr>
-          <p:cNvPr id="4" name="Table 3"/>
-          <p:cNvGraphicFramePr>
-            <a:graphicFrameLocks noGrp="1"/>
-          </p:cNvGraphicFramePr>
-          <p:nvPr/>
-        </p:nvGraphicFramePr>
-        <p:xfrm>
-          <a:off x="640080" y="1645920"/>
-          <a:ext cx="10881360" cy="3657600"/>
-        </p:xfrm>
-        <a:graphic>
-          <a:graphicData uri="http://schemas.openxmlformats.org/drawingml/2006/table">
-            <a:tbl>
-              <a:tblPr firstRow="1" bandRow="1">
-                <a:tableStyleId>{5C22544A-7EE6-4342-B048-85BDC9FD1C3A}</a:tableStyleId>
-              </a:tblPr>
-              <a:tblGrid>
-                <a:gridCol w="6035040"/>
-                <a:gridCol w="3566160"/>
-                <a:gridCol w="1280160"/>
-              </a:tblGrid>
-              <a:tr h="731520">
-                <a:tc>
-                  <a:txBody>
-                    <a:bodyPr/>
-                    <a:lstStyle/>
-                    <a:p>
-                      <a:r>
-                        <a:rPr sz="1600" b="1">
-                          <a:solidFill>
-                            <a:srgbClr val="FFFFFF"/>
-                          </a:solidFill>
-                        </a:rPr>
-                        <a:t>User story</a:t>
-                      </a:r>
-                    </a:p>
-                  </a:txBody>
-                  <a:tcPr>
-                    <a:solidFill>
-                      <a:srgbClr val="111827"/>
-                    </a:solidFill>
-                  </a:tcPr>
-                </a:tc>
-                <a:tc>
-                  <a:txBody>
-                    <a:bodyPr/>
-                    <a:lstStyle/>
-                    <a:p>
-                      <a:r>
-                        <a:rPr sz="1600" b="1">
-                          <a:solidFill>
-                            <a:srgbClr val="FFFFFF"/>
-                          </a:solidFill>
-                        </a:rPr>
-                        <a:t>Labels</a:t>
-                      </a:r>
-                    </a:p>
-                  </a:txBody>
-                  <a:tcPr>
-                    <a:solidFill>
-                      <a:srgbClr val="111827"/>
-                    </a:solidFill>
-                  </a:tcPr>
-                </a:tc>
-                <a:tc>
-                  <a:txBody>
-                    <a:bodyPr/>
-                    <a:lstStyle/>
-                    <a:p>
-                      <a:r>
-                        <a:rPr sz="1600" b="1">
-                          <a:solidFill>
-                            <a:srgbClr val="FFFFFF"/>
-                          </a:solidFill>
-                        </a:rPr>
-                        <a:t>Assignee</a:t>
-                      </a:r>
-                    </a:p>
-                  </a:txBody>
-                  <a:tcPr>
-                    <a:solidFill>
-                      <a:srgbClr val="111827"/>
-                    </a:solidFill>
-                  </a:tcPr>
-                </a:tc>
-              </a:tr>
-              <a:tr h="731520">
-                <a:tc>
-                  <a:txBody>
-                    <a:bodyPr/>
-                    <a:lstStyle/>
-                    <a:p>
-                      <a:r>
-                        <a:rPr sz="1600" b="0">
-                          <a:solidFill>
-                            <a:srgbClr val="0F172A"/>
-                          </a:solidFill>
-                        </a:rPr>
-                        <a:t>As a gym-goer, I want to register and log in with email and password</a:t>
-                      </a:r>
-                    </a:p>
-                  </a:txBody>
-                  <a:tcPr>
-                    <a:solidFill>
-                      <a:srgbClr val="F1F5F9"/>
-                    </a:solidFill>
-                  </a:tcPr>
-                </a:tc>
-                <a:tc>
-                  <a:txBody>
-                    <a:bodyPr/>
-                    <a:lstStyle/>
-                    <a:p>
-                      <a:r>
-                        <a:rPr sz="1600" b="0">
-                          <a:solidFill>
-                            <a:srgbClr val="0F172A"/>
-                          </a:solidFill>
-                        </a:rPr>
-                        <a:t>user-story · android · firebase</a:t>
-                      </a:r>
-                    </a:p>
-                  </a:txBody>
-                  <a:tcPr>
-                    <a:solidFill>
-                      <a:srgbClr val="F1F5F9"/>
-                    </a:solidFill>
-                  </a:tcPr>
-                </a:tc>
-                <a:tc>
-                  <a:txBody>
-                    <a:bodyPr/>
-                    <a:lstStyle/>
-                    <a:p>
-                      <a:r>
-                        <a:rPr sz="1600" b="0">
-                          <a:solidFill>
-                            <a:srgbClr val="0F172A"/>
-                          </a:solidFill>
-                        </a:rPr>
-                        <a:t>Ozodbek</a:t>
-                      </a:r>
-                    </a:p>
-                  </a:txBody>
-                  <a:tcPr>
-                    <a:solidFill>
-                      <a:srgbClr val="F1F5F9"/>
-                    </a:solidFill>
-                  </a:tcPr>
-                </a:tc>
-              </a:tr>
-              <a:tr h="731520">
-                <a:tc>
-                  <a:txBody>
-                    <a:bodyPr/>
-                    <a:lstStyle/>
-                    <a:p>
-                      <a:r>
-                        <a:rPr sz="1600" b="0">
-                          <a:solidFill>
-                            <a:srgbClr val="0F172A"/>
-                          </a:solidFill>
-                        </a:rPr>
-                        <a:t>As a gym-goer, I want to see a list of my workouts</a:t>
-                      </a:r>
-                    </a:p>
-                  </a:txBody>
-                  <a:tcPr>
-                    <a:solidFill>
-                      <a:srgbClr val="FFFFFF"/>
-                    </a:solidFill>
-                  </a:tcPr>
-                </a:tc>
-                <a:tc>
-                  <a:txBody>
-                    <a:bodyPr/>
-                    <a:lstStyle/>
-                    <a:p>
-                      <a:r>
-                        <a:rPr sz="1600" b="0">
-                          <a:solidFill>
-                            <a:srgbClr val="0F172A"/>
-                          </a:solidFill>
-                        </a:rPr>
-                        <a:t>user-story · android · ui</a:t>
-                      </a:r>
-                    </a:p>
-                  </a:txBody>
-                  <a:tcPr>
-                    <a:solidFill>
-                      <a:srgbClr val="FFFFFF"/>
-                    </a:solidFill>
-                  </a:tcPr>
-                </a:tc>
-                <a:tc>
-                  <a:txBody>
-                    <a:bodyPr/>
-                    <a:lstStyle/>
-                    <a:p>
-                      <a:r>
-                        <a:rPr sz="1600" b="0">
-                          <a:solidFill>
-                            <a:srgbClr val="0F172A"/>
-                          </a:solidFill>
-                        </a:rPr>
-                        <a:t>Elturan</a:t>
-                      </a:r>
-                    </a:p>
-                  </a:txBody>
-                  <a:tcPr>
-                    <a:solidFill>
-                      <a:srgbClr val="FFFFFF"/>
-                    </a:solidFill>
-                  </a:tcPr>
-                </a:tc>
-              </a:tr>
-              <a:tr h="731520">
-                <a:tc>
-                  <a:txBody>
-                    <a:bodyPr/>
-                    <a:lstStyle/>
-                    <a:p>
-                      <a:r>
-                        <a:rPr sz="1600" b="0">
-                          <a:solidFill>
-                            <a:srgbClr val="0F172A"/>
-                          </a:solidFill>
-                        </a:rPr>
-                        <a:t>As a gym-goer, I want to add a workout</a:t>
-                      </a:r>
-                    </a:p>
-                  </a:txBody>
-                  <a:tcPr>
-                    <a:solidFill>
-                      <a:srgbClr val="F1F5F9"/>
-                    </a:solidFill>
-                  </a:tcPr>
-                </a:tc>
-                <a:tc>
-                  <a:txBody>
-                    <a:bodyPr/>
-                    <a:lstStyle/>
-                    <a:p>
-                      <a:r>
-                        <a:rPr sz="1600" b="0">
-                          <a:solidFill>
-                            <a:srgbClr val="0F172A"/>
-                          </a:solidFill>
-                        </a:rPr>
-                        <a:t>user-story · android · firebase</a:t>
-                      </a:r>
-                    </a:p>
-                  </a:txBody>
-                  <a:tcPr>
-                    <a:solidFill>
-                      <a:srgbClr val="F1F5F9"/>
-                    </a:solidFill>
-                  </a:tcPr>
-                </a:tc>
-                <a:tc>
-                  <a:txBody>
-                    <a:bodyPr/>
-                    <a:lstStyle/>
-                    <a:p>
-                      <a:r>
-                        <a:rPr sz="1600" b="0">
-                          <a:solidFill>
-                            <a:srgbClr val="0F172A"/>
-                          </a:solidFill>
-                        </a:rPr>
-                        <a:t>Aida</a:t>
-                      </a:r>
-                    </a:p>
-                  </a:txBody>
-                  <a:tcPr>
-                    <a:solidFill>
-                      <a:srgbClr val="F1F5F9"/>
-                    </a:solidFill>
-                  </a:tcPr>
-                </a:tc>
-              </a:tr>
-              <a:tr h="731520">
-                <a:tc>
-                  <a:txBody>
-                    <a:bodyPr/>
-                    <a:lstStyle/>
-                    <a:p>
-                      <a:r>
-                        <a:rPr sz="1600" b="0">
-                          <a:solidFill>
-                            <a:srgbClr val="0F172A"/>
-                          </a:solidFill>
-                        </a:rPr>
-                        <a:t>As a gym-goer, I want to edit or delete a workout</a:t>
-                      </a:r>
-                    </a:p>
-                  </a:txBody>
-                  <a:tcPr>
-                    <a:solidFill>
-                      <a:srgbClr val="FFFFFF"/>
-                    </a:solidFill>
-                  </a:tcPr>
-                </a:tc>
-                <a:tc>
-                  <a:txBody>
-                    <a:bodyPr/>
-                    <a:lstStyle/>
-                    <a:p>
-                      <a:r>
-                        <a:rPr sz="1600" b="0">
-                          <a:solidFill>
-                            <a:srgbClr val="0F172A"/>
-                          </a:solidFill>
-                        </a:rPr>
-                        <a:t>user-story · android · firebase</a:t>
-                      </a:r>
-                    </a:p>
-                  </a:txBody>
-                  <a:tcPr>
-                    <a:solidFill>
-                      <a:srgbClr val="FFFFFF"/>
-                    </a:solidFill>
-                  </a:tcPr>
-                </a:tc>
-                <a:tc>
-                  <a:txBody>
-                    <a:bodyPr/>
-                    <a:lstStyle/>
-                    <a:p>
-                      <a:r>
-                        <a:rPr sz="1600" b="0">
-                          <a:solidFill>
-                            <a:srgbClr val="0F172A"/>
-                          </a:solidFill>
-                        </a:rPr>
-                        <a:t>Elturan</a:t>
-                      </a:r>
-                    </a:p>
-                  </a:txBody>
-                  <a:tcPr>
-                    <a:solidFill>
-                      <a:srgbClr val="FFFFFF"/>
-                    </a:solidFill>
-                  </a:tcPr>
-                </a:tc>
-              </a:tr>
-            </a:tbl>
-          </a:graphicData>
-        </a:graphic>
-      </p:graphicFrame>
-      <p:sp>
-        <p:nvSpPr>
-          <p:cNvPr id="5" name="TextBox 4"/>
-          <p:cNvSpPr txBox="1"/>
-          <p:nvPr/>
-        </p:nvSpPr>
-        <p:spPr>
-          <a:xfrm>
-            <a:off x="640080" y="5486400"/>
-            <a:ext cx="10881360" cy="914400"/>
-          </a:xfrm>
-          <a:prstGeom prst="rect">
-            <a:avLst/>
-          </a:prstGeom>
-          <a:noFill/>
-        </p:spPr>
-        <p:txBody>
-          <a:bodyPr wrap="square">
-            <a:spAutoFit/>
-          </a:bodyPr>
-          <a:lstStyle/>
-          <a:p>
-            <a:pPr algn="l"/>
-            <a:r>
-              <a:rPr sz="1700" b="0">
-                <a:solidFill>
-                  <a:srgbClr val="64748B"/>
-                </a:solidFill>
-              </a:rPr>
-              <a:t>Backlog: weekly stats Cloud Function, find a partner (sessions).</a:t>
-            </a:r>
-          </a:p>
-        </p:txBody>
-      </p:sp>
-    </p:spTree>
-  </p:cSld>
-  <p:clrMapOvr>
-    <a:masterClrMapping/>
-  </p:clrMapOvr>
-</p:sld>
-</file>
-
-<file path=ppt/slides/slide11.xml><?xml version="1.0" encoding="utf-8"?>
-<p:sld xmlns:a="http://schemas.openxmlformats.org/drawingml/2006/main" xmlns:p="http://schemas.openxmlformats.org/presentationml/2006/main" xmlns:r="http://schemas.openxmlformats.org/officeDocument/2006/relationships">
-  <p:cSld>
-    <p:spTree>
-      <p:nvGrpSpPr>
-        <p:cNvPr id="1" name=""/>
-        <p:cNvGrpSpPr/>
-        <p:nvPr/>
-      </p:nvGrpSpPr>
-      <p:grpSpPr/>
-      <p:sp>
-        <p:nvSpPr>
-          <p:cNvPr id="2" name="Rectangle 1"/>
-          <p:cNvSpPr/>
-          <p:nvPr/>
-        </p:nvSpPr>
-        <p:spPr>
-          <a:xfrm>
-            <a:off x="0" y="0"/>
-            <a:ext cx="12191695" cy="1097280"/>
-          </a:xfrm>
-          <a:prstGeom prst="rect">
-            <a:avLst/>
-          </a:prstGeom>
-          <a:solidFill>
-            <a:srgbClr val="111827"/>
-          </a:solidFill>
-          <a:ln>
-            <a:noFill/>
-          </a:ln>
-          <a:effectLst/>
-        </p:spPr>
-        <p:style>
-          <a:lnRef idx="1">
-            <a:schemeClr val="accent1"/>
-          </a:lnRef>
-          <a:fillRef idx="3">
-            <a:schemeClr val="accent1"/>
-          </a:fillRef>
-          <a:effectRef idx="2">
-            <a:schemeClr val="accent1"/>
-          </a:effectRef>
-          <a:fontRef idx="minor">
-            <a:schemeClr val="lt1"/>
-          </a:fontRef>
-        </p:style>
-        <p:txBody>
-          <a:bodyPr rtlCol="0" anchor="ctr" wrap="square" lIns="457200" rIns="457200" tIns="73152" bIns="73152"/>
-          <a:lstStyle/>
-          <a:p>
-            <a:pPr algn="ctr"/>
-            <a:r>
-              <a:rPr sz="3200" b="1">
-                <a:solidFill>
-                  <a:srgbClr val="FFFFFF"/>
-                </a:solidFill>
-              </a:rPr>
-              <a:t>Team and roles</a:t>
-            </a:r>
-          </a:p>
-          <a:p>
-            <a:pPr algn="l"/>
-            <a:r>
-              <a:rPr sz="1500" b="0">
-                <a:solidFill>
-                  <a:srgbClr val="FDBA74"/>
-                </a:solidFill>
-              </a:rPr>
-              <a:t>Everyone writes code – roles say who is accountable for a decision</a:t>
+              <a:t>Everyone writes code â€“ roles say who is accountable for a decision</a:t>
             </a:r>
           </a:p>
         </p:txBody>
@@ -4274,7 +3761,7 @@
 </p:sld>
 </file>
 
-<file path=ppt/slides/slide12.xml><?xml version="1.0" encoding="utf-8"?>
+<file path=ppt/slides/slide11.xml><?xml version="1.0" encoding="utf-8"?>
 <p:sld xmlns:a="http://schemas.openxmlformats.org/drawingml/2006/main" xmlns:p="http://schemas.openxmlformats.org/presentationml/2006/main" xmlns:r="http://schemas.openxmlformats.org/officeDocument/2006/relationships">
   <p:cSld>
     <p:spTree>
@@ -4698,7 +4185,7 @@
                   <a:srgbClr val="FFFFFF"/>
                 </a:solidFill>
               </a:rPr>
-              <a:t>Squash merge → Done</a:t>
+              <a:t>Squash merge â†’ Done</a:t>
             </a:r>
           </a:p>
         </p:txBody>
@@ -4736,7 +4223,7 @@
                   <a:srgbClr val="F97316"/>
                 </a:solidFill>
               </a:rPr>
-              <a:t>•  </a:t>
+              <a:t>â€¢  </a:t>
             </a:r>
             <a:r>
               <a:rPr sz="1900" b="1">
@@ -4752,7 +4239,7 @@
                   <a:srgbClr val="64748B"/>
                 </a:solidFill>
               </a:rPr>
-              <a:t> ruleset protect-main – pull request required, no force push, no deletion.</a:t>
+              <a:t> ruleset protect-main â€“ pull request required, no force push, no deletion.</a:t>
             </a:r>
           </a:p>
           <a:p>
@@ -4767,7 +4254,7 @@
                   <a:srgbClr val="F97316"/>
                 </a:solidFill>
               </a:rPr>
-              <a:t>•  </a:t>
+              <a:t>â€¢  </a:t>
             </a:r>
             <a:r>
               <a:rPr sz="1900" b="1">
@@ -4783,7 +4270,7 @@
                   <a:srgbClr val="64748B"/>
                 </a:solidFill>
               </a:rPr>
-              <a:t> Backlog · Sprint 1 · In progress · In review · Done.</a:t>
+              <a:t> Backlog Â· Sprint 1 Â· In progress Â· In review Â· Done.</a:t>
             </a:r>
           </a:p>
           <a:p>
@@ -4798,7 +4285,7 @@
                   <a:srgbClr val="F97316"/>
                 </a:solidFill>
               </a:rPr>
-              <a:t>•  </a:t>
+              <a:t>â€¢  </a:t>
             </a:r>
             <a:r>
               <a:rPr sz="1900" b="1">
@@ -4814,7 +4301,7 @@
                   <a:srgbClr val="64748B"/>
                 </a:solidFill>
               </a:rPr>
-              <a:t> pull request template with “Closes #issue” and a test checklist.</a:t>
+              <a:t> pull request template with â€œCloses #issueâ€ and a test checklist.</a:t>
             </a:r>
           </a:p>
           <a:p>
@@ -4829,7 +4316,7 @@
                   <a:srgbClr val="F97316"/>
                 </a:solidFill>
               </a:rPr>
-              <a:t>•  </a:t>
+              <a:t>â€¢  </a:t>
             </a:r>
             <a:r>
               <a:rPr sz="1900" b="1">
@@ -4858,7 +4345,7 @@
 </p:sld>
 </file>
 
-<file path=ppt/slides/slide13.xml><?xml version="1.0" encoding="utf-8"?>
+<file path=ppt/slides/slide12.xml><?xml version="1.0" encoding="utf-8"?>
 <p:sld xmlns:a="http://schemas.openxmlformats.org/drawingml/2006/main" xmlns:p="http://schemas.openxmlformats.org/presentationml/2006/main" xmlns:r="http://schemas.openxmlformats.org/officeDocument/2006/relationships">
   <p:cSld>
     <p:spTree>
@@ -5118,7 +4605,7 @@
                             <a:srgbClr val="0F172A"/>
                           </a:solidFill>
                         </a:rPr>
-                        <a:t>Data model and architecture diagram, then the live demo: register → logout → login → restart with auto-login</a:t>
+                        <a:t>Data model and architecture diagram, then the live demo: register â†’ logout â†’ login â†’ restart with auto-login</a:t>
                       </a:r>
                     </a:p>
                   </a:txBody>
@@ -5210,7 +4697,7 @@
                   <a:srgbClr val="F97316"/>
                 </a:solidFill>
               </a:rPr>
-              <a:t>•  </a:t>
+              <a:t>â€¢  </a:t>
             </a:r>
             <a:r>
               <a:rPr sz="1800" b="0">
@@ -5218,7 +4705,7 @@
                   <a:srgbClr val="0F172A"/>
                 </a:solidFill>
               </a:rPr>
-              <a:t>Expected question: “Where do you check that a user only edits their own data?” → In Firebase Security Rules (Lab 2), not only in the app.</a:t>
+              <a:t>Expected question: â€œWhere do you check that a user only edits their own data?â€ â†’ In Firebase Security Rules (Lab 2), not only in the app.</a:t>
             </a:r>
           </a:p>
         </p:txBody>
@@ -5231,7 +4718,7 @@
 </p:sld>
 </file>
 
-<file path=ppt/slides/slide14.xml><?xml version="1.0" encoding="utf-8"?>
+<file path=ppt/slides/slide13.xml><?xml version="1.0" encoding="utf-8"?>
 <p:sld xmlns:a="http://schemas.openxmlformats.org/drawingml/2006/main" xmlns:p="http://schemas.openxmlformats.org/presentationml/2006/main" xmlns:r="http://schemas.openxmlformats.org/officeDocument/2006/relationships">
   <p:cSld>
     <p:spTree>
@@ -5288,7 +4775,7 @@
                   <a:srgbClr val="FFFFFF"/>
                 </a:solidFill>
               </a:rPr>
-              <a:t>Where we are now</a:t>
+              <a:t>What's next</a:t>
             </a:r>
           </a:p>
           <a:p>
@@ -5299,7 +4786,7 @@
                   <a:srgbClr val="FDBA74"/>
                 </a:solidFill>
               </a:rPr>
-              <a:t>Lab 1 checklist: done and still to do</a:t>
+              <a:t>Lab 1 delivers the walking skeleton</a:t>
             </a:r>
           </a:p>
         </p:txBody>
@@ -5348,296 +4835,187 @@
           </a:p>
         </p:txBody>
       </p:sp>
-      <p:graphicFrame>
-        <p:nvGraphicFramePr>
-          <p:cNvPr id="4" name="Table 3"/>
-          <p:cNvGraphicFramePr>
-            <a:graphicFrameLocks noGrp="1"/>
-          </p:cNvGraphicFramePr>
+      <p:sp>
+        <p:nvSpPr>
+          <p:cNvPr id="4" name="TextBox 3"/>
+          <p:cNvSpPr txBox="1"/>
           <p:nvPr/>
-        </p:nvGraphicFramePr>
-        <p:xfrm>
-          <a:off x="640080" y="1645920"/>
-          <a:ext cx="10881360" cy="4663440"/>
-        </p:xfrm>
-        <a:graphic>
-          <a:graphicData uri="http://schemas.openxmlformats.org/drawingml/2006/table">
-            <a:tbl>
-              <a:tblPr firstRow="1" bandRow="1">
-                <a:tableStyleId>{5C22544A-7EE6-4342-B048-85BDC9FD1C3A}</a:tableStyleId>
-              </a:tblPr>
-              <a:tblGrid>
-                <a:gridCol w="5440680"/>
-                <a:gridCol w="5440680"/>
-              </a:tblGrid>
-              <a:tr h="777240">
-                <a:tc>
-                  <a:txBody>
-                    <a:bodyPr/>
-                    <a:lstStyle/>
-                    <a:p>
-                      <a:r>
-                        <a:rPr sz="1500" b="1">
-                          <a:solidFill>
-                            <a:srgbClr val="FFFFFF"/>
-                          </a:solidFill>
-                        </a:rPr>
-                        <a:t>Done</a:t>
-                      </a:r>
-                    </a:p>
-                  </a:txBody>
-                  <a:tcPr>
-                    <a:solidFill>
-                      <a:srgbClr val="111827"/>
-                    </a:solidFill>
-                  </a:tcPr>
-                </a:tc>
-                <a:tc>
-                  <a:txBody>
-                    <a:bodyPr/>
-                    <a:lstStyle/>
-                    <a:p>
-                      <a:r>
-                        <a:rPr sz="1500" b="1">
-                          <a:solidFill>
-                            <a:srgbClr val="FFFFFF"/>
-                          </a:solidFill>
-                        </a:rPr>
-                        <a:t>Still to do</a:t>
-                      </a:r>
-                    </a:p>
-                  </a:txBody>
-                  <a:tcPr>
-                    <a:solidFill>
-                      <a:srgbClr val="111827"/>
-                    </a:solidFill>
-                  </a:tcPr>
-                </a:tc>
-              </a:tr>
-              <a:tr h="777240">
-                <a:tc>
-                  <a:txBody>
-                    <a:bodyPr/>
-                    <a:lstStyle/>
-                    <a:p>
-                      <a:r>
-                        <a:rPr sz="1500" b="0">
-                          <a:solidFill>
-                            <a:srgbClr val="0F172A"/>
-                          </a:solidFill>
-                        </a:rPr>
-                        <a:t>Problem statement, MVP, data model and architecture in the README</a:t>
-                      </a:r>
-                    </a:p>
-                  </a:txBody>
-                  <a:tcPr>
-                    <a:solidFill>
-                      <a:srgbClr val="F1F5F9"/>
-                    </a:solidFill>
-                  </a:tcPr>
-                </a:tc>
-                <a:tc>
-                  <a:txBody>
-                    <a:bodyPr/>
-                    <a:lstStyle/>
-                    <a:p>
-                      <a:r>
-                        <a:rPr sz="1500" b="0">
-                          <a:solidFill>
-                            <a:srgbClr val="0F172A"/>
-                          </a:solidFill>
-                        </a:rPr>
-                        <a:t>Sprint board with 5 columns and issues in the right columns</a:t>
-                      </a:r>
-                    </a:p>
-                  </a:txBody>
-                  <a:tcPr>
-                    <a:solidFill>
-                      <a:srgbClr val="F1F5F9"/>
-                    </a:solidFill>
-                  </a:tcPr>
-                </a:tc>
-              </a:tr>
-              <a:tr h="777240">
-                <a:tc>
-                  <a:txBody>
-                    <a:bodyPr/>
-                    <a:lstStyle/>
-                    <a:p>
-                      <a:r>
-                        <a:rPr sz="1500" b="0">
-                          <a:solidFill>
-                            <a:srgbClr val="0F172A"/>
-                          </a:solidFill>
-                        </a:rPr>
-                        <a:t>Public repo, first push to main, PR template</a:t>
-                      </a:r>
-                    </a:p>
-                  </a:txBody>
-                  <a:tcPr>
-                    <a:solidFill>
-                      <a:srgbClr val="FFFFFF"/>
-                    </a:solidFill>
-                  </a:tcPr>
-                </a:tc>
-                <a:tc>
-                  <a:txBody>
-                    <a:bodyPr/>
-                    <a:lstStyle/>
-                    <a:p>
-                      <a:r>
-                        <a:rPr sz="1500" b="0">
-                          <a:solidFill>
-                            <a:srgbClr val="0F172A"/>
-                          </a:solidFill>
-                        </a:rPr>
-                        <a:t>Ruleset protecting main (PR required, no force push)</a:t>
-                      </a:r>
-                    </a:p>
-                  </a:txBody>
-                  <a:tcPr>
-                    <a:solidFill>
-                      <a:srgbClr val="FFFFFF"/>
-                    </a:solidFill>
-                  </a:tcPr>
-                </a:tc>
-              </a:tr>
-              <a:tr h="777240">
-                <a:tc>
-                  <a:txBody>
-                    <a:bodyPr/>
-                    <a:lstStyle/>
-                    <a:p>
-                      <a:r>
-                        <a:rPr sz="1500" b="0">
-                          <a:solidFill>
-                            <a:srgbClr val="0F172A"/>
-                          </a:solidFill>
-                        </a:rPr>
-                        <a:t>Labels and 6 issues with user story and acceptance criteria</a:t>
-                      </a:r>
-                    </a:p>
-                  </a:txBody>
-                  <a:tcPr>
-                    <a:solidFill>
-                      <a:srgbClr val="F1F5F9"/>
-                    </a:solidFill>
-                  </a:tcPr>
-                </a:tc>
-                <a:tc>
-                  <a:txBody>
-                    <a:bodyPr/>
-                    <a:lstStyle/>
-                    <a:p>
-                      <a:r>
-                        <a:rPr sz="1500" b="0">
-                          <a:solidFill>
-                            <a:srgbClr val="0F172A"/>
-                          </a:solidFill>
-                        </a:rPr>
-                        <a:t>Assignees on every Sprint 1 issue (teammates must accept their invitations)</a:t>
-                      </a:r>
-                    </a:p>
-                  </a:txBody>
-                  <a:tcPr>
-                    <a:solidFill>
-                      <a:srgbClr val="F1F5F9"/>
-                    </a:solidFill>
-                  </a:tcPr>
-                </a:tc>
-              </a:tr>
-              <a:tr h="777240">
-                <a:tc>
-                  <a:txBody>
-                    <a:bodyPr/>
-                    <a:lstStyle/>
-                    <a:p>
-                      <a:r>
-                        <a:rPr sz="1500" b="0">
-                          <a:solidFill>
-                            <a:srgbClr val="0F172A"/>
-                          </a:solidFill>
-                        </a:rPr>
-                        <a:t>Authentication code: repository, validator, ViewModel, screens, navigation</a:t>
-                      </a:r>
-                    </a:p>
-                  </a:txBody>
-                  <a:tcPr>
-                    <a:solidFill>
-                      <a:srgbClr val="FFFFFF"/>
-                    </a:solidFill>
-                  </a:tcPr>
-                </a:tc>
-                <a:tc>
-                  <a:txBody>
-                    <a:bodyPr/>
-                    <a:lstStyle/>
-                    <a:p>
-                      <a:r>
-                        <a:rPr sz="1500" b="0">
-                          <a:solidFill>
-                            <a:srgbClr val="0F172A"/>
-                          </a:solidFill>
-                        </a:rPr>
-                        <a:t>Firebase project, google-services.json, Email/Password sign-in, test on the emulator</a:t>
-                      </a:r>
-                    </a:p>
-                  </a:txBody>
-                  <a:tcPr>
-                    <a:solidFill>
-                      <a:srgbClr val="FFFFFF"/>
-                    </a:solidFill>
-                  </a:tcPr>
-                </a:tc>
-              </a:tr>
-              <a:tr h="777240">
-                <a:tc>
-                  <a:txBody>
-                    <a:bodyPr/>
-                    <a:lstStyle/>
-                    <a:p>
-                      <a:r>
-                        <a:rPr sz="1500" b="0">
-                          <a:solidFill>
-                            <a:srgbClr val="0F172A"/>
-                          </a:solidFill>
-                        </a:rPr>
-                        <a:t>PR #7 merged (project overview)</a:t>
-                      </a:r>
-                    </a:p>
-                  </a:txBody>
-                  <a:tcPr>
-                    <a:solidFill>
-                      <a:srgbClr val="F1F5F9"/>
-                    </a:solidFill>
-                  </a:tcPr>
-                </a:tc>
-                <a:tc>
-                  <a:txBody>
-                    <a:bodyPr/>
-                    <a:lstStyle/>
-                    <a:p>
-                      <a:r>
-                        <a:rPr sz="1500" b="0">
-                          <a:solidFill>
-                            <a:srgbClr val="0F172A"/>
-                          </a:solidFill>
-                        </a:rPr>
-                        <a:t>At least two merged PRs, each with a teammate review; Retro – Lab 1 issue</a:t>
-                      </a:r>
-                    </a:p>
-                  </a:txBody>
-                  <a:tcPr>
-                    <a:solidFill>
-                      <a:srgbClr val="F1F5F9"/>
-                    </a:solidFill>
-                  </a:tcPr>
-                </a:tc>
-              </a:tr>
-            </a:tbl>
-          </a:graphicData>
-        </a:graphic>
-      </p:graphicFrame>
+        </p:nvSpPr>
+        <p:spPr>
+          <a:xfrm>
+            <a:off x="640080" y="1645920"/>
+            <a:ext cx="10881360" cy="3657600"/>
+          </a:xfrm>
+          <a:prstGeom prst="rect">
+            <a:avLst/>
+          </a:prstGeom>
+          <a:noFill/>
+        </p:spPr>
+        <p:txBody>
+          <a:bodyPr wrap="square">
+            <a:spAutoFit/>
+          </a:bodyPr>
+          <a:lstStyle/>
+          <a:p>
+            <a:pPr algn="l">
+              <a:spcAft>
+                <a:spcPts val="1000"/>
+              </a:spcAft>
+            </a:pPr>
+            <a:r>
+              <a:rPr sz="2200" b="1">
+                <a:solidFill>
+                  <a:srgbClr val="F97316"/>
+                </a:solidFill>
+              </a:rPr>
+              <a:t>â€¢  </a:t>
+            </a:r>
+            <a:r>
+              <a:rPr sz="2200" b="1">
+                <a:solidFill>
+                  <a:srgbClr val="0F172A"/>
+                </a:solidFill>
+              </a:rPr>
+              <a:t>Lab 1:</a:t>
+            </a:r>
+            <a:r>
+              <a:rPr sz="2200" b="0">
+                <a:solidFill>
+                  <a:srgbClr val="64748B"/>
+                </a:solidFill>
+              </a:rPr>
+              <a:t> repo, board, Firebase project, register / login / logout / auto-login.</a:t>
+            </a:r>
+          </a:p>
+          <a:p>
+            <a:pPr algn="l">
+              <a:spcAft>
+                <a:spcPts val="1000"/>
+              </a:spcAft>
+            </a:pPr>
+            <a:r>
+              <a:rPr sz="2200" b="1">
+                <a:solidFill>
+                  <a:srgbClr val="F97316"/>
+                </a:solidFill>
+              </a:rPr>
+              <a:t>â€¢  </a:t>
+            </a:r>
+            <a:r>
+              <a:rPr sz="2200" b="1">
+                <a:solidFill>
+                  <a:srgbClr val="0F172A"/>
+                </a:solidFill>
+              </a:rPr>
+              <a:t>Lab 2:</a:t>
+            </a:r>
+            <a:r>
+              <a:rPr sz="2200" b="0">
+                <a:solidFill>
+                  <a:srgbClr val="64748B"/>
+                </a:solidFill>
+              </a:rPr>
+              <a:t> workouts in Firestore â€“ list, add, edit, delete â€“ and Security Rules.</a:t>
+            </a:r>
+          </a:p>
+          <a:p>
+            <a:pPr algn="l">
+              <a:spcAft>
+                <a:spcPts val="1000"/>
+              </a:spcAft>
+            </a:pPr>
+            <a:r>
+              <a:rPr sz="2200" b="1">
+                <a:solidFill>
+                  <a:srgbClr val="F97316"/>
+                </a:solidFill>
+              </a:rPr>
+              <a:t>â€¢  </a:t>
+            </a:r>
+            <a:r>
+              <a:rPr sz="2200" b="1">
+                <a:solidFill>
+                  <a:srgbClr val="0F172A"/>
+                </a:solidFill>
+              </a:rPr>
+              <a:t>Lab 3:</a:t>
+            </a:r>
+            <a:r>
+              <a:rPr sz="2200" b="0">
+                <a:solidFill>
+                  <a:srgbClr val="64748B"/>
+                </a:solidFill>
+              </a:rPr>
+              <a:t> Cloud Function for weekly stats, unit tests for the validator.</a:t>
+            </a:r>
+          </a:p>
+          <a:p>
+            <a:pPr algn="l">
+              <a:spcAft>
+                <a:spcPts val="1000"/>
+              </a:spcAft>
+            </a:pPr>
+            <a:r>
+              <a:rPr sz="2200" b="1">
+                <a:solidFill>
+                  <a:srgbClr val="F97316"/>
+                </a:solidFill>
+              </a:rPr>
+              <a:t>â€¢  </a:t>
+            </a:r>
+            <a:r>
+              <a:rPr sz="2200" b="1">
+                <a:solidFill>
+                  <a:srgbClr val="0F172A"/>
+                </a:solidFill>
+              </a:rPr>
+              <a:t>Retro â€“ Lab 1:</a:t>
+            </a:r>
+            <a:r>
+              <a:rPr sz="2200" b="0">
+                <a:solidFill>
+                  <a:srgbClr val="64748B"/>
+                </a:solidFill>
+              </a:rPr>
+              <a:t> one issue, every member comments: went well / did not go well / we will change.</a:t>
+            </a:r>
+          </a:p>
+        </p:txBody>
+      </p:sp>
+      <p:sp>
+        <p:nvSpPr>
+          <p:cNvPr id="5" name="TextBox 4"/>
+          <p:cNvSpPr txBox="1"/>
+          <p:nvPr/>
+        </p:nvSpPr>
+        <p:spPr>
+          <a:xfrm>
+            <a:off x="640080" y="5486400"/>
+            <a:ext cx="10881360" cy="914400"/>
+          </a:xfrm>
+          <a:prstGeom prst="rect">
+            <a:avLst/>
+          </a:prstGeom>
+          <a:noFill/>
+        </p:spPr>
+        <p:txBody>
+          <a:bodyPr wrap="none">
+            <a:spAutoFit/>
+          </a:bodyPr>
+          <a:lstStyle/>
+          <a:p>
+            <a:pPr algn="l"/>
+            <a:r>
+              <a:rPr sz="3000" b="1">
+                <a:solidFill>
+                  <a:srgbClr val="C2410C"/>
+                </a:solidFill>
+              </a:rPr>
+              <a:t>Thank you â€“ questions?</a:t>
+            </a:r>
+          </a:p>
+        </p:txBody>
+      </p:sp>
     </p:spTree>
   </p:cSld>
   <p:clrMapOvr>
@@ -5646,7 +5024,7 @@
 </p:sld>
 </file>
 
-<file path=ppt/slides/slide15.xml><?xml version="1.0" encoding="utf-8"?>
+<file path=ppt/slides/slide2.xml><?xml version="1.0" encoding="utf-8"?>
 <p:sld xmlns:a="http://schemas.openxmlformats.org/drawingml/2006/main" xmlns:p="http://schemas.openxmlformats.org/presentationml/2006/main" xmlns:r="http://schemas.openxmlformats.org/officeDocument/2006/relationships">
   <p:cSld>
     <p:spTree>
@@ -5703,7 +5081,7 @@
                   <a:srgbClr val="FFFFFF"/>
                 </a:solidFill>
               </a:rPr>
-              <a:t>What's next</a:t>
+              <a:t>What is GymBuddy?</a:t>
             </a:r>
           </a:p>
           <a:p>
@@ -5714,7 +5092,7 @@
                   <a:srgbClr val="FDBA74"/>
                 </a:solidFill>
               </a:rPr>
-              <a:t>Lab 1 delivers the walking skeleton</a:t>
+              <a:t>An Android app backed by the cloud</a:t>
             </a:r>
           </a:p>
         </p:txBody>
@@ -5771,8 +5149,8 @@
         </p:nvSpPr>
         <p:spPr>
           <a:xfrm>
-            <a:off x="640080" y="1645920"/>
-            <a:ext cx="10881360" cy="3657600"/>
+            <a:off x="640080" y="1554480"/>
+            <a:ext cx="6583680" cy="4572000"/>
           </a:xfrm>
           <a:prstGeom prst="rect">
             <a:avLst/>
@@ -5796,7 +5174,7 @@
                   <a:srgbClr val="F97316"/>
                 </a:solidFill>
               </a:rPr>
-              <a:t>•  </a:t>
+              <a:t>â€¢  </a:t>
             </a:r>
             <a:r>
               <a:rPr sz="2200" b="1">
@@ -5804,7 +5182,7 @@
                   <a:srgbClr val="0F172A"/>
                 </a:solidFill>
               </a:rPr>
-              <a:t>Lab 1:</a:t>
+              <a:t>Gym + Buddy:</a:t>
             </a:r>
             <a:r>
               <a:rPr sz="2200" b="0">
@@ -5812,7 +5190,7 @@
                   <a:srgbClr val="64748B"/>
                 </a:solidFill>
               </a:rPr>
-              <a:t> repo, board, Firebase project, register / login / logout / auto-login.</a:t>
+              <a:t> your workout log and your training partner finder in one app.</a:t>
             </a:r>
           </a:p>
           <a:p>
@@ -5827,7 +5205,7 @@
                   <a:srgbClr val="F97316"/>
                 </a:solidFill>
               </a:rPr>
-              <a:t>•  </a:t>
+              <a:t>â€¢  </a:t>
             </a:r>
             <a:r>
               <a:rPr sz="2200" b="1">
@@ -5835,7 +5213,7 @@
                   <a:srgbClr val="0F172A"/>
                 </a:solidFill>
               </a:rPr>
-              <a:t>Lab 2:</a:t>
+              <a:t>Log:</a:t>
             </a:r>
             <a:r>
               <a:rPr sz="2200" b="0">
@@ -5843,7 +5221,7 @@
                   <a:srgbClr val="64748B"/>
                 </a:solidFill>
               </a:rPr>
-              <a:t> workouts in Firestore – list, add, edit, delete – and Security Rules.</a:t>
+              <a:t> record each workout (type, duration, notes) and see your history and weekly progress.</a:t>
             </a:r>
           </a:p>
           <a:p>
@@ -5858,7 +5236,7 @@
                   <a:srgbClr val="F97316"/>
                 </a:solidFill>
               </a:rPr>
-              <a:t>•  </a:t>
+              <a:t>â€¢  </a:t>
             </a:r>
             <a:r>
               <a:rPr sz="2200" b="1">
@@ -5866,7 +5244,7 @@
                   <a:srgbClr val="0F172A"/>
                 </a:solidFill>
               </a:rPr>
-              <a:t>Lab 3:</a:t>
+              <a:t>Find:</a:t>
             </a:r>
             <a:r>
               <a:rPr sz="2200" b="0">
@@ -5874,7 +5252,7 @@
                   <a:srgbClr val="64748B"/>
                 </a:solidFill>
               </a:rPr>
-              <a:t> Cloud Function for weekly stats, unit tests for the validator.</a:t>
+              <a:t> post or join open training sessions, so you never have to train alone.</a:t>
             </a:r>
           </a:p>
           <a:p>
@@ -5889,7 +5267,7 @@
                   <a:srgbClr val="F97316"/>
                 </a:solidFill>
               </a:rPr>
-              <a:t>•  </a:t>
+              <a:t>â€¢  </a:t>
             </a:r>
             <a:r>
               <a:rPr sz="2200" b="1">
@@ -5897,7 +5275,7 @@
                   <a:srgbClr val="0F172A"/>
                 </a:solidFill>
               </a:rPr>
-              <a:t>Retro – Lab 1:</a:t>
+              <a:t>Cloud:</a:t>
             </a:r>
             <a:r>
               <a:rPr sz="2200" b="0">
@@ -5905,41 +5283,74 @@
                   <a:srgbClr val="64748B"/>
                 </a:solidFill>
               </a:rPr>
-              <a:t> one issue, every member comments: went well / did not go well / we will change.</a:t>
-            </a:r>
-          </a:p>
-        </p:txBody>
-      </p:sp>
-      <p:sp>
-        <p:nvSpPr>
-          <p:cNvPr id="5" name="TextBox 4"/>
-          <p:cNvSpPr txBox="1"/>
+              <a:t> everything is stored in Firebase, so your data follows you to any phone.</a:t>
+            </a:r>
+          </a:p>
+        </p:txBody>
+      </p:sp>
+      <p:sp>
+        <p:nvSpPr>
+          <p:cNvPr id="5" name="Rounded Rectangle 4"/>
+          <p:cNvSpPr/>
           <p:nvPr/>
         </p:nvSpPr>
         <p:spPr>
           <a:xfrm>
-            <a:off x="640080" y="5486400"/>
-            <a:ext cx="10881360" cy="914400"/>
+            <a:off x="7589520" y="1737360"/>
+            <a:ext cx="4023360" cy="4206240"/>
           </a:xfrm>
-          <a:prstGeom prst="rect">
+          <a:prstGeom prst="roundRect">
             <a:avLst/>
           </a:prstGeom>
-          <a:noFill/>
+          <a:solidFill>
+            <a:srgbClr val="F1F5F9"/>
+          </a:solidFill>
+          <a:ln>
+            <a:noFill/>
+          </a:ln>
+          <a:effectLst/>
         </p:spPr>
-        <p:txBody>
-          <a:bodyPr wrap="none">
-            <a:spAutoFit/>
-          </a:bodyPr>
-          <a:lstStyle/>
-          <a:p>
-            <a:pPr algn="l"/>
-            <a:r>
-              <a:rPr sz="3000" b="1">
+        <p:style>
+          <a:lnRef idx="1">
+            <a:schemeClr val="accent1"/>
+          </a:lnRef>
+          <a:fillRef idx="3">
+            <a:schemeClr val="accent1"/>
+          </a:fillRef>
+          <a:effectRef idx="2">
+            <a:schemeClr val="accent1"/>
+          </a:effectRef>
+          <a:fontRef idx="minor">
+            <a:schemeClr val="lt1"/>
+          </a:fontRef>
+        </p:style>
+        <p:txBody>
+          <a:bodyPr rtlCol="0" anchor="ctr" wrap="square" lIns="274320" rIns="274320" tIns="73152" bIns="73152"/>
+          <a:lstStyle/>
+          <a:p>
+            <a:pPr algn="ctr"/>
+            <a:r>
+              <a:rPr sz="2200" b="1">
                 <a:solidFill>
                   <a:srgbClr val="C2410C"/>
                 </a:solidFill>
               </a:rPr>
-              <a:t>Thank you – questions?</a:t>
+              <a:t>Why the name?</a:t>
+            </a:r>
+          </a:p>
+          <a:p>
+            <a:pPr algn="l">
+              <a:spcBef>
+                <a:spcPts val="1000"/>
+              </a:spcBef>
+            </a:pPr>
+            <a:r>
+              <a:rPr sz="1800" b="0">
+                <a:solidFill>
+                  <a:srgbClr val="0F172A"/>
+                </a:solidFill>
+              </a:rPr>
+              <a:t>â€œBuddyâ€ is the gym word for a training partner. People who train with a partner skip fewer sessions â€“ so the name says what the app is for: staying consistent, together.</a:t>
             </a:r>
           </a:p>
         </p:txBody>
@@ -5952,7 +5363,7 @@
 </p:sld>
 </file>
 
-<file path=ppt/slides/slide2.xml><?xml version="1.0" encoding="utf-8"?>
+<file path=ppt/slides/slide3.xml><?xml version="1.0" encoding="utf-8"?>
 <p:sld xmlns:a="http://schemas.openxmlformats.org/drawingml/2006/main" xmlns:p="http://schemas.openxmlformats.org/presentationml/2006/main" xmlns:r="http://schemas.openxmlformats.org/officeDocument/2006/relationships">
   <p:cSld>
     <p:spTree>
@@ -6009,7 +5420,7 @@
                   <a:srgbClr val="FFFFFF"/>
                 </a:solidFill>
               </a:rPr>
-              <a:t>What is GymBuddy?</a:t>
+              <a:t>The problem</a:t>
             </a:r>
           </a:p>
           <a:p>
@@ -6020,7 +5431,7 @@
                   <a:srgbClr val="FDBA74"/>
                 </a:solidFill>
               </a:rPr>
-              <a:t>An Android app backed by the cloud</a:t>
+              <a:t>One sentence: who has what problem, and why it matters</a:t>
             </a:r>
           </a:p>
         </p:txBody>
@@ -6071,167 +5482,20 @@
       </p:sp>
       <p:sp>
         <p:nvSpPr>
-          <p:cNvPr id="4" name="TextBox 3"/>
-          <p:cNvSpPr txBox="1"/>
+          <p:cNvPr id="4" name="Rounded Rectangle 3"/>
+          <p:cNvSpPr/>
           <p:nvPr/>
         </p:nvSpPr>
         <p:spPr>
           <a:xfrm>
-            <a:off x="640080" y="1554480"/>
-            <a:ext cx="6583680" cy="4572000"/>
-          </a:xfrm>
-          <a:prstGeom prst="rect">
-            <a:avLst/>
-          </a:prstGeom>
-          <a:noFill/>
-        </p:spPr>
-        <p:txBody>
-          <a:bodyPr wrap="square">
-            <a:spAutoFit/>
-          </a:bodyPr>
-          <a:lstStyle/>
-          <a:p>
-            <a:pPr algn="l">
-              <a:spcAft>
-                <a:spcPts val="1000"/>
-              </a:spcAft>
-            </a:pPr>
-            <a:r>
-              <a:rPr sz="2200" b="1">
-                <a:solidFill>
-                  <a:srgbClr val="F97316"/>
-                </a:solidFill>
-              </a:rPr>
-              <a:t>•  </a:t>
-            </a:r>
-            <a:r>
-              <a:rPr sz="2200" b="1">
-                <a:solidFill>
-                  <a:srgbClr val="0F172A"/>
-                </a:solidFill>
-              </a:rPr>
-              <a:t>Gym + Buddy:</a:t>
-            </a:r>
-            <a:r>
-              <a:rPr sz="2200" b="0">
-                <a:solidFill>
-                  <a:srgbClr val="64748B"/>
-                </a:solidFill>
-              </a:rPr>
-              <a:t> your workout log and your training partner finder in one app.</a:t>
-            </a:r>
-          </a:p>
-          <a:p>
-            <a:pPr algn="l">
-              <a:spcAft>
-                <a:spcPts val="1000"/>
-              </a:spcAft>
-            </a:pPr>
-            <a:r>
-              <a:rPr sz="2200" b="1">
-                <a:solidFill>
-                  <a:srgbClr val="F97316"/>
-                </a:solidFill>
-              </a:rPr>
-              <a:t>•  </a:t>
-            </a:r>
-            <a:r>
-              <a:rPr sz="2200" b="1">
-                <a:solidFill>
-                  <a:srgbClr val="0F172A"/>
-                </a:solidFill>
-              </a:rPr>
-              <a:t>Log:</a:t>
-            </a:r>
-            <a:r>
-              <a:rPr sz="2200" b="0">
-                <a:solidFill>
-                  <a:srgbClr val="64748B"/>
-                </a:solidFill>
-              </a:rPr>
-              <a:t> record each workout (type, duration, notes) and see your history and weekly progress.</a:t>
-            </a:r>
-          </a:p>
-          <a:p>
-            <a:pPr algn="l">
-              <a:spcAft>
-                <a:spcPts val="1000"/>
-              </a:spcAft>
-            </a:pPr>
-            <a:r>
-              <a:rPr sz="2200" b="1">
-                <a:solidFill>
-                  <a:srgbClr val="F97316"/>
-                </a:solidFill>
-              </a:rPr>
-              <a:t>•  </a:t>
-            </a:r>
-            <a:r>
-              <a:rPr sz="2200" b="1">
-                <a:solidFill>
-                  <a:srgbClr val="0F172A"/>
-                </a:solidFill>
-              </a:rPr>
-              <a:t>Find:</a:t>
-            </a:r>
-            <a:r>
-              <a:rPr sz="2200" b="0">
-                <a:solidFill>
-                  <a:srgbClr val="64748B"/>
-                </a:solidFill>
-              </a:rPr>
-              <a:t> post or join open training sessions, so you never have to train alone.</a:t>
-            </a:r>
-          </a:p>
-          <a:p>
-            <a:pPr algn="l">
-              <a:spcAft>
-                <a:spcPts val="1000"/>
-              </a:spcAft>
-            </a:pPr>
-            <a:r>
-              <a:rPr sz="2200" b="1">
-                <a:solidFill>
-                  <a:srgbClr val="F97316"/>
-                </a:solidFill>
-              </a:rPr>
-              <a:t>•  </a:t>
-            </a:r>
-            <a:r>
-              <a:rPr sz="2200" b="1">
-                <a:solidFill>
-                  <a:srgbClr val="0F172A"/>
-                </a:solidFill>
-              </a:rPr>
-              <a:t>Cloud:</a:t>
-            </a:r>
-            <a:r>
-              <a:rPr sz="2200" b="0">
-                <a:solidFill>
-                  <a:srgbClr val="64748B"/>
-                </a:solidFill>
-              </a:rPr>
-              <a:t> everything is stored in Firebase, so your data follows you to any phone.</a:t>
-            </a:r>
-          </a:p>
-        </p:txBody>
-      </p:sp>
-      <p:sp>
-        <p:nvSpPr>
-          <p:cNvPr id="5" name="Rounded Rectangle 4"/>
-          <p:cNvSpPr/>
-          <p:nvPr/>
-        </p:nvSpPr>
-        <p:spPr>
-          <a:xfrm>
-            <a:off x="7589520" y="1737360"/>
-            <a:ext cx="4023360" cy="4206240"/>
+            <a:off x="640080" y="1645920"/>
+            <a:ext cx="10881360" cy="1371600"/>
           </a:xfrm>
           <a:prstGeom prst="roundRect">
             <a:avLst/>
           </a:prstGeom>
           <a:solidFill>
-            <a:srgbClr val="F1F5F9"/>
+            <a:srgbClr val="F97316"/>
           </a:solidFill>
           <a:ln>
             <a:noFill/>
@@ -6253,32 +5517,133 @@
           </a:fontRef>
         </p:style>
         <p:txBody>
-          <a:bodyPr rtlCol="0" anchor="ctr" wrap="square" lIns="274320" rIns="274320" tIns="73152" bIns="73152"/>
+          <a:bodyPr rtlCol="0" anchor="ctr" wrap="square" lIns="365760" rIns="365760" tIns="73152" bIns="73152"/>
           <a:lstStyle/>
           <a:p>
             <a:pPr algn="ctr"/>
             <a:r>
+              <a:rPr sz="2400" b="1">
+                <a:solidFill>
+                  <a:srgbClr val="FFFFFF"/>
+                </a:solidFill>
+              </a:rPr>
+              <a:t>â€œGym-goers forget what they trained and struggle to find training partners, so progress stalls and motivation drops.â€</a:t>
+            </a:r>
+          </a:p>
+        </p:txBody>
+      </p:sp>
+      <p:sp>
+        <p:nvSpPr>
+          <p:cNvPr id="5" name="TextBox 4"/>
+          <p:cNvSpPr txBox="1"/>
+          <p:nvPr/>
+        </p:nvSpPr>
+        <p:spPr>
+          <a:xfrm>
+            <a:off x="640080" y="3383280"/>
+            <a:ext cx="10881360" cy="2743200"/>
+          </a:xfrm>
+          <a:prstGeom prst="rect">
+            <a:avLst/>
+          </a:prstGeom>
+          <a:noFill/>
+        </p:spPr>
+        <p:txBody>
+          <a:bodyPr wrap="square">
+            <a:spAutoFit/>
+          </a:bodyPr>
+          <a:lstStyle/>
+          <a:p>
+            <a:pPr algn="l">
+              <a:spcAft>
+                <a:spcPts val="1000"/>
+              </a:spcAft>
+            </a:pPr>
+            <a:r>
               <a:rPr sz="2200" b="1">
                 <a:solidFill>
-                  <a:srgbClr val="C2410C"/>
-                </a:solidFill>
-              </a:rPr>
-              <a:t>Why the name?</a:t>
+                  <a:srgbClr val="F97316"/>
+                </a:solidFill>
+              </a:rPr>
+              <a:t>â€¢  </a:t>
+            </a:r>
+            <a:r>
+              <a:rPr sz="2200" b="1">
+                <a:solidFill>
+                  <a:srgbClr val="0F172A"/>
+                </a:solidFill>
+              </a:rPr>
+              <a:t>Today:</a:t>
+            </a:r>
+            <a:r>
+              <a:rPr sz="2200" b="0">
+                <a:solidFill>
+                  <a:srgbClr val="64748B"/>
+                </a:solidFill>
+              </a:rPr>
+              <a:t> workouts live in notes apps, memory or nowhere; partners are found by chance.</a:t>
             </a:r>
           </a:p>
           <a:p>
             <a:pPr algn="l">
-              <a:spcBef>
+              <a:spcAft>
                 <a:spcPts val="1000"/>
-              </a:spcBef>
+              </a:spcAft>
             </a:pPr>
             <a:r>
-              <a:rPr sz="1800" b="0">
+              <a:rPr sz="2200" b="1">
+                <a:solidFill>
+                  <a:srgbClr val="F97316"/>
+                </a:solidFill>
+              </a:rPr>
+              <a:t>â€¢  </a:t>
+            </a:r>
+            <a:r>
+              <a:rPr sz="2200" b="1">
                 <a:solidFill>
                   <a:srgbClr val="0F172A"/>
                 </a:solidFill>
               </a:rPr>
-              <a:t>“Buddy” is the gym word for a training partner. People who train with a partner skip fewer sessions – so the name says what the app is for: staying consistent, together.</a:t>
+              <a:t>Impact:</a:t>
+            </a:r>
+            <a:r>
+              <a:rPr sz="2200" b="0">
+                <a:solidFill>
+                  <a:srgbClr val="64748B"/>
+                </a:solidFill>
+              </a:rPr>
+              <a:t> no visible progress and no accountability lead to people quitting.</a:t>
+            </a:r>
+          </a:p>
+          <a:p>
+            <a:pPr algn="l">
+              <a:spcAft>
+                <a:spcPts val="1000"/>
+              </a:spcAft>
+            </a:pPr>
+            <a:r>
+              <a:rPr sz="2200" b="1">
+                <a:solidFill>
+                  <a:srgbClr val="F97316"/>
+                </a:solidFill>
+              </a:rPr>
+              <a:t>â€¢  </a:t>
+            </a:r>
+            <a:r>
+              <a:rPr sz="2200" b="1">
+                <a:solidFill>
+                  <a:srgbClr val="0F172A"/>
+                </a:solidFill>
+              </a:rPr>
+              <a:t>Our answer:</a:t>
+            </a:r>
+            <a:r>
+              <a:rPr sz="2200" b="0">
+                <a:solidFill>
+                  <a:srgbClr val="64748B"/>
+                </a:solidFill>
+              </a:rPr>
+              <a:t> a simple cloud log plus a place to arrange sessions with others.</a:t>
             </a:r>
           </a:p>
         </p:txBody>
@@ -6291,7 +5656,7 @@
 </p:sld>
 </file>
 
-<file path=ppt/slides/slide3.xml><?xml version="1.0" encoding="utf-8"?>
+<file path=ppt/slides/slide4.xml><?xml version="1.0" encoding="utf-8"?>
 <p:sld xmlns:a="http://schemas.openxmlformats.org/drawingml/2006/main" xmlns:p="http://schemas.openxmlformats.org/presentationml/2006/main" xmlns:r="http://schemas.openxmlformats.org/officeDocument/2006/relationships">
   <p:cSld>
     <p:spTree>
@@ -6348,7 +5713,7 @@
                   <a:srgbClr val="FFFFFF"/>
                 </a:solidFill>
               </a:rPr>
-              <a:t>Where GymBuddy can be used</a:t>
+              <a:t>MVP features</a:t>
             </a:r>
           </a:p>
           <a:p>
@@ -6359,793 +5724,7 @@
                   <a:srgbClr val="FDBA74"/>
                 </a:solidFill>
               </a:rPr>
-              <a:t>The same app helps different groups</a:t>
-            </a:r>
-          </a:p>
-        </p:txBody>
-      </p:sp>
-      <p:sp>
-        <p:nvSpPr>
-          <p:cNvPr id="3" name="Rectangle 2"/>
-          <p:cNvSpPr/>
-          <p:nvPr/>
-        </p:nvSpPr>
-        <p:spPr>
-          <a:xfrm>
-            <a:off x="0" y="1097280"/>
-            <a:ext cx="12191695" cy="64008"/>
-          </a:xfrm>
-          <a:prstGeom prst="rect">
-            <a:avLst/>
-          </a:prstGeom>
-          <a:solidFill>
-            <a:srgbClr val="F97316"/>
-          </a:solidFill>
-          <a:ln>
-            <a:noFill/>
-          </a:ln>
-          <a:effectLst/>
-        </p:spPr>
-        <p:style>
-          <a:lnRef idx="1">
-            <a:schemeClr val="accent1"/>
-          </a:lnRef>
-          <a:fillRef idx="3">
-            <a:schemeClr val="accent1"/>
-          </a:fillRef>
-          <a:effectRef idx="2">
-            <a:schemeClr val="accent1"/>
-          </a:effectRef>
-          <a:fontRef idx="minor">
-            <a:schemeClr val="lt1"/>
-          </a:fontRef>
-        </p:style>
-        <p:txBody>
-          <a:bodyPr rtlCol="0" anchor="ctr"/>
-          <a:lstStyle/>
-          <a:p>
-            <a:pPr algn="ctr"/>
-          </a:p>
-        </p:txBody>
-      </p:sp>
-      <p:graphicFrame>
-        <p:nvGraphicFramePr>
-          <p:cNvPr id="4" name="Table 3"/>
-          <p:cNvGraphicFramePr>
-            <a:graphicFrameLocks noGrp="1"/>
-          </p:cNvGraphicFramePr>
-          <p:nvPr/>
-        </p:nvGraphicFramePr>
-        <p:xfrm>
-          <a:off x="640080" y="1645920"/>
-          <a:ext cx="10881360" cy="3968496"/>
-        </p:xfrm>
-        <a:graphic>
-          <a:graphicData uri="http://schemas.openxmlformats.org/drawingml/2006/table">
-            <a:tbl>
-              <a:tblPr firstRow="1" bandRow="1">
-                <a:tableStyleId>{5C22544A-7EE6-4342-B048-85BDC9FD1C3A}</a:tableStyleId>
-              </a:tblPr>
-              <a:tblGrid>
-                <a:gridCol w="4023360"/>
-                <a:gridCol w="6858000"/>
-              </a:tblGrid>
-              <a:tr h="566928">
-                <a:tc>
-                  <a:txBody>
-                    <a:bodyPr/>
-                    <a:lstStyle/>
-                    <a:p>
-                      <a:r>
-                        <a:rPr sz="1800" b="1">
-                          <a:solidFill>
-                            <a:srgbClr val="FFFFFF"/>
-                          </a:solidFill>
-                        </a:rPr>
-                        <a:t>Who</a:t>
-                      </a:r>
-                    </a:p>
-                  </a:txBody>
-                  <a:tcPr>
-                    <a:solidFill>
-                      <a:srgbClr val="111827"/>
-                    </a:solidFill>
-                  </a:tcPr>
-                </a:tc>
-                <a:tc>
-                  <a:txBody>
-                    <a:bodyPr/>
-                    <a:lstStyle/>
-                    <a:p>
-                      <a:r>
-                        <a:rPr sz="1800" b="1">
-                          <a:solidFill>
-                            <a:srgbClr val="FFFFFF"/>
-                          </a:solidFill>
-                        </a:rPr>
-                        <a:t>How GymBuddy helps</a:t>
-                      </a:r>
-                    </a:p>
-                  </a:txBody>
-                  <a:tcPr>
-                    <a:solidFill>
-                      <a:srgbClr val="111827"/>
-                    </a:solidFill>
-                  </a:tcPr>
-                </a:tc>
-              </a:tr>
-              <a:tr h="566928">
-                <a:tc>
-                  <a:txBody>
-                    <a:bodyPr/>
-                    <a:lstStyle/>
-                    <a:p>
-                      <a:r>
-                        <a:rPr sz="1800" b="0">
-                          <a:solidFill>
-                            <a:srgbClr val="0F172A"/>
-                          </a:solidFill>
-                        </a:rPr>
-                        <a:t>Individual gym-goers</a:t>
-                      </a:r>
-                    </a:p>
-                  </a:txBody>
-                  <a:tcPr>
-                    <a:solidFill>
-                      <a:srgbClr val="F1F5F9"/>
-                    </a:solidFill>
-                  </a:tcPr>
-                </a:tc>
-                <a:tc>
-                  <a:txBody>
-                    <a:bodyPr/>
-                    <a:lstStyle/>
-                    <a:p>
-                      <a:r>
-                        <a:rPr sz="1800" b="0">
-                          <a:solidFill>
-                            <a:srgbClr val="0F172A"/>
-                          </a:solidFill>
-                        </a:rPr>
-                        <a:t>Keep a simple training history and see weekly progress</a:t>
-                      </a:r>
-                    </a:p>
-                  </a:txBody>
-                  <a:tcPr>
-                    <a:solidFill>
-                      <a:srgbClr val="F1F5F9"/>
-                    </a:solidFill>
-                  </a:tcPr>
-                </a:tc>
-              </a:tr>
-              <a:tr h="566928">
-                <a:tc>
-                  <a:txBody>
-                    <a:bodyPr/>
-                    <a:lstStyle/>
-                    <a:p>
-                      <a:r>
-                        <a:rPr sz="1800" b="0">
-                          <a:solidFill>
-                            <a:srgbClr val="0F172A"/>
-                          </a:solidFill>
-                        </a:rPr>
-                        <a:t>Friends and training groups</a:t>
-                      </a:r>
-                    </a:p>
-                  </a:txBody>
-                  <a:tcPr>
-                    <a:solidFill>
-                      <a:srgbClr val="FFFFFF"/>
-                    </a:solidFill>
-                  </a:tcPr>
-                </a:tc>
-                <a:tc>
-                  <a:txBody>
-                    <a:bodyPr/>
-                    <a:lstStyle/>
-                    <a:p>
-                      <a:r>
-                        <a:rPr sz="1800" b="0">
-                          <a:solidFill>
-                            <a:srgbClr val="0F172A"/>
-                          </a:solidFill>
-                        </a:rPr>
-                        <a:t>Plan shared sessions and see who joined</a:t>
-                      </a:r>
-                    </a:p>
-                  </a:txBody>
-                  <a:tcPr>
-                    <a:solidFill>
-                      <a:srgbClr val="FFFFFF"/>
-                    </a:solidFill>
-                  </a:tcPr>
-                </a:tc>
-              </a:tr>
-              <a:tr h="566928">
-                <a:tc>
-                  <a:txBody>
-                    <a:bodyPr/>
-                    <a:lstStyle/>
-                    <a:p>
-                      <a:r>
-                        <a:rPr sz="1800" b="0">
-                          <a:solidFill>
-                            <a:srgbClr val="0F172A"/>
-                          </a:solidFill>
-                        </a:rPr>
-                        <a:t>Newcomers to a gym</a:t>
-                      </a:r>
-                    </a:p>
-                  </a:txBody>
-                  <a:tcPr>
-                    <a:solidFill>
-                      <a:srgbClr val="F1F5F9"/>
-                    </a:solidFill>
-                  </a:tcPr>
-                </a:tc>
-                <a:tc>
-                  <a:txBody>
-                    <a:bodyPr/>
-                    <a:lstStyle/>
-                    <a:p>
-                      <a:r>
-                        <a:rPr sz="1800" b="0">
-                          <a:solidFill>
-                            <a:srgbClr val="0F172A"/>
-                          </a:solidFill>
-                        </a:rPr>
-                        <a:t>Find a partner instead of training alone</a:t>
-                      </a:r>
-                    </a:p>
-                  </a:txBody>
-                  <a:tcPr>
-                    <a:solidFill>
-                      <a:srgbClr val="F1F5F9"/>
-                    </a:solidFill>
-                  </a:tcPr>
-                </a:tc>
-              </a:tr>
-              <a:tr h="566928">
-                <a:tc>
-                  <a:txBody>
-                    <a:bodyPr/>
-                    <a:lstStyle/>
-                    <a:p>
-                      <a:r>
-                        <a:rPr sz="1800" b="0">
-                          <a:solidFill>
-                            <a:srgbClr val="0F172A"/>
-                          </a:solidFill>
-                        </a:rPr>
-                        <a:t>University sports clubs</a:t>
-                      </a:r>
-                    </a:p>
-                  </a:txBody>
-                  <a:tcPr>
-                    <a:solidFill>
-                      <a:srgbClr val="FFFFFF"/>
-                    </a:solidFill>
-                  </a:tcPr>
-                </a:tc>
-                <a:tc>
-                  <a:txBody>
-                    <a:bodyPr/>
-                    <a:lstStyle/>
-                    <a:p>
-                      <a:r>
-                        <a:rPr sz="1800" b="0">
-                          <a:solidFill>
-                            <a:srgbClr val="0F172A"/>
-                          </a:solidFill>
-                        </a:rPr>
-                        <a:t>Organise open sessions for students and staff</a:t>
-                      </a:r>
-                    </a:p>
-                  </a:txBody>
-                  <a:tcPr>
-                    <a:solidFill>
-                      <a:srgbClr val="FFFFFF"/>
-                    </a:solidFill>
-                  </a:tcPr>
-                </a:tc>
-              </a:tr>
-              <a:tr h="566928">
-                <a:tc>
-                  <a:txBody>
-                    <a:bodyPr/>
-                    <a:lstStyle/>
-                    <a:p>
-                      <a:r>
-                        <a:rPr sz="1800" b="0">
-                          <a:solidFill>
-                            <a:srgbClr val="0F172A"/>
-                          </a:solidFill>
-                        </a:rPr>
-                        <a:t>Workplace wellness programmes</a:t>
-                      </a:r>
-                    </a:p>
-                  </a:txBody>
-                  <a:tcPr>
-                    <a:solidFill>
-                      <a:srgbClr val="F1F5F9"/>
-                    </a:solidFill>
-                  </a:tcPr>
-                </a:tc>
-                <a:tc>
-                  <a:txBody>
-                    <a:bodyPr/>
-                    <a:lstStyle/>
-                    <a:p>
-                      <a:r>
-                        <a:rPr sz="1800" b="0">
-                          <a:solidFill>
-                            <a:srgbClr val="0F172A"/>
-                          </a:solidFill>
-                        </a:rPr>
-                        <a:t>Let colleagues arrange group workouts</a:t>
-                      </a:r>
-                    </a:p>
-                  </a:txBody>
-                  <a:tcPr>
-                    <a:solidFill>
-                      <a:srgbClr val="F1F5F9"/>
-                    </a:solidFill>
-                  </a:tcPr>
-                </a:tc>
-              </a:tr>
-              <a:tr h="566928">
-                <a:tc>
-                  <a:txBody>
-                    <a:bodyPr/>
-                    <a:lstStyle/>
-                    <a:p>
-                      <a:r>
-                        <a:rPr sz="1800" b="0">
-                          <a:solidFill>
-                            <a:srgbClr val="0F172A"/>
-                          </a:solidFill>
-                        </a:rPr>
-                        <a:t>Small gyms and fitness studios</a:t>
-                      </a:r>
-                    </a:p>
-                  </a:txBody>
-                  <a:tcPr>
-                    <a:solidFill>
-                      <a:srgbClr val="FFFFFF"/>
-                    </a:solidFill>
-                  </a:tcPr>
-                </a:tc>
-                <a:tc>
-                  <a:txBody>
-                    <a:bodyPr/>
-                    <a:lstStyle/>
-                    <a:p>
-                      <a:r>
-                        <a:rPr sz="1800" b="0">
-                          <a:solidFill>
-                            <a:srgbClr val="0F172A"/>
-                          </a:solidFill>
-                        </a:rPr>
-                        <a:t>Give members a free way to meet training partners</a:t>
-                      </a:r>
-                    </a:p>
-                  </a:txBody>
-                  <a:tcPr>
-                    <a:solidFill>
-                      <a:srgbClr val="FFFFFF"/>
-                    </a:solidFill>
-                  </a:tcPr>
-                </a:tc>
-              </a:tr>
-            </a:tbl>
-          </a:graphicData>
-        </a:graphic>
-      </p:graphicFrame>
-      <p:sp>
-        <p:nvSpPr>
-          <p:cNvPr id="5" name="TextBox 4"/>
-          <p:cNvSpPr txBox="1"/>
-          <p:nvPr/>
-        </p:nvSpPr>
-        <p:spPr>
-          <a:xfrm>
-            <a:off x="640080" y="5806440"/>
-            <a:ext cx="10881360" cy="731520"/>
-          </a:xfrm>
-          <a:prstGeom prst="rect">
-            <a:avLst/>
-          </a:prstGeom>
-          <a:noFill/>
-        </p:spPr>
-        <p:txBody>
-          <a:bodyPr wrap="square">
-            <a:spAutoFit/>
-          </a:bodyPr>
-          <a:lstStyle/>
-          <a:p>
-            <a:pPr algn="l"/>
-            <a:r>
-              <a:rPr sz="1600" b="0">
-                <a:solidFill>
-                  <a:srgbClr val="64748B"/>
-                </a:solidFill>
-              </a:rPr>
-              <a:t>People who track their training see progress, and people who train with a partner skip fewer sessions.</a:t>
-            </a:r>
-          </a:p>
-        </p:txBody>
-      </p:sp>
-    </p:spTree>
-  </p:cSld>
-  <p:clrMapOvr>
-    <a:masterClrMapping/>
-  </p:clrMapOvr>
-</p:sld>
-</file>
-
-<file path=ppt/slides/slide4.xml><?xml version="1.0" encoding="utf-8"?>
-<p:sld xmlns:a="http://schemas.openxmlformats.org/drawingml/2006/main" xmlns:p="http://schemas.openxmlformats.org/presentationml/2006/main" xmlns:r="http://schemas.openxmlformats.org/officeDocument/2006/relationships">
-  <p:cSld>
-    <p:spTree>
-      <p:nvGrpSpPr>
-        <p:cNvPr id="1" name=""/>
-        <p:cNvGrpSpPr/>
-        <p:nvPr/>
-      </p:nvGrpSpPr>
-      <p:grpSpPr/>
-      <p:sp>
-        <p:nvSpPr>
-          <p:cNvPr id="2" name="Rectangle 1"/>
-          <p:cNvSpPr/>
-          <p:nvPr/>
-        </p:nvSpPr>
-        <p:spPr>
-          <a:xfrm>
-            <a:off x="0" y="0"/>
-            <a:ext cx="12191695" cy="1097280"/>
-          </a:xfrm>
-          <a:prstGeom prst="rect">
-            <a:avLst/>
-          </a:prstGeom>
-          <a:solidFill>
-            <a:srgbClr val="111827"/>
-          </a:solidFill>
-          <a:ln>
-            <a:noFill/>
-          </a:ln>
-          <a:effectLst/>
-        </p:spPr>
-        <p:style>
-          <a:lnRef idx="1">
-            <a:schemeClr val="accent1"/>
-          </a:lnRef>
-          <a:fillRef idx="3">
-            <a:schemeClr val="accent1"/>
-          </a:fillRef>
-          <a:effectRef idx="2">
-            <a:schemeClr val="accent1"/>
-          </a:effectRef>
-          <a:fontRef idx="minor">
-            <a:schemeClr val="lt1"/>
-          </a:fontRef>
-        </p:style>
-        <p:txBody>
-          <a:bodyPr rtlCol="0" anchor="ctr" wrap="square" lIns="457200" rIns="457200" tIns="73152" bIns="73152"/>
-          <a:lstStyle/>
-          <a:p>
-            <a:pPr algn="ctr"/>
-            <a:r>
-              <a:rPr sz="3200" b="1">
-                <a:solidFill>
-                  <a:srgbClr val="FFFFFF"/>
-                </a:solidFill>
-              </a:rPr>
-              <a:t>The problem</a:t>
-            </a:r>
-          </a:p>
-          <a:p>
-            <a:pPr algn="l"/>
-            <a:r>
-              <a:rPr sz="1500" b="0">
-                <a:solidFill>
-                  <a:srgbClr val="FDBA74"/>
-                </a:solidFill>
-              </a:rPr>
-              <a:t>One sentence: who has what problem, and why it matters</a:t>
-            </a:r>
-          </a:p>
-        </p:txBody>
-      </p:sp>
-      <p:sp>
-        <p:nvSpPr>
-          <p:cNvPr id="3" name="Rectangle 2"/>
-          <p:cNvSpPr/>
-          <p:nvPr/>
-        </p:nvSpPr>
-        <p:spPr>
-          <a:xfrm>
-            <a:off x="0" y="1097280"/>
-            <a:ext cx="12191695" cy="64008"/>
-          </a:xfrm>
-          <a:prstGeom prst="rect">
-            <a:avLst/>
-          </a:prstGeom>
-          <a:solidFill>
-            <a:srgbClr val="F97316"/>
-          </a:solidFill>
-          <a:ln>
-            <a:noFill/>
-          </a:ln>
-          <a:effectLst/>
-        </p:spPr>
-        <p:style>
-          <a:lnRef idx="1">
-            <a:schemeClr val="accent1"/>
-          </a:lnRef>
-          <a:fillRef idx="3">
-            <a:schemeClr val="accent1"/>
-          </a:fillRef>
-          <a:effectRef idx="2">
-            <a:schemeClr val="accent1"/>
-          </a:effectRef>
-          <a:fontRef idx="minor">
-            <a:schemeClr val="lt1"/>
-          </a:fontRef>
-        </p:style>
-        <p:txBody>
-          <a:bodyPr rtlCol="0" anchor="ctr"/>
-          <a:lstStyle/>
-          <a:p>
-            <a:pPr algn="ctr"/>
-          </a:p>
-        </p:txBody>
-      </p:sp>
-      <p:sp>
-        <p:nvSpPr>
-          <p:cNvPr id="4" name="Rounded Rectangle 3"/>
-          <p:cNvSpPr/>
-          <p:nvPr/>
-        </p:nvSpPr>
-        <p:spPr>
-          <a:xfrm>
-            <a:off x="640080" y="1645920"/>
-            <a:ext cx="10881360" cy="1371600"/>
-          </a:xfrm>
-          <a:prstGeom prst="roundRect">
-            <a:avLst/>
-          </a:prstGeom>
-          <a:solidFill>
-            <a:srgbClr val="F97316"/>
-          </a:solidFill>
-          <a:ln>
-            <a:noFill/>
-          </a:ln>
-          <a:effectLst/>
-        </p:spPr>
-        <p:style>
-          <a:lnRef idx="1">
-            <a:schemeClr val="accent1"/>
-          </a:lnRef>
-          <a:fillRef idx="3">
-            <a:schemeClr val="accent1"/>
-          </a:fillRef>
-          <a:effectRef idx="2">
-            <a:schemeClr val="accent1"/>
-          </a:effectRef>
-          <a:fontRef idx="minor">
-            <a:schemeClr val="lt1"/>
-          </a:fontRef>
-        </p:style>
-        <p:txBody>
-          <a:bodyPr rtlCol="0" anchor="ctr" wrap="square" lIns="365760" rIns="365760" tIns="73152" bIns="73152"/>
-          <a:lstStyle/>
-          <a:p>
-            <a:pPr algn="ctr"/>
-            <a:r>
-              <a:rPr sz="2400" b="1">
-                <a:solidFill>
-                  <a:srgbClr val="FFFFFF"/>
-                </a:solidFill>
-              </a:rPr>
-              <a:t>“Gym-goers forget what they trained and struggle to find training partners, so progress stalls and motivation drops.”</a:t>
-            </a:r>
-          </a:p>
-        </p:txBody>
-      </p:sp>
-      <p:sp>
-        <p:nvSpPr>
-          <p:cNvPr id="5" name="TextBox 4"/>
-          <p:cNvSpPr txBox="1"/>
-          <p:nvPr/>
-        </p:nvSpPr>
-        <p:spPr>
-          <a:xfrm>
-            <a:off x="640080" y="3383280"/>
-            <a:ext cx="10881360" cy="2743200"/>
-          </a:xfrm>
-          <a:prstGeom prst="rect">
-            <a:avLst/>
-          </a:prstGeom>
-          <a:noFill/>
-        </p:spPr>
-        <p:txBody>
-          <a:bodyPr wrap="square">
-            <a:spAutoFit/>
-          </a:bodyPr>
-          <a:lstStyle/>
-          <a:p>
-            <a:pPr algn="l">
-              <a:spcAft>
-                <a:spcPts val="1000"/>
-              </a:spcAft>
-            </a:pPr>
-            <a:r>
-              <a:rPr sz="2200" b="1">
-                <a:solidFill>
-                  <a:srgbClr val="F97316"/>
-                </a:solidFill>
-              </a:rPr>
-              <a:t>•  </a:t>
-            </a:r>
-            <a:r>
-              <a:rPr sz="2200" b="1">
-                <a:solidFill>
-                  <a:srgbClr val="0F172A"/>
-                </a:solidFill>
-              </a:rPr>
-              <a:t>Today:</a:t>
-            </a:r>
-            <a:r>
-              <a:rPr sz="2200" b="0">
-                <a:solidFill>
-                  <a:srgbClr val="64748B"/>
-                </a:solidFill>
-              </a:rPr>
-              <a:t> workouts live in notes apps, memory or nowhere; partners are found by chance.</a:t>
-            </a:r>
-          </a:p>
-          <a:p>
-            <a:pPr algn="l">
-              <a:spcAft>
-                <a:spcPts val="1000"/>
-              </a:spcAft>
-            </a:pPr>
-            <a:r>
-              <a:rPr sz="2200" b="1">
-                <a:solidFill>
-                  <a:srgbClr val="F97316"/>
-                </a:solidFill>
-              </a:rPr>
-              <a:t>•  </a:t>
-            </a:r>
-            <a:r>
-              <a:rPr sz="2200" b="1">
-                <a:solidFill>
-                  <a:srgbClr val="0F172A"/>
-                </a:solidFill>
-              </a:rPr>
-              <a:t>Impact:</a:t>
-            </a:r>
-            <a:r>
-              <a:rPr sz="2200" b="0">
-                <a:solidFill>
-                  <a:srgbClr val="64748B"/>
-                </a:solidFill>
-              </a:rPr>
-              <a:t> no visible progress and no accountability lead to people quitting.</a:t>
-            </a:r>
-          </a:p>
-          <a:p>
-            <a:pPr algn="l">
-              <a:spcAft>
-                <a:spcPts val="1000"/>
-              </a:spcAft>
-            </a:pPr>
-            <a:r>
-              <a:rPr sz="2200" b="1">
-                <a:solidFill>
-                  <a:srgbClr val="F97316"/>
-                </a:solidFill>
-              </a:rPr>
-              <a:t>•  </a:t>
-            </a:r>
-            <a:r>
-              <a:rPr sz="2200" b="1">
-                <a:solidFill>
-                  <a:srgbClr val="0F172A"/>
-                </a:solidFill>
-              </a:rPr>
-              <a:t>Our answer:</a:t>
-            </a:r>
-            <a:r>
-              <a:rPr sz="2200" b="0">
-                <a:solidFill>
-                  <a:srgbClr val="64748B"/>
-                </a:solidFill>
-              </a:rPr>
-              <a:t> a simple cloud log plus a place to arrange sessions with others.</a:t>
-            </a:r>
-          </a:p>
-        </p:txBody>
-      </p:sp>
-    </p:spTree>
-  </p:cSld>
-  <p:clrMapOvr>
-    <a:masterClrMapping/>
-  </p:clrMapOvr>
-</p:sld>
-</file>
-
-<file path=ppt/slides/slide5.xml><?xml version="1.0" encoding="utf-8"?>
-<p:sld xmlns:a="http://schemas.openxmlformats.org/drawingml/2006/main" xmlns:p="http://schemas.openxmlformats.org/presentationml/2006/main" xmlns:r="http://schemas.openxmlformats.org/officeDocument/2006/relationships">
-  <p:cSld>
-    <p:spTree>
-      <p:nvGrpSpPr>
-        <p:cNvPr id="1" name=""/>
-        <p:cNvGrpSpPr/>
-        <p:nvPr/>
-      </p:nvGrpSpPr>
-      <p:grpSpPr/>
-      <p:sp>
-        <p:nvSpPr>
-          <p:cNvPr id="2" name="Rectangle 1"/>
-          <p:cNvSpPr/>
-          <p:nvPr/>
-        </p:nvSpPr>
-        <p:spPr>
-          <a:xfrm>
-            <a:off x="0" y="0"/>
-            <a:ext cx="12191695" cy="1097280"/>
-          </a:xfrm>
-          <a:prstGeom prst="rect">
-            <a:avLst/>
-          </a:prstGeom>
-          <a:solidFill>
-            <a:srgbClr val="111827"/>
-          </a:solidFill>
-          <a:ln>
-            <a:noFill/>
-          </a:ln>
-          <a:effectLst/>
-        </p:spPr>
-        <p:style>
-          <a:lnRef idx="1">
-            <a:schemeClr val="accent1"/>
-          </a:lnRef>
-          <a:fillRef idx="3">
-            <a:schemeClr val="accent1"/>
-          </a:fillRef>
-          <a:effectRef idx="2">
-            <a:schemeClr val="accent1"/>
-          </a:effectRef>
-          <a:fontRef idx="minor">
-            <a:schemeClr val="lt1"/>
-          </a:fontRef>
-        </p:style>
-        <p:txBody>
-          <a:bodyPr rtlCol="0" anchor="ctr" wrap="square" lIns="457200" rIns="457200" tIns="73152" bIns="73152"/>
-          <a:lstStyle/>
-          <a:p>
-            <a:pPr algn="ctr"/>
-            <a:r>
-              <a:rPr sz="3200" b="1">
-                <a:solidFill>
-                  <a:srgbClr val="FFFFFF"/>
-                </a:solidFill>
-              </a:rPr>
-              <a:t>MVP features</a:t>
-            </a:r>
-          </a:p>
-          <a:p>
-            <a:pPr algn="l"/>
-            <a:r>
-              <a:rPr sz="1500" b="0">
-                <a:solidFill>
-                  <a:srgbClr val="FDBA74"/>
-                </a:solidFill>
-              </a:rPr>
-              <a:t>Sprint 1 = Labs 1–2, the rest is planned for later</a:t>
+              <a:t>Sprint 1 = Labs 1â€“2, the rest is planned for later</a:t>
             </a:r>
           </a:p>
         </p:txBody>
@@ -7653,7 +6232,7 @@
 </p:sld>
 </file>
 
-<file path=ppt/slides/slide6.xml><?xml version="1.0" encoding="utf-8"?>
+<file path=ppt/slides/slide5.xml><?xml version="1.0" encoding="utf-8"?>
 <p:sld xmlns:a="http://schemas.openxmlformats.org/drawingml/2006/main" xmlns:p="http://schemas.openxmlformats.org/presentationml/2006/main" xmlns:r="http://schemas.openxmlformats.org/officeDocument/2006/relationships">
   <p:cSld>
     <p:spTree>
@@ -7721,7 +6300,7 @@
                   <a:srgbClr val="FDBA74"/>
                 </a:solidFill>
               </a:rPr>
-              <a:t>5 screens: Login · Register · Workouts · Workout detail/edit · Partners</a:t>
+              <a:t>5 screens: Login Â· Register Â· Workouts Â· Workout detail/edit Â· Partners</a:t>
             </a:r>
           </a:p>
         </p:txBody>
@@ -7823,7 +6402,7 @@
                   <a:srgbClr val="64748B"/>
                 </a:solidFill>
               </a:rPr>
-              <a:t>Concept mockups. Login, Register and a temporary Home are built in Lab 1; the rest follow in Labs 2–3.</a:t>
+              <a:t>Concept mockups. Login, Register and a temporary Home are built in Lab 1; the rest follow in Labs 2â€“3.</a:t>
             </a:r>
           </a:p>
         </p:txBody>
@@ -7836,7 +6415,7 @@
 </p:sld>
 </file>
 
-<file path=ppt/slides/slide7.xml><?xml version="1.0" encoding="utf-8"?>
+<file path=ppt/slides/slide6.xml><?xml version="1.0" encoding="utf-8"?>
 <p:sld xmlns:a="http://schemas.openxmlformats.org/drawingml/2006/main" xmlns:p="http://schemas.openxmlformats.org/presentationml/2006/main" xmlns:r="http://schemas.openxmlformats.org/officeDocument/2006/relationships">
   <p:cSld>
     <p:spTree>
@@ -7904,7 +6483,7 @@
                   <a:srgbClr val="FDBA74"/>
                 </a:solidFill>
               </a:rPr>
-              <a:t>Cloud Firestore · 3 collections · ownerId links every document to its owner</a:t>
+              <a:t>Cloud Firestore Â· 3 collections Â· ownerId links every document to its owner</a:t>
             </a:r>
           </a:p>
         </p:txBody>
@@ -8052,7 +6631,7 @@
                             <a:srgbClr val="0F172A"/>
                           </a:solidFill>
                         </a:rPr>
-                        <a:t>uid (doc id) · email (string) · displayName (string) · createdAt (timestamp)</a:t>
+                        <a:t>uid (doc id) Â· email (string) Â· displayName (string) Â· createdAt (timestamp)</a:t>
                       </a:r>
                     </a:p>
                   </a:txBody>
@@ -8096,7 +6675,7 @@
                             <a:srgbClr val="0F172A"/>
                           </a:solidFill>
                         </a:rPr>
-                        <a:t>ownerId (string) · title (string) · type (string) · durationMin (number) · notes (string) · date (timestamp) · createdAt (timestamp)</a:t>
+                        <a:t>ownerId (string) Â· title (string) Â· type (string) Â· durationMin (number) Â· notes (string) Â· date (timestamp) Â· createdAt (timestamp)</a:t>
                       </a:r>
                     </a:p>
                   </a:txBody>
@@ -8140,7 +6719,7 @@
                             <a:srgbClr val="0F172A"/>
                           </a:solidFill>
                         </a:rPr>
-                        <a:t>ownerId (string) · title (string) · gym (string) · startsAt (timestamp) · maxPeople (number) · participantIds (array of string)</a:t>
+                        <a:t>ownerId (string) Â· title (string) Â· gym (string) Â· startsAt (timestamp) Â· maxPeople (number) Â· participantIds (array of string)</a:t>
                       </a:r>
                     </a:p>
                   </a:txBody>
@@ -8184,7 +6763,7 @@
                   <a:srgbClr val="C2410C"/>
                 </a:solidFill>
               </a:rPr>
-              <a:t>Security Rules (Lab 2) make sure users can only edit their own data – enforced in Firebase, not just in the app.</a:t>
+              <a:t>Security Rules (Lab 2) make sure users can only edit their own data â€“ enforced in Firebase, not just in the app.</a:t>
             </a:r>
           </a:p>
         </p:txBody>
@@ -8197,7 +6776,7 @@
 </p:sld>
 </file>
 
-<file path=ppt/slides/slide8.xml><?xml version="1.0" encoding="utf-8"?>
+<file path=ppt/slides/slide7.xml><?xml version="1.0" encoding="utf-8"?>
 <p:sld xmlns:a="http://schemas.openxmlformats.org/drawingml/2006/main" xmlns:p="http://schemas.openxmlformats.org/presentationml/2006/main" xmlns:r="http://schemas.openxmlformats.org/officeDocument/2006/relationships">
   <p:cSld>
     <p:spTree>
@@ -8374,7 +6953,7 @@
                   <a:srgbClr val="0F172A"/>
                 </a:solidFill>
               </a:rPr>
-              <a:t>LoginScreen · RegisterScreen · HomeScreen · AppNavHost</a:t>
+              <a:t>LoginScreen Â· RegisterScreen Â· HomeScreen Â· AppNavHost</a:t>
             </a:r>
           </a:p>
         </p:txBody>
@@ -8439,7 +7018,7 @@
                   <a:srgbClr val="0F172A"/>
                 </a:solidFill>
               </a:rPr>
-              <a:t>AuthValidator · AuthViewModel (StateFlow)</a:t>
+              <a:t>AuthValidator Â· AuthViewModel (StateFlow)</a:t>
             </a:r>
           </a:p>
         </p:txBody>
@@ -8504,7 +7083,7 @@
                   <a:srgbClr val="0F172A"/>
                 </a:solidFill>
               </a:rPr>
-              <a:t>AuthRepository → FirebaseAuthRepository</a:t>
+              <a:t>AuthRepository â†’ FirebaseAuthRepository</a:t>
             </a:r>
           </a:p>
         </p:txBody>
@@ -8844,7 +7423,7 @@
                   <a:srgbClr val="FFFFFF"/>
                 </a:solidFill>
               </a:rPr>
-              <a:t>Lab 3 – weekly stats</a:t>
+              <a:t>Lab 3 â€“ weekly stats</a:t>
             </a:r>
           </a:p>
         </p:txBody>
@@ -8879,6 +7458,418 @@
                 </a:solidFill>
               </a:rPr>
               <a:t>Why: simple screens, and the logic (e.g. AuthValidator) can be unit-tested on the JVM in Lab 3.</a:t>
+            </a:r>
+          </a:p>
+        </p:txBody>
+      </p:sp>
+    </p:spTree>
+  </p:cSld>
+  <p:clrMapOvr>
+    <a:masterClrMapping/>
+  </p:clrMapOvr>
+</p:sld>
+</file>
+
+<file path=ppt/slides/slide8.xml><?xml version="1.0" encoding="utf-8"?>
+<p:sld xmlns:a="http://schemas.openxmlformats.org/drawingml/2006/main" xmlns:p="http://schemas.openxmlformats.org/presentationml/2006/main" xmlns:r="http://schemas.openxmlformats.org/officeDocument/2006/relationships">
+  <p:cSld>
+    <p:spTree>
+      <p:nvGrpSpPr>
+        <p:cNvPr id="1" name=""/>
+        <p:cNvGrpSpPr/>
+        <p:nvPr/>
+      </p:nvGrpSpPr>
+      <p:grpSpPr/>
+      <p:sp>
+        <p:nvSpPr>
+          <p:cNvPr id="2" name="Rectangle 1"/>
+          <p:cNvSpPr/>
+          <p:nvPr/>
+        </p:nvSpPr>
+        <p:spPr>
+          <a:xfrm>
+            <a:off x="0" y="0"/>
+            <a:ext cx="12191695" cy="1097280"/>
+          </a:xfrm>
+          <a:prstGeom prst="rect">
+            <a:avLst/>
+          </a:prstGeom>
+          <a:solidFill>
+            <a:srgbClr val="111827"/>
+          </a:solidFill>
+          <a:ln>
+            <a:noFill/>
+          </a:ln>
+          <a:effectLst/>
+        </p:spPr>
+        <p:style>
+          <a:lnRef idx="1">
+            <a:schemeClr val="accent1"/>
+          </a:lnRef>
+          <a:fillRef idx="3">
+            <a:schemeClr val="accent1"/>
+          </a:fillRef>
+          <a:effectRef idx="2">
+            <a:schemeClr val="accent1"/>
+          </a:effectRef>
+          <a:fontRef idx="minor">
+            <a:schemeClr val="lt1"/>
+          </a:fontRef>
+        </p:style>
+        <p:txBody>
+          <a:bodyPr rtlCol="0" anchor="ctr" wrap="square" lIns="457200" rIns="457200" tIns="73152" bIns="73152"/>
+          <a:lstStyle/>
+          <a:p>
+            <a:pPr algn="ctr"/>
+            <a:r>
+              <a:rPr sz="3200" b="1">
+                <a:solidFill>
+                  <a:srgbClr val="FFFFFF"/>
+                </a:solidFill>
+              </a:rPr>
+              <a:t>User stories</a:t>
+            </a:r>
+          </a:p>
+          <a:p>
+            <a:pPr algn="l"/>
+            <a:r>
+              <a:rPr sz="1500" b="0">
+                <a:solidFill>
+                  <a:srgbClr val="FDBA74"/>
+                </a:solidFill>
+              </a:rPr>
+              <a:t>Written as GitHub Issues, in the format required by the lab instructions</a:t>
+            </a:r>
+          </a:p>
+        </p:txBody>
+      </p:sp>
+      <p:sp>
+        <p:nvSpPr>
+          <p:cNvPr id="3" name="Rectangle 2"/>
+          <p:cNvSpPr/>
+          <p:nvPr/>
+        </p:nvSpPr>
+        <p:spPr>
+          <a:xfrm>
+            <a:off x="0" y="1097280"/>
+            <a:ext cx="12191695" cy="64008"/>
+          </a:xfrm>
+          <a:prstGeom prst="rect">
+            <a:avLst/>
+          </a:prstGeom>
+          <a:solidFill>
+            <a:srgbClr val="F97316"/>
+          </a:solidFill>
+          <a:ln>
+            <a:noFill/>
+          </a:ln>
+          <a:effectLst/>
+        </p:spPr>
+        <p:style>
+          <a:lnRef idx="1">
+            <a:schemeClr val="accent1"/>
+          </a:lnRef>
+          <a:fillRef idx="3">
+            <a:schemeClr val="accent1"/>
+          </a:fillRef>
+          <a:effectRef idx="2">
+            <a:schemeClr val="accent1"/>
+          </a:effectRef>
+          <a:fontRef idx="minor">
+            <a:schemeClr val="lt1"/>
+          </a:fontRef>
+        </p:style>
+        <p:txBody>
+          <a:bodyPr rtlCol="0" anchor="ctr"/>
+          <a:lstStyle/>
+          <a:p>
+            <a:pPr algn="ctr"/>
+          </a:p>
+        </p:txBody>
+      </p:sp>
+      <p:sp>
+        <p:nvSpPr>
+          <p:cNvPr id="4" name="Rounded Rectangle 3"/>
+          <p:cNvSpPr/>
+          <p:nvPr/>
+        </p:nvSpPr>
+        <p:spPr>
+          <a:xfrm>
+            <a:off x="640080" y="1554480"/>
+            <a:ext cx="5394960" cy="4480560"/>
+          </a:xfrm>
+          <a:prstGeom prst="roundRect">
+            <a:avLst/>
+          </a:prstGeom>
+          <a:solidFill>
+            <a:srgbClr val="F1F5F9"/>
+          </a:solidFill>
+          <a:ln>
+            <a:noFill/>
+          </a:ln>
+          <a:effectLst/>
+        </p:spPr>
+        <p:style>
+          <a:lnRef idx="1">
+            <a:schemeClr val="accent1"/>
+          </a:lnRef>
+          <a:fillRef idx="3">
+            <a:schemeClr val="accent1"/>
+          </a:fillRef>
+          <a:effectRef idx="2">
+            <a:schemeClr val="accent1"/>
+          </a:effectRef>
+          <a:fontRef idx="minor">
+            <a:schemeClr val="lt1"/>
+          </a:fontRef>
+        </p:style>
+        <p:txBody>
+          <a:bodyPr rtlCol="0" anchor="ctr" wrap="square" lIns="274320" rIns="274320" tIns="73152" bIns="73152"/>
+          <a:lstStyle/>
+          <a:p>
+            <a:pPr algn="ctr"/>
+            <a:r>
+              <a:rPr sz="1500" b="1">
+                <a:solidFill>
+                  <a:srgbClr val="0F172A"/>
+                </a:solidFill>
+              </a:rPr>
+              <a:t>Title: As a gym-goer, I want to log in with email and password</a:t>
+            </a:r>
+          </a:p>
+          <a:p>
+            <a:pPr algn="l"/>
+            <a:r>
+              <a:rPr sz="1400" b="0">
+                <a:solidFill>
+                  <a:srgbClr val="0F172A"/>
+                </a:solidFill>
+              </a:rPr>
+              <a:t/>
+            </a:r>
+          </a:p>
+          <a:p>
+            <a:pPr algn="l"/>
+            <a:r>
+              <a:rPr sz="1400" b="1">
+                <a:solidFill>
+                  <a:srgbClr val="0F172A"/>
+                </a:solidFill>
+              </a:rPr>
+              <a:t>User story</a:t>
+            </a:r>
+          </a:p>
+          <a:p>
+            <a:pPr algn="l"/>
+            <a:r>
+              <a:rPr sz="1400" b="0">
+                <a:solidFill>
+                  <a:srgbClr val="0F172A"/>
+                </a:solidFill>
+              </a:rPr>
+              <a:t>As a gym-goer, I want to log in with my email and password, so that I can access my own workouts.</a:t>
+            </a:r>
+          </a:p>
+          <a:p>
+            <a:pPr algn="l"/>
+            <a:r>
+              <a:rPr sz="1400" b="0">
+                <a:solidFill>
+                  <a:srgbClr val="0F172A"/>
+                </a:solidFill>
+              </a:rPr>
+              <a:t/>
+            </a:r>
+          </a:p>
+          <a:p>
+            <a:pPr algn="l"/>
+            <a:r>
+              <a:rPr sz="1400" b="1">
+                <a:solidFill>
+                  <a:srgbClr val="0F172A"/>
+                </a:solidFill>
+              </a:rPr>
+              <a:t>Acceptance criteria</a:t>
+            </a:r>
+          </a:p>
+          <a:p>
+            <a:pPr algn="l"/>
+            <a:r>
+              <a:rPr sz="1400" b="0">
+                <a:solidFill>
+                  <a:srgbClr val="0F172A"/>
+                </a:solidFill>
+              </a:rPr>
+              <a:t>â˜ Valid credentials open the home screen</a:t>
+            </a:r>
+          </a:p>
+          <a:p>
+            <a:pPr algn="l"/>
+            <a:r>
+              <a:rPr sz="1400" b="0">
+                <a:solidFill>
+                  <a:srgbClr val="0F172A"/>
+                </a:solidFill>
+              </a:rPr>
+              <a:t>â˜ Wrong credentials show an error message</a:t>
+            </a:r>
+          </a:p>
+          <a:p>
+            <a:pPr algn="l"/>
+            <a:r>
+              <a:rPr sz="1400" b="0">
+                <a:solidFill>
+                  <a:srgbClr val="0F172A"/>
+                </a:solidFill>
+              </a:rPr>
+              <a:t>â˜ A logged-in user skips the login screen after restart</a:t>
+            </a:r>
+          </a:p>
+        </p:txBody>
+      </p:sp>
+      <p:sp>
+        <p:nvSpPr>
+          <p:cNvPr id="5" name="TextBox 4"/>
+          <p:cNvSpPr txBox="1"/>
+          <p:nvPr/>
+        </p:nvSpPr>
+        <p:spPr>
+          <a:xfrm>
+            <a:off x="6309360" y="1554480"/>
+            <a:ext cx="5394960" cy="4572000"/>
+          </a:xfrm>
+          <a:prstGeom prst="rect">
+            <a:avLst/>
+          </a:prstGeom>
+          <a:noFill/>
+        </p:spPr>
+        <p:txBody>
+          <a:bodyPr wrap="square">
+            <a:spAutoFit/>
+          </a:bodyPr>
+          <a:lstStyle/>
+          <a:p>
+            <a:pPr algn="l">
+              <a:spcAft>
+                <a:spcPts val="1000"/>
+              </a:spcAft>
+            </a:pPr>
+            <a:r>
+              <a:rPr sz="1700" b="1">
+                <a:solidFill>
+                  <a:srgbClr val="F97316"/>
+                </a:solidFill>
+              </a:rPr>
+              <a:t>â€¢  </a:t>
+            </a:r>
+            <a:r>
+              <a:rPr sz="1700" b="1">
+                <a:solidFill>
+                  <a:srgbClr val="0F172A"/>
+                </a:solidFill>
+              </a:rPr>
+              <a:t>Format:</a:t>
+            </a:r>
+            <a:r>
+              <a:rPr sz="1700" b="0">
+                <a:solidFill>
+                  <a:srgbClr val="64748B"/>
+                </a:solidFill>
+              </a:rPr>
+              <a:t> title + user story + acceptance criteria checklist.</a:t>
+            </a:r>
+          </a:p>
+          <a:p>
+            <a:pPr algn="l">
+              <a:spcAft>
+                <a:spcPts val="1000"/>
+              </a:spcAft>
+            </a:pPr>
+            <a:r>
+              <a:rPr sz="1700" b="1">
+                <a:solidFill>
+                  <a:srgbClr val="F97316"/>
+                </a:solidFill>
+              </a:rPr>
+              <a:t>â€¢  </a:t>
+            </a:r>
+            <a:r>
+              <a:rPr sz="1700" b="1">
+                <a:solidFill>
+                  <a:srgbClr val="0F172A"/>
+                </a:solidFill>
+              </a:rPr>
+              <a:t>Labels:</a:t>
+            </a:r>
+            <a:r>
+              <a:rPr sz="1700" b="0">
+                <a:solidFill>
+                  <a:srgbClr val="64748B"/>
+                </a:solidFill>
+              </a:rPr>
+              <a:t> user-story plus android / firebase / ui.</a:t>
+            </a:r>
+          </a:p>
+          <a:p>
+            <a:pPr algn="l">
+              <a:spcAft>
+                <a:spcPts val="1000"/>
+              </a:spcAft>
+            </a:pPr>
+            <a:r>
+              <a:rPr sz="1700" b="1">
+                <a:solidFill>
+                  <a:srgbClr val="F97316"/>
+                </a:solidFill>
+              </a:rPr>
+              <a:t>â€¢  </a:t>
+            </a:r>
+            <a:r>
+              <a:rPr sz="1700" b="1">
+                <a:solidFill>
+                  <a:srgbClr val="0F172A"/>
+                </a:solidFill>
+              </a:rPr>
+              <a:t>Board:</a:t>
+            </a:r>
+            <a:r>
+              <a:rPr sz="1700" b="0">
+                <a:solidFill>
+                  <a:srgbClr val="64748B"/>
+                </a:solidFill>
+              </a:rPr>
+              <a:t> Sprint 1 issues in the Sprint 1 column, others in Backlog; each has an assignee.</a:t>
+            </a:r>
+          </a:p>
+          <a:p>
+            <a:pPr algn="l">
+              <a:spcAft>
+                <a:spcPts val="1000"/>
+              </a:spcAft>
+            </a:pPr>
+            <a:r>
+              <a:rPr sz="1700" b="1">
+                <a:solidFill>
+                  <a:srgbClr val="F97316"/>
+                </a:solidFill>
+              </a:rPr>
+              <a:t>â€¢  </a:t>
+            </a:r>
+            <a:r>
+              <a:rPr sz="1700" b="1">
+                <a:solidFill>
+                  <a:srgbClr val="0F172A"/>
+                </a:solidFill>
+              </a:rPr>
+              <a:t>Closing:</a:t>
+            </a:r>
+            <a:r>
+              <a:rPr sz="1700" b="0">
+                <a:solidFill>
+                  <a:srgbClr val="64748B"/>
+                </a:solidFill>
+              </a:rPr>
+              <a:t> the PR says â€œCloses #issueâ€, so the issue moves to Done on merge.</a:t>
             </a:r>
           </a:p>
         </p:txBody>
@@ -8948,7 +7939,7 @@
                   <a:srgbClr val="FFFFFF"/>
                 </a:solidFill>
               </a:rPr>
-              <a:t>User stories</a:t>
+              <a:t>Sprint 1 backlog</a:t>
             </a:r>
           </a:p>
           <a:p>
@@ -8959,7 +7950,7 @@
                   <a:srgbClr val="FDBA74"/>
                 </a:solidFill>
               </a:rPr>
-              <a:t>Written as GitHub Issues, in the format required by the lab instructions</a:t>
+              <a:t>Each story has acceptance criteria and an assignee</a:t>
             </a:r>
           </a:p>
         </p:txBody>
@@ -9008,146 +7999,358 @@
           </a:p>
         </p:txBody>
       </p:sp>
-      <p:sp>
-        <p:nvSpPr>
-          <p:cNvPr id="4" name="Rounded Rectangle 3"/>
-          <p:cNvSpPr/>
+      <p:graphicFrame>
+        <p:nvGraphicFramePr>
+          <p:cNvPr id="4" name="Table 3"/>
+          <p:cNvGraphicFramePr>
+            <a:graphicFrameLocks noGrp="1"/>
+          </p:cNvGraphicFramePr>
           <p:nvPr/>
-        </p:nvSpPr>
-        <p:spPr>
-          <a:xfrm>
-            <a:off x="640080" y="1554480"/>
-            <a:ext cx="5394960" cy="4480560"/>
-          </a:xfrm>
-          <a:prstGeom prst="roundRect">
-            <a:avLst/>
-          </a:prstGeom>
-          <a:solidFill>
-            <a:srgbClr val="F1F5F9"/>
-          </a:solidFill>
-          <a:ln>
-            <a:noFill/>
-          </a:ln>
-          <a:effectLst/>
-        </p:spPr>
-        <p:style>
-          <a:lnRef idx="1">
-            <a:schemeClr val="accent1"/>
-          </a:lnRef>
-          <a:fillRef idx="3">
-            <a:schemeClr val="accent1"/>
-          </a:fillRef>
-          <a:effectRef idx="2">
-            <a:schemeClr val="accent1"/>
-          </a:effectRef>
-          <a:fontRef idx="minor">
-            <a:schemeClr val="lt1"/>
-          </a:fontRef>
-        </p:style>
-        <p:txBody>
-          <a:bodyPr rtlCol="0" anchor="ctr" wrap="square" lIns="274320" rIns="274320" tIns="73152" bIns="73152"/>
-          <a:lstStyle/>
-          <a:p>
-            <a:pPr algn="ctr"/>
-            <a:r>
-              <a:rPr sz="1500" b="1">
-                <a:solidFill>
-                  <a:srgbClr val="0F172A"/>
-                </a:solidFill>
-              </a:rPr>
-              <a:t>Title: As a gym-goer, I want to log in with email and password</a:t>
-            </a:r>
-          </a:p>
-          <a:p>
-            <a:pPr algn="l"/>
-            <a:r>
-              <a:rPr sz="1400" b="0">
-                <a:solidFill>
-                  <a:srgbClr val="0F172A"/>
-                </a:solidFill>
-              </a:rPr>
-              <a:t/>
-            </a:r>
-          </a:p>
-          <a:p>
-            <a:pPr algn="l"/>
-            <a:r>
-              <a:rPr sz="1400" b="1">
-                <a:solidFill>
-                  <a:srgbClr val="0F172A"/>
-                </a:solidFill>
-              </a:rPr>
-              <a:t>User story</a:t>
-            </a:r>
-          </a:p>
-          <a:p>
-            <a:pPr algn="l"/>
-            <a:r>
-              <a:rPr sz="1400" b="0">
-                <a:solidFill>
-                  <a:srgbClr val="0F172A"/>
-                </a:solidFill>
-              </a:rPr>
-              <a:t>As a gym-goer, I want to log in with my email and password, so that I can access my own workouts.</a:t>
-            </a:r>
-          </a:p>
-          <a:p>
-            <a:pPr algn="l"/>
-            <a:r>
-              <a:rPr sz="1400" b="0">
-                <a:solidFill>
-                  <a:srgbClr val="0F172A"/>
-                </a:solidFill>
-              </a:rPr>
-              <a:t/>
-            </a:r>
-          </a:p>
-          <a:p>
-            <a:pPr algn="l"/>
-            <a:r>
-              <a:rPr sz="1400" b="1">
-                <a:solidFill>
-                  <a:srgbClr val="0F172A"/>
-                </a:solidFill>
-              </a:rPr>
-              <a:t>Acceptance criteria</a:t>
-            </a:r>
-          </a:p>
-          <a:p>
-            <a:pPr algn="l"/>
-            <a:r>
-              <a:rPr sz="1400" b="0">
-                <a:solidFill>
-                  <a:srgbClr val="0F172A"/>
-                </a:solidFill>
-              </a:rPr>
-              <a:t>☐ Valid credentials open the home screen</a:t>
-            </a:r>
-          </a:p>
-          <a:p>
-            <a:pPr algn="l"/>
-            <a:r>
-              <a:rPr sz="1400" b="0">
-                <a:solidFill>
-                  <a:srgbClr val="0F172A"/>
-                </a:solidFill>
-              </a:rPr>
-              <a:t>☐ Wrong credentials show an error message</a:t>
-            </a:r>
-          </a:p>
-          <a:p>
-            <a:pPr algn="l"/>
-            <a:r>
-              <a:rPr sz="1400" b="0">
-                <a:solidFill>
-                  <a:srgbClr val="0F172A"/>
-                </a:solidFill>
-              </a:rPr>
-              <a:t>☐ A logged-in user skips the login screen after restart</a:t>
-            </a:r>
-          </a:p>
-        </p:txBody>
-      </p:sp>
+        </p:nvGraphicFramePr>
+        <p:xfrm>
+          <a:off x="640080" y="1645920"/>
+          <a:ext cx="10881360" cy="3657600"/>
+        </p:xfrm>
+        <a:graphic>
+          <a:graphicData uri="http://schemas.openxmlformats.org/drawingml/2006/table">
+            <a:tbl>
+              <a:tblPr firstRow="1" bandRow="1">
+                <a:tableStyleId>{5C22544A-7EE6-4342-B048-85BDC9FD1C3A}</a:tableStyleId>
+              </a:tblPr>
+              <a:tblGrid>
+                <a:gridCol w="6035040"/>
+                <a:gridCol w="3566160"/>
+                <a:gridCol w="1280160"/>
+              </a:tblGrid>
+              <a:tr h="731520">
+                <a:tc>
+                  <a:txBody>
+                    <a:bodyPr/>
+                    <a:lstStyle/>
+                    <a:p>
+                      <a:r>
+                        <a:rPr sz="1600" b="1">
+                          <a:solidFill>
+                            <a:srgbClr val="FFFFFF"/>
+                          </a:solidFill>
+                        </a:rPr>
+                        <a:t>User story</a:t>
+                      </a:r>
+                    </a:p>
+                  </a:txBody>
+                  <a:tcPr>
+                    <a:solidFill>
+                      <a:srgbClr val="111827"/>
+                    </a:solidFill>
+                  </a:tcPr>
+                </a:tc>
+                <a:tc>
+                  <a:txBody>
+                    <a:bodyPr/>
+                    <a:lstStyle/>
+                    <a:p>
+                      <a:r>
+                        <a:rPr sz="1600" b="1">
+                          <a:solidFill>
+                            <a:srgbClr val="FFFFFF"/>
+                          </a:solidFill>
+                        </a:rPr>
+                        <a:t>Labels</a:t>
+                      </a:r>
+                    </a:p>
+                  </a:txBody>
+                  <a:tcPr>
+                    <a:solidFill>
+                      <a:srgbClr val="111827"/>
+                    </a:solidFill>
+                  </a:tcPr>
+                </a:tc>
+                <a:tc>
+                  <a:txBody>
+                    <a:bodyPr/>
+                    <a:lstStyle/>
+                    <a:p>
+                      <a:r>
+                        <a:rPr sz="1600" b="1">
+                          <a:solidFill>
+                            <a:srgbClr val="FFFFFF"/>
+                          </a:solidFill>
+                        </a:rPr>
+                        <a:t>Assignee</a:t>
+                      </a:r>
+                    </a:p>
+                  </a:txBody>
+                  <a:tcPr>
+                    <a:solidFill>
+                      <a:srgbClr val="111827"/>
+                    </a:solidFill>
+                  </a:tcPr>
+                </a:tc>
+              </a:tr>
+              <a:tr h="731520">
+                <a:tc>
+                  <a:txBody>
+                    <a:bodyPr/>
+                    <a:lstStyle/>
+                    <a:p>
+                      <a:r>
+                        <a:rPr sz="1600" b="0">
+                          <a:solidFill>
+                            <a:srgbClr val="0F172A"/>
+                          </a:solidFill>
+                        </a:rPr>
+                        <a:t>As a gym-goer, I want to register and log in with email and password</a:t>
+                      </a:r>
+                    </a:p>
+                  </a:txBody>
+                  <a:tcPr>
+                    <a:solidFill>
+                      <a:srgbClr val="F1F5F9"/>
+                    </a:solidFill>
+                  </a:tcPr>
+                </a:tc>
+                <a:tc>
+                  <a:txBody>
+                    <a:bodyPr/>
+                    <a:lstStyle/>
+                    <a:p>
+                      <a:r>
+                        <a:rPr sz="1600" b="0">
+                          <a:solidFill>
+                            <a:srgbClr val="0F172A"/>
+                          </a:solidFill>
+                        </a:rPr>
+                        <a:t>user-story Â· android Â· firebase</a:t>
+                      </a:r>
+                    </a:p>
+                  </a:txBody>
+                  <a:tcPr>
+                    <a:solidFill>
+                      <a:srgbClr val="F1F5F9"/>
+                    </a:solidFill>
+                  </a:tcPr>
+                </a:tc>
+                <a:tc>
+                  <a:txBody>
+                    <a:bodyPr/>
+                    <a:lstStyle/>
+                    <a:p>
+                      <a:r>
+                        <a:rPr sz="1600" b="0">
+                          <a:solidFill>
+                            <a:srgbClr val="0F172A"/>
+                          </a:solidFill>
+                        </a:rPr>
+                        <a:t>Ozodbek</a:t>
+                      </a:r>
+                    </a:p>
+                  </a:txBody>
+                  <a:tcPr>
+                    <a:solidFill>
+                      <a:srgbClr val="F1F5F9"/>
+                    </a:solidFill>
+                  </a:tcPr>
+                </a:tc>
+              </a:tr>
+              <a:tr h="731520">
+                <a:tc>
+                  <a:txBody>
+                    <a:bodyPr/>
+                    <a:lstStyle/>
+                    <a:p>
+                      <a:r>
+                        <a:rPr sz="1600" b="0">
+                          <a:solidFill>
+                            <a:srgbClr val="0F172A"/>
+                          </a:solidFill>
+                        </a:rPr>
+                        <a:t>As a gym-goer, I want to see a list of my workouts</a:t>
+                      </a:r>
+                    </a:p>
+                  </a:txBody>
+                  <a:tcPr>
+                    <a:solidFill>
+                      <a:srgbClr val="FFFFFF"/>
+                    </a:solidFill>
+                  </a:tcPr>
+                </a:tc>
+                <a:tc>
+                  <a:txBody>
+                    <a:bodyPr/>
+                    <a:lstStyle/>
+                    <a:p>
+                      <a:r>
+                        <a:rPr sz="1600" b="0">
+                          <a:solidFill>
+                            <a:srgbClr val="0F172A"/>
+                          </a:solidFill>
+                        </a:rPr>
+                        <a:t>user-story Â· android Â· ui</a:t>
+                      </a:r>
+                    </a:p>
+                  </a:txBody>
+                  <a:tcPr>
+                    <a:solidFill>
+                      <a:srgbClr val="FFFFFF"/>
+                    </a:solidFill>
+                  </a:tcPr>
+                </a:tc>
+                <a:tc>
+                  <a:txBody>
+                    <a:bodyPr/>
+                    <a:lstStyle/>
+                    <a:p>
+                      <a:r>
+                        <a:rPr sz="1600" b="0">
+                          <a:solidFill>
+                            <a:srgbClr val="0F172A"/>
+                          </a:solidFill>
+                        </a:rPr>
+                        <a:t>Elturan</a:t>
+                      </a:r>
+                    </a:p>
+                  </a:txBody>
+                  <a:tcPr>
+                    <a:solidFill>
+                      <a:srgbClr val="FFFFFF"/>
+                    </a:solidFill>
+                  </a:tcPr>
+                </a:tc>
+              </a:tr>
+              <a:tr h="731520">
+                <a:tc>
+                  <a:txBody>
+                    <a:bodyPr/>
+                    <a:lstStyle/>
+                    <a:p>
+                      <a:r>
+                        <a:rPr sz="1600" b="0">
+                          <a:solidFill>
+                            <a:srgbClr val="0F172A"/>
+                          </a:solidFill>
+                        </a:rPr>
+                        <a:t>As a gym-goer, I want to add a workout</a:t>
+                      </a:r>
+                    </a:p>
+                  </a:txBody>
+                  <a:tcPr>
+                    <a:solidFill>
+                      <a:srgbClr val="F1F5F9"/>
+                    </a:solidFill>
+                  </a:tcPr>
+                </a:tc>
+                <a:tc>
+                  <a:txBody>
+                    <a:bodyPr/>
+                    <a:lstStyle/>
+                    <a:p>
+                      <a:r>
+                        <a:rPr sz="1600" b="0">
+                          <a:solidFill>
+                            <a:srgbClr val="0F172A"/>
+                          </a:solidFill>
+                        </a:rPr>
+                        <a:t>user-story Â· android Â· firebase</a:t>
+                      </a:r>
+                    </a:p>
+                  </a:txBody>
+                  <a:tcPr>
+                    <a:solidFill>
+                      <a:srgbClr val="F1F5F9"/>
+                    </a:solidFill>
+                  </a:tcPr>
+                </a:tc>
+                <a:tc>
+                  <a:txBody>
+                    <a:bodyPr/>
+                    <a:lstStyle/>
+                    <a:p>
+                      <a:r>
+                        <a:rPr sz="1600" b="0">
+                          <a:solidFill>
+                            <a:srgbClr val="0F172A"/>
+                          </a:solidFill>
+                        </a:rPr>
+                        <a:t>Aida</a:t>
+                      </a:r>
+                    </a:p>
+                  </a:txBody>
+                  <a:tcPr>
+                    <a:solidFill>
+                      <a:srgbClr val="F1F5F9"/>
+                    </a:solidFill>
+                  </a:tcPr>
+                </a:tc>
+              </a:tr>
+              <a:tr h="731520">
+                <a:tc>
+                  <a:txBody>
+                    <a:bodyPr/>
+                    <a:lstStyle/>
+                    <a:p>
+                      <a:r>
+                        <a:rPr sz="1600" b="0">
+                          <a:solidFill>
+                            <a:srgbClr val="0F172A"/>
+                          </a:solidFill>
+                        </a:rPr>
+                        <a:t>As a gym-goer, I want to edit or delete a workout</a:t>
+                      </a:r>
+                    </a:p>
+                  </a:txBody>
+                  <a:tcPr>
+                    <a:solidFill>
+                      <a:srgbClr val="FFFFFF"/>
+                    </a:solidFill>
+                  </a:tcPr>
+                </a:tc>
+                <a:tc>
+                  <a:txBody>
+                    <a:bodyPr/>
+                    <a:lstStyle/>
+                    <a:p>
+                      <a:r>
+                        <a:rPr sz="1600" b="0">
+                          <a:solidFill>
+                            <a:srgbClr val="0F172A"/>
+                          </a:solidFill>
+                        </a:rPr>
+                        <a:t>user-story Â· android Â· firebase</a:t>
+                      </a:r>
+                    </a:p>
+                  </a:txBody>
+                  <a:tcPr>
+                    <a:solidFill>
+                      <a:srgbClr val="FFFFFF"/>
+                    </a:solidFill>
+                  </a:tcPr>
+                </a:tc>
+                <a:tc>
+                  <a:txBody>
+                    <a:bodyPr/>
+                    <a:lstStyle/>
+                    <a:p>
+                      <a:r>
+                        <a:rPr sz="1600" b="0">
+                          <a:solidFill>
+                            <a:srgbClr val="0F172A"/>
+                          </a:solidFill>
+                        </a:rPr>
+                        <a:t>Elturan</a:t>
+                      </a:r>
+                    </a:p>
+                  </a:txBody>
+                  <a:tcPr>
+                    <a:solidFill>
+                      <a:srgbClr val="FFFFFF"/>
+                    </a:solidFill>
+                  </a:tcPr>
+                </a:tc>
+              </a:tr>
+            </a:tbl>
+          </a:graphicData>
+        </a:graphic>
+      </p:graphicFrame>
       <p:sp>
         <p:nvSpPr>
           <p:cNvPr id="5" name="TextBox 4"/>
@@ -9156,8 +8359,8 @@
         </p:nvSpPr>
         <p:spPr>
           <a:xfrm>
-            <a:off x="6309360" y="1554480"/>
-            <a:ext cx="5394960" cy="4572000"/>
+            <a:off x="640080" y="5486400"/>
+            <a:ext cx="10881360" cy="914400"/>
           </a:xfrm>
           <a:prstGeom prst="rect">
             <a:avLst/>
@@ -9170,127 +8373,14 @@
           </a:bodyPr>
           <a:lstStyle/>
           <a:p>
-            <a:pPr algn="l">
-              <a:spcAft>
-                <a:spcPts val="1000"/>
-              </a:spcAft>
-            </a:pPr>
-            <a:r>
-              <a:rPr sz="1700" b="1">
-                <a:solidFill>
-                  <a:srgbClr val="F97316"/>
-                </a:solidFill>
-              </a:rPr>
-              <a:t>•  </a:t>
-            </a:r>
-            <a:r>
-              <a:rPr sz="1700" b="1">
-                <a:solidFill>
-                  <a:srgbClr val="0F172A"/>
-                </a:solidFill>
-              </a:rPr>
-              <a:t>Format:</a:t>
-            </a:r>
+            <a:pPr algn="l"/>
             <a:r>
               <a:rPr sz="1700" b="0">
                 <a:solidFill>
                   <a:srgbClr val="64748B"/>
                 </a:solidFill>
               </a:rPr>
-              <a:t> title + user story + acceptance criteria checklist.</a:t>
-            </a:r>
-          </a:p>
-          <a:p>
-            <a:pPr algn="l">
-              <a:spcAft>
-                <a:spcPts val="1000"/>
-              </a:spcAft>
-            </a:pPr>
-            <a:r>
-              <a:rPr sz="1700" b="1">
-                <a:solidFill>
-                  <a:srgbClr val="F97316"/>
-                </a:solidFill>
-              </a:rPr>
-              <a:t>•  </a:t>
-            </a:r>
-            <a:r>
-              <a:rPr sz="1700" b="1">
-                <a:solidFill>
-                  <a:srgbClr val="0F172A"/>
-                </a:solidFill>
-              </a:rPr>
-              <a:t>Labels:</a:t>
-            </a:r>
-            <a:r>
-              <a:rPr sz="1700" b="0">
-                <a:solidFill>
-                  <a:srgbClr val="64748B"/>
-                </a:solidFill>
-              </a:rPr>
-              <a:t> user-story plus android / firebase / ui.</a:t>
-            </a:r>
-          </a:p>
-          <a:p>
-            <a:pPr algn="l">
-              <a:spcAft>
-                <a:spcPts val="1000"/>
-              </a:spcAft>
-            </a:pPr>
-            <a:r>
-              <a:rPr sz="1700" b="1">
-                <a:solidFill>
-                  <a:srgbClr val="F97316"/>
-                </a:solidFill>
-              </a:rPr>
-              <a:t>•  </a:t>
-            </a:r>
-            <a:r>
-              <a:rPr sz="1700" b="1">
-                <a:solidFill>
-                  <a:srgbClr val="0F172A"/>
-                </a:solidFill>
-              </a:rPr>
-              <a:t>Board:</a:t>
-            </a:r>
-            <a:r>
-              <a:rPr sz="1700" b="0">
-                <a:solidFill>
-                  <a:srgbClr val="64748B"/>
-                </a:solidFill>
-              </a:rPr>
-              <a:t> Sprint 1 issues in the Sprint 1 column, others in Backlog; each has an assignee.</a:t>
-            </a:r>
-          </a:p>
-          <a:p>
-            <a:pPr algn="l">
-              <a:spcAft>
-                <a:spcPts val="1000"/>
-              </a:spcAft>
-            </a:pPr>
-            <a:r>
-              <a:rPr sz="1700" b="1">
-                <a:solidFill>
-                  <a:srgbClr val="F97316"/>
-                </a:solidFill>
-              </a:rPr>
-              <a:t>•  </a:t>
-            </a:r>
-            <a:r>
-              <a:rPr sz="1700" b="1">
-                <a:solidFill>
-                  <a:srgbClr val="0F172A"/>
-                </a:solidFill>
-              </a:rPr>
-              <a:t>Closing:</a:t>
-            </a:r>
-            <a:r>
-              <a:rPr sz="1700" b="0">
-                <a:solidFill>
-                  <a:srgbClr val="64748B"/>
-                </a:solidFill>
-              </a:rPr>
-              <a:t> the PR says “Closes #issue”, so the issue moves to Done on merge.</a:t>
+              <a:t>Backlog: weekly stats Cloud Function, find a partner (sessions).</a:t>
             </a:r>
           </a:p>
         </p:txBody>

</xml_diff>

<commit_message>
docs: remove report pictures and the presentation update
</commit_message>
<xml_diff>
--- a/docs/presentation/GymBuddy_Lab1_Presentation.pptx
+++ b/docs/presentation/GymBuddy_Lab1_Presentation.pptx
@@ -18,8 +18,6 @@
     <p:sldId id="266" r:id="rId17"/>
     <p:sldId id="267" r:id="rId18"/>
     <p:sldId id="268" r:id="rId19"/>
-    <p:sldId id="269" r:id="rId20"/>
-    <p:sldId id="270" r:id="rId21"/>
   </p:sldIdLst>
   <p:sldSz cx="12191695" cy="6858000" type="screen4x3"/>
   <p:notesSz cx="6858000" cy="9144000"/>
@@ -3376,517 +3374,6 @@
                   <a:srgbClr val="FFFFFF"/>
                 </a:solidFill>
               </a:rPr>
-              <a:t>Sprint 1 backlog</a:t>
-            </a:r>
-          </a:p>
-          <a:p>
-            <a:pPr algn="l"/>
-            <a:r>
-              <a:rPr sz="1500" b="0">
-                <a:solidFill>
-                  <a:srgbClr val="FDBA74"/>
-                </a:solidFill>
-              </a:rPr>
-              <a:t>Each story has acceptance criteria and an assignee</a:t>
-            </a:r>
-          </a:p>
-        </p:txBody>
-      </p:sp>
-      <p:sp>
-        <p:nvSpPr>
-          <p:cNvPr id="3" name="Rectangle 2"/>
-          <p:cNvSpPr/>
-          <p:nvPr/>
-        </p:nvSpPr>
-        <p:spPr>
-          <a:xfrm>
-            <a:off x="0" y="1097280"/>
-            <a:ext cx="12191695" cy="64008"/>
-          </a:xfrm>
-          <a:prstGeom prst="rect">
-            <a:avLst/>
-          </a:prstGeom>
-          <a:solidFill>
-            <a:srgbClr val="F97316"/>
-          </a:solidFill>
-          <a:ln>
-            <a:noFill/>
-          </a:ln>
-          <a:effectLst/>
-        </p:spPr>
-        <p:style>
-          <a:lnRef idx="1">
-            <a:schemeClr val="accent1"/>
-          </a:lnRef>
-          <a:fillRef idx="3">
-            <a:schemeClr val="accent1"/>
-          </a:fillRef>
-          <a:effectRef idx="2">
-            <a:schemeClr val="accent1"/>
-          </a:effectRef>
-          <a:fontRef idx="minor">
-            <a:schemeClr val="lt1"/>
-          </a:fontRef>
-        </p:style>
-        <p:txBody>
-          <a:bodyPr rtlCol="0" anchor="ctr"/>
-          <a:lstStyle/>
-          <a:p>
-            <a:pPr algn="ctr"/>
-          </a:p>
-        </p:txBody>
-      </p:sp>
-      <p:graphicFrame>
-        <p:nvGraphicFramePr>
-          <p:cNvPr id="4" name="Table 3"/>
-          <p:cNvGraphicFramePr>
-            <a:graphicFrameLocks noGrp="1"/>
-          </p:cNvGraphicFramePr>
-          <p:nvPr/>
-        </p:nvGraphicFramePr>
-        <p:xfrm>
-          <a:off x="640080" y="1645920"/>
-          <a:ext cx="10881360" cy="3657600"/>
-        </p:xfrm>
-        <a:graphic>
-          <a:graphicData uri="http://schemas.openxmlformats.org/drawingml/2006/table">
-            <a:tbl>
-              <a:tblPr firstRow="1" bandRow="1">
-                <a:tableStyleId>{5C22544A-7EE6-4342-B048-85BDC9FD1C3A}</a:tableStyleId>
-              </a:tblPr>
-              <a:tblGrid>
-                <a:gridCol w="6035040"/>
-                <a:gridCol w="3566160"/>
-                <a:gridCol w="1280160"/>
-              </a:tblGrid>
-              <a:tr h="731520">
-                <a:tc>
-                  <a:txBody>
-                    <a:bodyPr/>
-                    <a:lstStyle/>
-                    <a:p>
-                      <a:r>
-                        <a:rPr sz="1600" b="1">
-                          <a:solidFill>
-                            <a:srgbClr val="FFFFFF"/>
-                          </a:solidFill>
-                        </a:rPr>
-                        <a:t>User story</a:t>
-                      </a:r>
-                    </a:p>
-                  </a:txBody>
-                  <a:tcPr>
-                    <a:solidFill>
-                      <a:srgbClr val="111827"/>
-                    </a:solidFill>
-                  </a:tcPr>
-                </a:tc>
-                <a:tc>
-                  <a:txBody>
-                    <a:bodyPr/>
-                    <a:lstStyle/>
-                    <a:p>
-                      <a:r>
-                        <a:rPr sz="1600" b="1">
-                          <a:solidFill>
-                            <a:srgbClr val="FFFFFF"/>
-                          </a:solidFill>
-                        </a:rPr>
-                        <a:t>Labels</a:t>
-                      </a:r>
-                    </a:p>
-                  </a:txBody>
-                  <a:tcPr>
-                    <a:solidFill>
-                      <a:srgbClr val="111827"/>
-                    </a:solidFill>
-                  </a:tcPr>
-                </a:tc>
-                <a:tc>
-                  <a:txBody>
-                    <a:bodyPr/>
-                    <a:lstStyle/>
-                    <a:p>
-                      <a:r>
-                        <a:rPr sz="1600" b="1">
-                          <a:solidFill>
-                            <a:srgbClr val="FFFFFF"/>
-                          </a:solidFill>
-                        </a:rPr>
-                        <a:t>Assignee</a:t>
-                      </a:r>
-                    </a:p>
-                  </a:txBody>
-                  <a:tcPr>
-                    <a:solidFill>
-                      <a:srgbClr val="111827"/>
-                    </a:solidFill>
-                  </a:tcPr>
-                </a:tc>
-              </a:tr>
-              <a:tr h="731520">
-                <a:tc>
-                  <a:txBody>
-                    <a:bodyPr/>
-                    <a:lstStyle/>
-                    <a:p>
-                      <a:r>
-                        <a:rPr sz="1600" b="0">
-                          <a:solidFill>
-                            <a:srgbClr val="0F172A"/>
-                          </a:solidFill>
-                        </a:rPr>
-                        <a:t>As a gym-goer, I want to register and log in with email and password</a:t>
-                      </a:r>
-                    </a:p>
-                  </a:txBody>
-                  <a:tcPr>
-                    <a:solidFill>
-                      <a:srgbClr val="F1F5F9"/>
-                    </a:solidFill>
-                  </a:tcPr>
-                </a:tc>
-                <a:tc>
-                  <a:txBody>
-                    <a:bodyPr/>
-                    <a:lstStyle/>
-                    <a:p>
-                      <a:r>
-                        <a:rPr sz="1600" b="0">
-                          <a:solidFill>
-                            <a:srgbClr val="0F172A"/>
-                          </a:solidFill>
-                        </a:rPr>
-                        <a:t>user-story · android · firebase</a:t>
-                      </a:r>
-                    </a:p>
-                  </a:txBody>
-                  <a:tcPr>
-                    <a:solidFill>
-                      <a:srgbClr val="F1F5F9"/>
-                    </a:solidFill>
-                  </a:tcPr>
-                </a:tc>
-                <a:tc>
-                  <a:txBody>
-                    <a:bodyPr/>
-                    <a:lstStyle/>
-                    <a:p>
-                      <a:r>
-                        <a:rPr sz="1600" b="0">
-                          <a:solidFill>
-                            <a:srgbClr val="0F172A"/>
-                          </a:solidFill>
-                        </a:rPr>
-                        <a:t>Ozodbek</a:t>
-                      </a:r>
-                    </a:p>
-                  </a:txBody>
-                  <a:tcPr>
-                    <a:solidFill>
-                      <a:srgbClr val="F1F5F9"/>
-                    </a:solidFill>
-                  </a:tcPr>
-                </a:tc>
-              </a:tr>
-              <a:tr h="731520">
-                <a:tc>
-                  <a:txBody>
-                    <a:bodyPr/>
-                    <a:lstStyle/>
-                    <a:p>
-                      <a:r>
-                        <a:rPr sz="1600" b="0">
-                          <a:solidFill>
-                            <a:srgbClr val="0F172A"/>
-                          </a:solidFill>
-                        </a:rPr>
-                        <a:t>As a gym-goer, I want to see a list of my workouts</a:t>
-                      </a:r>
-                    </a:p>
-                  </a:txBody>
-                  <a:tcPr>
-                    <a:solidFill>
-                      <a:srgbClr val="FFFFFF"/>
-                    </a:solidFill>
-                  </a:tcPr>
-                </a:tc>
-                <a:tc>
-                  <a:txBody>
-                    <a:bodyPr/>
-                    <a:lstStyle/>
-                    <a:p>
-                      <a:r>
-                        <a:rPr sz="1600" b="0">
-                          <a:solidFill>
-                            <a:srgbClr val="0F172A"/>
-                          </a:solidFill>
-                        </a:rPr>
-                        <a:t>user-story · android · ui</a:t>
-                      </a:r>
-                    </a:p>
-                  </a:txBody>
-                  <a:tcPr>
-                    <a:solidFill>
-                      <a:srgbClr val="FFFFFF"/>
-                    </a:solidFill>
-                  </a:tcPr>
-                </a:tc>
-                <a:tc>
-                  <a:txBody>
-                    <a:bodyPr/>
-                    <a:lstStyle/>
-                    <a:p>
-                      <a:r>
-                        <a:rPr sz="1600" b="0">
-                          <a:solidFill>
-                            <a:srgbClr val="0F172A"/>
-                          </a:solidFill>
-                        </a:rPr>
-                        <a:t>Elturan</a:t>
-                      </a:r>
-                    </a:p>
-                  </a:txBody>
-                  <a:tcPr>
-                    <a:solidFill>
-                      <a:srgbClr val="FFFFFF"/>
-                    </a:solidFill>
-                  </a:tcPr>
-                </a:tc>
-              </a:tr>
-              <a:tr h="731520">
-                <a:tc>
-                  <a:txBody>
-                    <a:bodyPr/>
-                    <a:lstStyle/>
-                    <a:p>
-                      <a:r>
-                        <a:rPr sz="1600" b="0">
-                          <a:solidFill>
-                            <a:srgbClr val="0F172A"/>
-                          </a:solidFill>
-                        </a:rPr>
-                        <a:t>As a gym-goer, I want to add a workout</a:t>
-                      </a:r>
-                    </a:p>
-                  </a:txBody>
-                  <a:tcPr>
-                    <a:solidFill>
-                      <a:srgbClr val="F1F5F9"/>
-                    </a:solidFill>
-                  </a:tcPr>
-                </a:tc>
-                <a:tc>
-                  <a:txBody>
-                    <a:bodyPr/>
-                    <a:lstStyle/>
-                    <a:p>
-                      <a:r>
-                        <a:rPr sz="1600" b="0">
-                          <a:solidFill>
-                            <a:srgbClr val="0F172A"/>
-                          </a:solidFill>
-                        </a:rPr>
-                        <a:t>user-story · android · firebase</a:t>
-                      </a:r>
-                    </a:p>
-                  </a:txBody>
-                  <a:tcPr>
-                    <a:solidFill>
-                      <a:srgbClr val="F1F5F9"/>
-                    </a:solidFill>
-                  </a:tcPr>
-                </a:tc>
-                <a:tc>
-                  <a:txBody>
-                    <a:bodyPr/>
-                    <a:lstStyle/>
-                    <a:p>
-                      <a:r>
-                        <a:rPr sz="1600" b="0">
-                          <a:solidFill>
-                            <a:srgbClr val="0F172A"/>
-                          </a:solidFill>
-                        </a:rPr>
-                        <a:t>Aida</a:t>
-                      </a:r>
-                    </a:p>
-                  </a:txBody>
-                  <a:tcPr>
-                    <a:solidFill>
-                      <a:srgbClr val="F1F5F9"/>
-                    </a:solidFill>
-                  </a:tcPr>
-                </a:tc>
-              </a:tr>
-              <a:tr h="731520">
-                <a:tc>
-                  <a:txBody>
-                    <a:bodyPr/>
-                    <a:lstStyle/>
-                    <a:p>
-                      <a:r>
-                        <a:rPr sz="1600" b="0">
-                          <a:solidFill>
-                            <a:srgbClr val="0F172A"/>
-                          </a:solidFill>
-                        </a:rPr>
-                        <a:t>As a gym-goer, I want to edit or delete a workout</a:t>
-                      </a:r>
-                    </a:p>
-                  </a:txBody>
-                  <a:tcPr>
-                    <a:solidFill>
-                      <a:srgbClr val="FFFFFF"/>
-                    </a:solidFill>
-                  </a:tcPr>
-                </a:tc>
-                <a:tc>
-                  <a:txBody>
-                    <a:bodyPr/>
-                    <a:lstStyle/>
-                    <a:p>
-                      <a:r>
-                        <a:rPr sz="1600" b="0">
-                          <a:solidFill>
-                            <a:srgbClr val="0F172A"/>
-                          </a:solidFill>
-                        </a:rPr>
-                        <a:t>user-story · android · firebase</a:t>
-                      </a:r>
-                    </a:p>
-                  </a:txBody>
-                  <a:tcPr>
-                    <a:solidFill>
-                      <a:srgbClr val="FFFFFF"/>
-                    </a:solidFill>
-                  </a:tcPr>
-                </a:tc>
-                <a:tc>
-                  <a:txBody>
-                    <a:bodyPr/>
-                    <a:lstStyle/>
-                    <a:p>
-                      <a:r>
-                        <a:rPr sz="1600" b="0">
-                          <a:solidFill>
-                            <a:srgbClr val="0F172A"/>
-                          </a:solidFill>
-                        </a:rPr>
-                        <a:t>Elturan</a:t>
-                      </a:r>
-                    </a:p>
-                  </a:txBody>
-                  <a:tcPr>
-                    <a:solidFill>
-                      <a:srgbClr val="FFFFFF"/>
-                    </a:solidFill>
-                  </a:tcPr>
-                </a:tc>
-              </a:tr>
-            </a:tbl>
-          </a:graphicData>
-        </a:graphic>
-      </p:graphicFrame>
-      <p:sp>
-        <p:nvSpPr>
-          <p:cNvPr id="5" name="TextBox 4"/>
-          <p:cNvSpPr txBox="1"/>
-          <p:nvPr/>
-        </p:nvSpPr>
-        <p:spPr>
-          <a:xfrm>
-            <a:off x="640080" y="5486400"/>
-            <a:ext cx="10881360" cy="914400"/>
-          </a:xfrm>
-          <a:prstGeom prst="rect">
-            <a:avLst/>
-          </a:prstGeom>
-          <a:noFill/>
-        </p:spPr>
-        <p:txBody>
-          <a:bodyPr wrap="square">
-            <a:spAutoFit/>
-          </a:bodyPr>
-          <a:lstStyle/>
-          <a:p>
-            <a:pPr algn="l"/>
-            <a:r>
-              <a:rPr sz="1700" b="0">
-                <a:solidFill>
-                  <a:srgbClr val="64748B"/>
-                </a:solidFill>
-              </a:rPr>
-              <a:t>Backlog: weekly stats Cloud Function, find a partner (sessions).</a:t>
-            </a:r>
-          </a:p>
-        </p:txBody>
-      </p:sp>
-    </p:spTree>
-  </p:cSld>
-  <p:clrMapOvr>
-    <a:masterClrMapping/>
-  </p:clrMapOvr>
-</p:sld>
-</file>
-
-<file path=ppt/slides/slide11.xml><?xml version="1.0" encoding="utf-8"?>
-<p:sld xmlns:a="http://schemas.openxmlformats.org/drawingml/2006/main" xmlns:p="http://schemas.openxmlformats.org/presentationml/2006/main" xmlns:r="http://schemas.openxmlformats.org/officeDocument/2006/relationships">
-  <p:cSld>
-    <p:spTree>
-      <p:nvGrpSpPr>
-        <p:cNvPr id="1" name=""/>
-        <p:cNvGrpSpPr/>
-        <p:nvPr/>
-      </p:nvGrpSpPr>
-      <p:grpSpPr/>
-      <p:sp>
-        <p:nvSpPr>
-          <p:cNvPr id="2" name="Rectangle 1"/>
-          <p:cNvSpPr/>
-          <p:nvPr/>
-        </p:nvSpPr>
-        <p:spPr>
-          <a:xfrm>
-            <a:off x="0" y="0"/>
-            <a:ext cx="12191695" cy="1097280"/>
-          </a:xfrm>
-          <a:prstGeom prst="rect">
-            <a:avLst/>
-          </a:prstGeom>
-          <a:solidFill>
-            <a:srgbClr val="111827"/>
-          </a:solidFill>
-          <a:ln>
-            <a:noFill/>
-          </a:ln>
-          <a:effectLst/>
-        </p:spPr>
-        <p:style>
-          <a:lnRef idx="1">
-            <a:schemeClr val="accent1"/>
-          </a:lnRef>
-          <a:fillRef idx="3">
-            <a:schemeClr val="accent1"/>
-          </a:fillRef>
-          <a:effectRef idx="2">
-            <a:schemeClr val="accent1"/>
-          </a:effectRef>
-          <a:fontRef idx="minor">
-            <a:schemeClr val="lt1"/>
-          </a:fontRef>
-        </p:style>
-        <p:txBody>
-          <a:bodyPr rtlCol="0" anchor="ctr" wrap="square" lIns="457200" rIns="457200" tIns="73152" bIns="73152"/>
-          <a:lstStyle/>
-          <a:p>
-            <a:pPr algn="ctr"/>
-            <a:r>
-              <a:rPr sz="3200" b="1">
-                <a:solidFill>
-                  <a:srgbClr val="FFFFFF"/>
-                </a:solidFill>
-              </a:rPr>
               <a:t>Team and roles</a:t>
             </a:r>
           </a:p>
@@ -4274,7 +3761,7 @@
 </p:sld>
 </file>
 
-<file path=ppt/slides/slide12.xml><?xml version="1.0" encoding="utf-8"?>
+<file path=ppt/slides/slide11.xml><?xml version="1.0" encoding="utf-8"?>
 <p:sld xmlns:a="http://schemas.openxmlformats.org/drawingml/2006/main" xmlns:p="http://schemas.openxmlformats.org/presentationml/2006/main" xmlns:r="http://schemas.openxmlformats.org/officeDocument/2006/relationships">
   <p:cSld>
     <p:spTree>
@@ -4858,7 +4345,7 @@
 </p:sld>
 </file>
 
-<file path=ppt/slides/slide13.xml><?xml version="1.0" encoding="utf-8"?>
+<file path=ppt/slides/slide12.xml><?xml version="1.0" encoding="utf-8"?>
 <p:sld xmlns:a="http://schemas.openxmlformats.org/drawingml/2006/main" xmlns:p="http://schemas.openxmlformats.org/presentationml/2006/main" xmlns:r="http://schemas.openxmlformats.org/officeDocument/2006/relationships">
   <p:cSld>
     <p:spTree>
@@ -5231,7 +4718,7 @@
 </p:sld>
 </file>
 
-<file path=ppt/slides/slide14.xml><?xml version="1.0" encoding="utf-8"?>
+<file path=ppt/slides/slide13.xml><?xml version="1.0" encoding="utf-8"?>
 <p:sld xmlns:a="http://schemas.openxmlformats.org/drawingml/2006/main" xmlns:p="http://schemas.openxmlformats.org/presentationml/2006/main" xmlns:r="http://schemas.openxmlformats.org/officeDocument/2006/relationships">
   <p:cSld>
     <p:spTree>
@@ -5288,7 +4775,7 @@
                   <a:srgbClr val="FFFFFF"/>
                 </a:solidFill>
               </a:rPr>
-              <a:t>Where we are now</a:t>
+              <a:t>What's next</a:t>
             </a:r>
           </a:p>
           <a:p>
@@ -5299,7 +4786,7 @@
                   <a:srgbClr val="FDBA74"/>
                 </a:solidFill>
               </a:rPr>
-              <a:t>Lab 1 checklist: done and still to do</a:t>
+              <a:t>Lab 1 delivers the walking skeleton</a:t>
             </a:r>
           </a:p>
         </p:txBody>
@@ -5348,296 +4835,187 @@
           </a:p>
         </p:txBody>
       </p:sp>
-      <p:graphicFrame>
-        <p:nvGraphicFramePr>
-          <p:cNvPr id="4" name="Table 3"/>
-          <p:cNvGraphicFramePr>
-            <a:graphicFrameLocks noGrp="1"/>
-          </p:cNvGraphicFramePr>
+      <p:sp>
+        <p:nvSpPr>
+          <p:cNvPr id="4" name="TextBox 3"/>
+          <p:cNvSpPr txBox="1"/>
           <p:nvPr/>
-        </p:nvGraphicFramePr>
-        <p:xfrm>
-          <a:off x="640080" y="1645920"/>
-          <a:ext cx="10881360" cy="4663440"/>
-        </p:xfrm>
-        <a:graphic>
-          <a:graphicData uri="http://schemas.openxmlformats.org/drawingml/2006/table">
-            <a:tbl>
-              <a:tblPr firstRow="1" bandRow="1">
-                <a:tableStyleId>{5C22544A-7EE6-4342-B048-85BDC9FD1C3A}</a:tableStyleId>
-              </a:tblPr>
-              <a:tblGrid>
-                <a:gridCol w="5440680"/>
-                <a:gridCol w="5440680"/>
-              </a:tblGrid>
-              <a:tr h="777240">
-                <a:tc>
-                  <a:txBody>
-                    <a:bodyPr/>
-                    <a:lstStyle/>
-                    <a:p>
-                      <a:r>
-                        <a:rPr sz="1500" b="1">
-                          <a:solidFill>
-                            <a:srgbClr val="FFFFFF"/>
-                          </a:solidFill>
-                        </a:rPr>
-                        <a:t>Done</a:t>
-                      </a:r>
-                    </a:p>
-                  </a:txBody>
-                  <a:tcPr>
-                    <a:solidFill>
-                      <a:srgbClr val="111827"/>
-                    </a:solidFill>
-                  </a:tcPr>
-                </a:tc>
-                <a:tc>
-                  <a:txBody>
-                    <a:bodyPr/>
-                    <a:lstStyle/>
-                    <a:p>
-                      <a:r>
-                        <a:rPr sz="1500" b="1">
-                          <a:solidFill>
-                            <a:srgbClr val="FFFFFF"/>
-                          </a:solidFill>
-                        </a:rPr>
-                        <a:t>Still to do</a:t>
-                      </a:r>
-                    </a:p>
-                  </a:txBody>
-                  <a:tcPr>
-                    <a:solidFill>
-                      <a:srgbClr val="111827"/>
-                    </a:solidFill>
-                  </a:tcPr>
-                </a:tc>
-              </a:tr>
-              <a:tr h="777240">
-                <a:tc>
-                  <a:txBody>
-                    <a:bodyPr/>
-                    <a:lstStyle/>
-                    <a:p>
-                      <a:r>
-                        <a:rPr sz="1500" b="0">
-                          <a:solidFill>
-                            <a:srgbClr val="0F172A"/>
-                          </a:solidFill>
-                        </a:rPr>
-                        <a:t>Problem statement, MVP, data model and architecture in the README</a:t>
-                      </a:r>
-                    </a:p>
-                  </a:txBody>
-                  <a:tcPr>
-                    <a:solidFill>
-                      <a:srgbClr val="F1F5F9"/>
-                    </a:solidFill>
-                  </a:tcPr>
-                </a:tc>
-                <a:tc>
-                  <a:txBody>
-                    <a:bodyPr/>
-                    <a:lstStyle/>
-                    <a:p>
-                      <a:r>
-                        <a:rPr sz="1500" b="0">
-                          <a:solidFill>
-                            <a:srgbClr val="0F172A"/>
-                          </a:solidFill>
-                        </a:rPr>
-                        <a:t>Sprint board with 5 columns and issues in the right columns</a:t>
-                      </a:r>
-                    </a:p>
-                  </a:txBody>
-                  <a:tcPr>
-                    <a:solidFill>
-                      <a:srgbClr val="F1F5F9"/>
-                    </a:solidFill>
-                  </a:tcPr>
-                </a:tc>
-              </a:tr>
-              <a:tr h="777240">
-                <a:tc>
-                  <a:txBody>
-                    <a:bodyPr/>
-                    <a:lstStyle/>
-                    <a:p>
-                      <a:r>
-                        <a:rPr sz="1500" b="0">
-                          <a:solidFill>
-                            <a:srgbClr val="0F172A"/>
-                          </a:solidFill>
-                        </a:rPr>
-                        <a:t>Public repo, first push to main, PR template</a:t>
-                      </a:r>
-                    </a:p>
-                  </a:txBody>
-                  <a:tcPr>
-                    <a:solidFill>
-                      <a:srgbClr val="FFFFFF"/>
-                    </a:solidFill>
-                  </a:tcPr>
-                </a:tc>
-                <a:tc>
-                  <a:txBody>
-                    <a:bodyPr/>
-                    <a:lstStyle/>
-                    <a:p>
-                      <a:r>
-                        <a:rPr sz="1500" b="0">
-                          <a:solidFill>
-                            <a:srgbClr val="0F172A"/>
-                          </a:solidFill>
-                        </a:rPr>
-                        <a:t>Ruleset protecting main (PR required, no force push)</a:t>
-                      </a:r>
-                    </a:p>
-                  </a:txBody>
-                  <a:tcPr>
-                    <a:solidFill>
-                      <a:srgbClr val="FFFFFF"/>
-                    </a:solidFill>
-                  </a:tcPr>
-                </a:tc>
-              </a:tr>
-              <a:tr h="777240">
-                <a:tc>
-                  <a:txBody>
-                    <a:bodyPr/>
-                    <a:lstStyle/>
-                    <a:p>
-                      <a:r>
-                        <a:rPr sz="1500" b="0">
-                          <a:solidFill>
-                            <a:srgbClr val="0F172A"/>
-                          </a:solidFill>
-                        </a:rPr>
-                        <a:t>Labels and 6 issues with user story and acceptance criteria</a:t>
-                      </a:r>
-                    </a:p>
-                  </a:txBody>
-                  <a:tcPr>
-                    <a:solidFill>
-                      <a:srgbClr val="F1F5F9"/>
-                    </a:solidFill>
-                  </a:tcPr>
-                </a:tc>
-                <a:tc>
-                  <a:txBody>
-                    <a:bodyPr/>
-                    <a:lstStyle/>
-                    <a:p>
-                      <a:r>
-                        <a:rPr sz="1500" b="0">
-                          <a:solidFill>
-                            <a:srgbClr val="0F172A"/>
-                          </a:solidFill>
-                        </a:rPr>
-                        <a:t>Assignees on every Sprint 1 issue (teammates must accept their invitations)</a:t>
-                      </a:r>
-                    </a:p>
-                  </a:txBody>
-                  <a:tcPr>
-                    <a:solidFill>
-                      <a:srgbClr val="F1F5F9"/>
-                    </a:solidFill>
-                  </a:tcPr>
-                </a:tc>
-              </a:tr>
-              <a:tr h="777240">
-                <a:tc>
-                  <a:txBody>
-                    <a:bodyPr/>
-                    <a:lstStyle/>
-                    <a:p>
-                      <a:r>
-                        <a:rPr sz="1500" b="0">
-                          <a:solidFill>
-                            <a:srgbClr val="0F172A"/>
-                          </a:solidFill>
-                        </a:rPr>
-                        <a:t>Authentication code: repository, validator, ViewModel, screens, navigation</a:t>
-                      </a:r>
-                    </a:p>
-                  </a:txBody>
-                  <a:tcPr>
-                    <a:solidFill>
-                      <a:srgbClr val="FFFFFF"/>
-                    </a:solidFill>
-                  </a:tcPr>
-                </a:tc>
-                <a:tc>
-                  <a:txBody>
-                    <a:bodyPr/>
-                    <a:lstStyle/>
-                    <a:p>
-                      <a:r>
-                        <a:rPr sz="1500" b="0">
-                          <a:solidFill>
-                            <a:srgbClr val="0F172A"/>
-                          </a:solidFill>
-                        </a:rPr>
-                        <a:t>Firebase project, google-services.json, Email/Password sign-in, test on the emulator</a:t>
-                      </a:r>
-                    </a:p>
-                  </a:txBody>
-                  <a:tcPr>
-                    <a:solidFill>
-                      <a:srgbClr val="FFFFFF"/>
-                    </a:solidFill>
-                  </a:tcPr>
-                </a:tc>
-              </a:tr>
-              <a:tr h="777240">
-                <a:tc>
-                  <a:txBody>
-                    <a:bodyPr/>
-                    <a:lstStyle/>
-                    <a:p>
-                      <a:r>
-                        <a:rPr sz="1500" b="0">
-                          <a:solidFill>
-                            <a:srgbClr val="0F172A"/>
-                          </a:solidFill>
-                        </a:rPr>
-                        <a:t>PR #7 merged (project overview)</a:t>
-                      </a:r>
-                    </a:p>
-                  </a:txBody>
-                  <a:tcPr>
-                    <a:solidFill>
-                      <a:srgbClr val="F1F5F9"/>
-                    </a:solidFill>
-                  </a:tcPr>
-                </a:tc>
-                <a:tc>
-                  <a:txBody>
-                    <a:bodyPr/>
-                    <a:lstStyle/>
-                    <a:p>
-                      <a:r>
-                        <a:rPr sz="1500" b="0">
-                          <a:solidFill>
-                            <a:srgbClr val="0F172A"/>
-                          </a:solidFill>
-                        </a:rPr>
-                        <a:t>At least two merged PRs, each with a teammate review; Retro – Lab 1 issue</a:t>
-                      </a:r>
-                    </a:p>
-                  </a:txBody>
-                  <a:tcPr>
-                    <a:solidFill>
-                      <a:srgbClr val="F1F5F9"/>
-                    </a:solidFill>
-                  </a:tcPr>
-                </a:tc>
-              </a:tr>
-            </a:tbl>
-          </a:graphicData>
-        </a:graphic>
-      </p:graphicFrame>
+        </p:nvSpPr>
+        <p:spPr>
+          <a:xfrm>
+            <a:off x="640080" y="1645920"/>
+            <a:ext cx="10881360" cy="3657600"/>
+          </a:xfrm>
+          <a:prstGeom prst="rect">
+            <a:avLst/>
+          </a:prstGeom>
+          <a:noFill/>
+        </p:spPr>
+        <p:txBody>
+          <a:bodyPr wrap="square">
+            <a:spAutoFit/>
+          </a:bodyPr>
+          <a:lstStyle/>
+          <a:p>
+            <a:pPr algn="l">
+              <a:spcAft>
+                <a:spcPts val="1000"/>
+              </a:spcAft>
+            </a:pPr>
+            <a:r>
+              <a:rPr sz="2200" b="1">
+                <a:solidFill>
+                  <a:srgbClr val="F97316"/>
+                </a:solidFill>
+              </a:rPr>
+              <a:t>•  </a:t>
+            </a:r>
+            <a:r>
+              <a:rPr sz="2200" b="1">
+                <a:solidFill>
+                  <a:srgbClr val="0F172A"/>
+                </a:solidFill>
+              </a:rPr>
+              <a:t>Lab 1:</a:t>
+            </a:r>
+            <a:r>
+              <a:rPr sz="2200" b="0">
+                <a:solidFill>
+                  <a:srgbClr val="64748B"/>
+                </a:solidFill>
+              </a:rPr>
+              <a:t> repo, board, Firebase project, register / login / logout / auto-login.</a:t>
+            </a:r>
+          </a:p>
+          <a:p>
+            <a:pPr algn="l">
+              <a:spcAft>
+                <a:spcPts val="1000"/>
+              </a:spcAft>
+            </a:pPr>
+            <a:r>
+              <a:rPr sz="2200" b="1">
+                <a:solidFill>
+                  <a:srgbClr val="F97316"/>
+                </a:solidFill>
+              </a:rPr>
+              <a:t>•  </a:t>
+            </a:r>
+            <a:r>
+              <a:rPr sz="2200" b="1">
+                <a:solidFill>
+                  <a:srgbClr val="0F172A"/>
+                </a:solidFill>
+              </a:rPr>
+              <a:t>Lab 2:</a:t>
+            </a:r>
+            <a:r>
+              <a:rPr sz="2200" b="0">
+                <a:solidFill>
+                  <a:srgbClr val="64748B"/>
+                </a:solidFill>
+              </a:rPr>
+              <a:t> workouts in Firestore – list, add, edit, delete – and Security Rules.</a:t>
+            </a:r>
+          </a:p>
+          <a:p>
+            <a:pPr algn="l">
+              <a:spcAft>
+                <a:spcPts val="1000"/>
+              </a:spcAft>
+            </a:pPr>
+            <a:r>
+              <a:rPr sz="2200" b="1">
+                <a:solidFill>
+                  <a:srgbClr val="F97316"/>
+                </a:solidFill>
+              </a:rPr>
+              <a:t>•  </a:t>
+            </a:r>
+            <a:r>
+              <a:rPr sz="2200" b="1">
+                <a:solidFill>
+                  <a:srgbClr val="0F172A"/>
+                </a:solidFill>
+              </a:rPr>
+              <a:t>Lab 3:</a:t>
+            </a:r>
+            <a:r>
+              <a:rPr sz="2200" b="0">
+                <a:solidFill>
+                  <a:srgbClr val="64748B"/>
+                </a:solidFill>
+              </a:rPr>
+              <a:t> Cloud Function for weekly stats, unit tests for the validator.</a:t>
+            </a:r>
+          </a:p>
+          <a:p>
+            <a:pPr algn="l">
+              <a:spcAft>
+                <a:spcPts val="1000"/>
+              </a:spcAft>
+            </a:pPr>
+            <a:r>
+              <a:rPr sz="2200" b="1">
+                <a:solidFill>
+                  <a:srgbClr val="F97316"/>
+                </a:solidFill>
+              </a:rPr>
+              <a:t>•  </a:t>
+            </a:r>
+            <a:r>
+              <a:rPr sz="2200" b="1">
+                <a:solidFill>
+                  <a:srgbClr val="0F172A"/>
+                </a:solidFill>
+              </a:rPr>
+              <a:t>Retro – Lab 1:</a:t>
+            </a:r>
+            <a:r>
+              <a:rPr sz="2200" b="0">
+                <a:solidFill>
+                  <a:srgbClr val="64748B"/>
+                </a:solidFill>
+              </a:rPr>
+              <a:t> one issue, every member comments: went well / did not go well / we will change.</a:t>
+            </a:r>
+          </a:p>
+        </p:txBody>
+      </p:sp>
+      <p:sp>
+        <p:nvSpPr>
+          <p:cNvPr id="5" name="TextBox 4"/>
+          <p:cNvSpPr txBox="1"/>
+          <p:nvPr/>
+        </p:nvSpPr>
+        <p:spPr>
+          <a:xfrm>
+            <a:off x="640080" y="5486400"/>
+            <a:ext cx="10881360" cy="914400"/>
+          </a:xfrm>
+          <a:prstGeom prst="rect">
+            <a:avLst/>
+          </a:prstGeom>
+          <a:noFill/>
+        </p:spPr>
+        <p:txBody>
+          <a:bodyPr wrap="none">
+            <a:spAutoFit/>
+          </a:bodyPr>
+          <a:lstStyle/>
+          <a:p>
+            <a:pPr algn="l"/>
+            <a:r>
+              <a:rPr sz="3000" b="1">
+                <a:solidFill>
+                  <a:srgbClr val="C2410C"/>
+                </a:solidFill>
+              </a:rPr>
+              <a:t>Thank you – questions?</a:t>
+            </a:r>
+          </a:p>
+        </p:txBody>
+      </p:sp>
     </p:spTree>
   </p:cSld>
   <p:clrMapOvr>
@@ -5646,7 +5024,7 @@
 </p:sld>
 </file>
 
-<file path=ppt/slides/slide15.xml><?xml version="1.0" encoding="utf-8"?>
+<file path=ppt/slides/slide2.xml><?xml version="1.0" encoding="utf-8"?>
 <p:sld xmlns:a="http://schemas.openxmlformats.org/drawingml/2006/main" xmlns:p="http://schemas.openxmlformats.org/presentationml/2006/main" xmlns:r="http://schemas.openxmlformats.org/officeDocument/2006/relationships">
   <p:cSld>
     <p:spTree>
@@ -5703,7 +5081,7 @@
                   <a:srgbClr val="FFFFFF"/>
                 </a:solidFill>
               </a:rPr>
-              <a:t>What's next</a:t>
+              <a:t>What is GymBuddy?</a:t>
             </a:r>
           </a:p>
           <a:p>
@@ -5714,7 +5092,7 @@
                   <a:srgbClr val="FDBA74"/>
                 </a:solidFill>
               </a:rPr>
-              <a:t>Lab 1 delivers the walking skeleton</a:t>
+              <a:t>An Android app backed by the cloud</a:t>
             </a:r>
           </a:p>
         </p:txBody>
@@ -5771,8 +5149,8 @@
         </p:nvSpPr>
         <p:spPr>
           <a:xfrm>
-            <a:off x="640080" y="1645920"/>
-            <a:ext cx="10881360" cy="3657600"/>
+            <a:off x="640080" y="1554480"/>
+            <a:ext cx="6583680" cy="4572000"/>
           </a:xfrm>
           <a:prstGeom prst="rect">
             <a:avLst/>
@@ -5804,7 +5182,7 @@
                   <a:srgbClr val="0F172A"/>
                 </a:solidFill>
               </a:rPr>
-              <a:t>Lab 1:</a:t>
+              <a:t>Gym + Buddy:</a:t>
             </a:r>
             <a:r>
               <a:rPr sz="2200" b="0">
@@ -5812,7 +5190,7 @@
                   <a:srgbClr val="64748B"/>
                 </a:solidFill>
               </a:rPr>
-              <a:t> repo, board, Firebase project, register / login / logout / auto-login.</a:t>
+              <a:t> your workout log and your training partner finder in one app.</a:t>
             </a:r>
           </a:p>
           <a:p>
@@ -5835,7 +5213,7 @@
                   <a:srgbClr val="0F172A"/>
                 </a:solidFill>
               </a:rPr>
-              <a:t>Lab 2:</a:t>
+              <a:t>Log:</a:t>
             </a:r>
             <a:r>
               <a:rPr sz="2200" b="0">
@@ -5843,7 +5221,7 @@
                   <a:srgbClr val="64748B"/>
                 </a:solidFill>
               </a:rPr>
-              <a:t> workouts in Firestore – list, add, edit, delete – and Security Rules.</a:t>
+              <a:t> record each workout (type, duration, notes) and see your history and weekly progress.</a:t>
             </a:r>
           </a:p>
           <a:p>
@@ -5866,7 +5244,7 @@
                   <a:srgbClr val="0F172A"/>
                 </a:solidFill>
               </a:rPr>
-              <a:t>Lab 3:</a:t>
+              <a:t>Find:</a:t>
             </a:r>
             <a:r>
               <a:rPr sz="2200" b="0">
@@ -5874,7 +5252,7 @@
                   <a:srgbClr val="64748B"/>
                 </a:solidFill>
               </a:rPr>
-              <a:t> Cloud Function for weekly stats, unit tests for the validator.</a:t>
+              <a:t> post or join open training sessions, so you never have to train alone.</a:t>
             </a:r>
           </a:p>
           <a:p>
@@ -5897,7 +5275,7 @@
                   <a:srgbClr val="0F172A"/>
                 </a:solidFill>
               </a:rPr>
-              <a:t>Retro – Lab 1:</a:t>
+              <a:t>Cloud:</a:t>
             </a:r>
             <a:r>
               <a:rPr sz="2200" b="0">
@@ -5905,41 +5283,74 @@
                   <a:srgbClr val="64748B"/>
                 </a:solidFill>
               </a:rPr>
-              <a:t> one issue, every member comments: went well / did not go well / we will change.</a:t>
-            </a:r>
-          </a:p>
-        </p:txBody>
-      </p:sp>
-      <p:sp>
-        <p:nvSpPr>
-          <p:cNvPr id="5" name="TextBox 4"/>
-          <p:cNvSpPr txBox="1"/>
+              <a:t> everything is stored in Firebase, so your data follows you to any phone.</a:t>
+            </a:r>
+          </a:p>
+        </p:txBody>
+      </p:sp>
+      <p:sp>
+        <p:nvSpPr>
+          <p:cNvPr id="5" name="Rounded Rectangle 4"/>
+          <p:cNvSpPr/>
           <p:nvPr/>
         </p:nvSpPr>
         <p:spPr>
           <a:xfrm>
-            <a:off x="640080" y="5486400"/>
-            <a:ext cx="10881360" cy="914400"/>
+            <a:off x="7589520" y="1737360"/>
+            <a:ext cx="4023360" cy="4206240"/>
           </a:xfrm>
-          <a:prstGeom prst="rect">
+          <a:prstGeom prst="roundRect">
             <a:avLst/>
           </a:prstGeom>
-          <a:noFill/>
+          <a:solidFill>
+            <a:srgbClr val="F1F5F9"/>
+          </a:solidFill>
+          <a:ln>
+            <a:noFill/>
+          </a:ln>
+          <a:effectLst/>
         </p:spPr>
-        <p:txBody>
-          <a:bodyPr wrap="none">
-            <a:spAutoFit/>
-          </a:bodyPr>
-          <a:lstStyle/>
-          <a:p>
-            <a:pPr algn="l"/>
-            <a:r>
-              <a:rPr sz="3000" b="1">
+        <p:style>
+          <a:lnRef idx="1">
+            <a:schemeClr val="accent1"/>
+          </a:lnRef>
+          <a:fillRef idx="3">
+            <a:schemeClr val="accent1"/>
+          </a:fillRef>
+          <a:effectRef idx="2">
+            <a:schemeClr val="accent1"/>
+          </a:effectRef>
+          <a:fontRef idx="minor">
+            <a:schemeClr val="lt1"/>
+          </a:fontRef>
+        </p:style>
+        <p:txBody>
+          <a:bodyPr rtlCol="0" anchor="ctr" wrap="square" lIns="274320" rIns="274320" tIns="73152" bIns="73152"/>
+          <a:lstStyle/>
+          <a:p>
+            <a:pPr algn="ctr"/>
+            <a:r>
+              <a:rPr sz="2200" b="1">
                 <a:solidFill>
                   <a:srgbClr val="C2410C"/>
                 </a:solidFill>
               </a:rPr>
-              <a:t>Thank you – questions?</a:t>
+              <a:t>Why the name?</a:t>
+            </a:r>
+          </a:p>
+          <a:p>
+            <a:pPr algn="l">
+              <a:spcBef>
+                <a:spcPts val="1000"/>
+              </a:spcBef>
+            </a:pPr>
+            <a:r>
+              <a:rPr sz="1800" b="0">
+                <a:solidFill>
+                  <a:srgbClr val="0F172A"/>
+                </a:solidFill>
+              </a:rPr>
+              <a:t>“Buddy” is the gym word for a training partner. People who train with a partner skip fewer sessions – so the name says what the app is for: staying consistent, together.</a:t>
             </a:r>
           </a:p>
         </p:txBody>
@@ -5952,7 +5363,7 @@
 </p:sld>
 </file>
 
-<file path=ppt/slides/slide2.xml><?xml version="1.0" encoding="utf-8"?>
+<file path=ppt/slides/slide3.xml><?xml version="1.0" encoding="utf-8"?>
 <p:sld xmlns:a="http://schemas.openxmlformats.org/drawingml/2006/main" xmlns:p="http://schemas.openxmlformats.org/presentationml/2006/main" xmlns:r="http://schemas.openxmlformats.org/officeDocument/2006/relationships">
   <p:cSld>
     <p:spTree>
@@ -6009,7 +5420,7 @@
                   <a:srgbClr val="FFFFFF"/>
                 </a:solidFill>
               </a:rPr>
-              <a:t>What is GymBuddy?</a:t>
+              <a:t>The problem</a:t>
             </a:r>
           </a:p>
           <a:p>
@@ -6020,7 +5431,7 @@
                   <a:srgbClr val="FDBA74"/>
                 </a:solidFill>
               </a:rPr>
-              <a:t>An Android app backed by the cloud</a:t>
+              <a:t>One sentence: who has what problem, and why it matters</a:t>
             </a:r>
           </a:p>
         </p:txBody>
@@ -6071,838 +5482,6 @@
       </p:sp>
       <p:sp>
         <p:nvSpPr>
-          <p:cNvPr id="4" name="TextBox 3"/>
-          <p:cNvSpPr txBox="1"/>
-          <p:nvPr/>
-        </p:nvSpPr>
-        <p:spPr>
-          <a:xfrm>
-            <a:off x="640080" y="1554480"/>
-            <a:ext cx="6583680" cy="4572000"/>
-          </a:xfrm>
-          <a:prstGeom prst="rect">
-            <a:avLst/>
-          </a:prstGeom>
-          <a:noFill/>
-        </p:spPr>
-        <p:txBody>
-          <a:bodyPr wrap="square">
-            <a:spAutoFit/>
-          </a:bodyPr>
-          <a:lstStyle/>
-          <a:p>
-            <a:pPr algn="l">
-              <a:spcAft>
-                <a:spcPts val="1000"/>
-              </a:spcAft>
-            </a:pPr>
-            <a:r>
-              <a:rPr sz="2200" b="1">
-                <a:solidFill>
-                  <a:srgbClr val="F97316"/>
-                </a:solidFill>
-              </a:rPr>
-              <a:t>•  </a:t>
-            </a:r>
-            <a:r>
-              <a:rPr sz="2200" b="1">
-                <a:solidFill>
-                  <a:srgbClr val="0F172A"/>
-                </a:solidFill>
-              </a:rPr>
-              <a:t>Gym + Buddy:</a:t>
-            </a:r>
-            <a:r>
-              <a:rPr sz="2200" b="0">
-                <a:solidFill>
-                  <a:srgbClr val="64748B"/>
-                </a:solidFill>
-              </a:rPr>
-              <a:t> your workout log and your training partner finder in one app.</a:t>
-            </a:r>
-          </a:p>
-          <a:p>
-            <a:pPr algn="l">
-              <a:spcAft>
-                <a:spcPts val="1000"/>
-              </a:spcAft>
-            </a:pPr>
-            <a:r>
-              <a:rPr sz="2200" b="1">
-                <a:solidFill>
-                  <a:srgbClr val="F97316"/>
-                </a:solidFill>
-              </a:rPr>
-              <a:t>•  </a:t>
-            </a:r>
-            <a:r>
-              <a:rPr sz="2200" b="1">
-                <a:solidFill>
-                  <a:srgbClr val="0F172A"/>
-                </a:solidFill>
-              </a:rPr>
-              <a:t>Log:</a:t>
-            </a:r>
-            <a:r>
-              <a:rPr sz="2200" b="0">
-                <a:solidFill>
-                  <a:srgbClr val="64748B"/>
-                </a:solidFill>
-              </a:rPr>
-              <a:t> record each workout (type, duration, notes) and see your history and weekly progress.</a:t>
-            </a:r>
-          </a:p>
-          <a:p>
-            <a:pPr algn="l">
-              <a:spcAft>
-                <a:spcPts val="1000"/>
-              </a:spcAft>
-            </a:pPr>
-            <a:r>
-              <a:rPr sz="2200" b="1">
-                <a:solidFill>
-                  <a:srgbClr val="F97316"/>
-                </a:solidFill>
-              </a:rPr>
-              <a:t>•  </a:t>
-            </a:r>
-            <a:r>
-              <a:rPr sz="2200" b="1">
-                <a:solidFill>
-                  <a:srgbClr val="0F172A"/>
-                </a:solidFill>
-              </a:rPr>
-              <a:t>Find:</a:t>
-            </a:r>
-            <a:r>
-              <a:rPr sz="2200" b="0">
-                <a:solidFill>
-                  <a:srgbClr val="64748B"/>
-                </a:solidFill>
-              </a:rPr>
-              <a:t> post or join open training sessions, so you never have to train alone.</a:t>
-            </a:r>
-          </a:p>
-          <a:p>
-            <a:pPr algn="l">
-              <a:spcAft>
-                <a:spcPts val="1000"/>
-              </a:spcAft>
-            </a:pPr>
-            <a:r>
-              <a:rPr sz="2200" b="1">
-                <a:solidFill>
-                  <a:srgbClr val="F97316"/>
-                </a:solidFill>
-              </a:rPr>
-              <a:t>•  </a:t>
-            </a:r>
-            <a:r>
-              <a:rPr sz="2200" b="1">
-                <a:solidFill>
-                  <a:srgbClr val="0F172A"/>
-                </a:solidFill>
-              </a:rPr>
-              <a:t>Cloud:</a:t>
-            </a:r>
-            <a:r>
-              <a:rPr sz="2200" b="0">
-                <a:solidFill>
-                  <a:srgbClr val="64748B"/>
-                </a:solidFill>
-              </a:rPr>
-              <a:t> everything is stored in Firebase, so your data follows you to any phone.</a:t>
-            </a:r>
-          </a:p>
-        </p:txBody>
-      </p:sp>
-      <p:sp>
-        <p:nvSpPr>
-          <p:cNvPr id="5" name="Rounded Rectangle 4"/>
-          <p:cNvSpPr/>
-          <p:nvPr/>
-        </p:nvSpPr>
-        <p:spPr>
-          <a:xfrm>
-            <a:off x="7589520" y="1737360"/>
-            <a:ext cx="4023360" cy="4206240"/>
-          </a:xfrm>
-          <a:prstGeom prst="roundRect">
-            <a:avLst/>
-          </a:prstGeom>
-          <a:solidFill>
-            <a:srgbClr val="F1F5F9"/>
-          </a:solidFill>
-          <a:ln>
-            <a:noFill/>
-          </a:ln>
-          <a:effectLst/>
-        </p:spPr>
-        <p:style>
-          <a:lnRef idx="1">
-            <a:schemeClr val="accent1"/>
-          </a:lnRef>
-          <a:fillRef idx="3">
-            <a:schemeClr val="accent1"/>
-          </a:fillRef>
-          <a:effectRef idx="2">
-            <a:schemeClr val="accent1"/>
-          </a:effectRef>
-          <a:fontRef idx="minor">
-            <a:schemeClr val="lt1"/>
-          </a:fontRef>
-        </p:style>
-        <p:txBody>
-          <a:bodyPr rtlCol="0" anchor="ctr" wrap="square" lIns="274320" rIns="274320" tIns="73152" bIns="73152"/>
-          <a:lstStyle/>
-          <a:p>
-            <a:pPr algn="ctr"/>
-            <a:r>
-              <a:rPr sz="2200" b="1">
-                <a:solidFill>
-                  <a:srgbClr val="C2410C"/>
-                </a:solidFill>
-              </a:rPr>
-              <a:t>Why the name?</a:t>
-            </a:r>
-          </a:p>
-          <a:p>
-            <a:pPr algn="l">
-              <a:spcBef>
-                <a:spcPts val="1000"/>
-              </a:spcBef>
-            </a:pPr>
-            <a:r>
-              <a:rPr sz="1800" b="0">
-                <a:solidFill>
-                  <a:srgbClr val="0F172A"/>
-                </a:solidFill>
-              </a:rPr>
-              <a:t>“Buddy” is the gym word for a training partner. People who train with a partner skip fewer sessions – so the name says what the app is for: staying consistent, together.</a:t>
-            </a:r>
-          </a:p>
-        </p:txBody>
-      </p:sp>
-    </p:spTree>
-  </p:cSld>
-  <p:clrMapOvr>
-    <a:masterClrMapping/>
-  </p:clrMapOvr>
-</p:sld>
-</file>
-
-<file path=ppt/slides/slide3.xml><?xml version="1.0" encoding="utf-8"?>
-<p:sld xmlns:a="http://schemas.openxmlformats.org/drawingml/2006/main" xmlns:p="http://schemas.openxmlformats.org/presentationml/2006/main" xmlns:r="http://schemas.openxmlformats.org/officeDocument/2006/relationships">
-  <p:cSld>
-    <p:spTree>
-      <p:nvGrpSpPr>
-        <p:cNvPr id="1" name=""/>
-        <p:cNvGrpSpPr/>
-        <p:nvPr/>
-      </p:nvGrpSpPr>
-      <p:grpSpPr/>
-      <p:sp>
-        <p:nvSpPr>
-          <p:cNvPr id="2" name="Rectangle 1"/>
-          <p:cNvSpPr/>
-          <p:nvPr/>
-        </p:nvSpPr>
-        <p:spPr>
-          <a:xfrm>
-            <a:off x="0" y="0"/>
-            <a:ext cx="12191695" cy="1097280"/>
-          </a:xfrm>
-          <a:prstGeom prst="rect">
-            <a:avLst/>
-          </a:prstGeom>
-          <a:solidFill>
-            <a:srgbClr val="111827"/>
-          </a:solidFill>
-          <a:ln>
-            <a:noFill/>
-          </a:ln>
-          <a:effectLst/>
-        </p:spPr>
-        <p:style>
-          <a:lnRef idx="1">
-            <a:schemeClr val="accent1"/>
-          </a:lnRef>
-          <a:fillRef idx="3">
-            <a:schemeClr val="accent1"/>
-          </a:fillRef>
-          <a:effectRef idx="2">
-            <a:schemeClr val="accent1"/>
-          </a:effectRef>
-          <a:fontRef idx="minor">
-            <a:schemeClr val="lt1"/>
-          </a:fontRef>
-        </p:style>
-        <p:txBody>
-          <a:bodyPr rtlCol="0" anchor="ctr" wrap="square" lIns="457200" rIns="457200" tIns="73152" bIns="73152"/>
-          <a:lstStyle/>
-          <a:p>
-            <a:pPr algn="ctr"/>
-            <a:r>
-              <a:rPr sz="3200" b="1">
-                <a:solidFill>
-                  <a:srgbClr val="FFFFFF"/>
-                </a:solidFill>
-              </a:rPr>
-              <a:t>Where GymBuddy can be used</a:t>
-            </a:r>
-          </a:p>
-          <a:p>
-            <a:pPr algn="l"/>
-            <a:r>
-              <a:rPr sz="1500" b="0">
-                <a:solidFill>
-                  <a:srgbClr val="FDBA74"/>
-                </a:solidFill>
-              </a:rPr>
-              <a:t>The same app helps different groups</a:t>
-            </a:r>
-          </a:p>
-        </p:txBody>
-      </p:sp>
-      <p:sp>
-        <p:nvSpPr>
-          <p:cNvPr id="3" name="Rectangle 2"/>
-          <p:cNvSpPr/>
-          <p:nvPr/>
-        </p:nvSpPr>
-        <p:spPr>
-          <a:xfrm>
-            <a:off x="0" y="1097280"/>
-            <a:ext cx="12191695" cy="64008"/>
-          </a:xfrm>
-          <a:prstGeom prst="rect">
-            <a:avLst/>
-          </a:prstGeom>
-          <a:solidFill>
-            <a:srgbClr val="F97316"/>
-          </a:solidFill>
-          <a:ln>
-            <a:noFill/>
-          </a:ln>
-          <a:effectLst/>
-        </p:spPr>
-        <p:style>
-          <a:lnRef idx="1">
-            <a:schemeClr val="accent1"/>
-          </a:lnRef>
-          <a:fillRef idx="3">
-            <a:schemeClr val="accent1"/>
-          </a:fillRef>
-          <a:effectRef idx="2">
-            <a:schemeClr val="accent1"/>
-          </a:effectRef>
-          <a:fontRef idx="minor">
-            <a:schemeClr val="lt1"/>
-          </a:fontRef>
-        </p:style>
-        <p:txBody>
-          <a:bodyPr rtlCol="0" anchor="ctr"/>
-          <a:lstStyle/>
-          <a:p>
-            <a:pPr algn="ctr"/>
-          </a:p>
-        </p:txBody>
-      </p:sp>
-      <p:graphicFrame>
-        <p:nvGraphicFramePr>
-          <p:cNvPr id="4" name="Table 3"/>
-          <p:cNvGraphicFramePr>
-            <a:graphicFrameLocks noGrp="1"/>
-          </p:cNvGraphicFramePr>
-          <p:nvPr/>
-        </p:nvGraphicFramePr>
-        <p:xfrm>
-          <a:off x="640080" y="1645920"/>
-          <a:ext cx="10881360" cy="3968496"/>
-        </p:xfrm>
-        <a:graphic>
-          <a:graphicData uri="http://schemas.openxmlformats.org/drawingml/2006/table">
-            <a:tbl>
-              <a:tblPr firstRow="1" bandRow="1">
-                <a:tableStyleId>{5C22544A-7EE6-4342-B048-85BDC9FD1C3A}</a:tableStyleId>
-              </a:tblPr>
-              <a:tblGrid>
-                <a:gridCol w="4023360"/>
-                <a:gridCol w="6858000"/>
-              </a:tblGrid>
-              <a:tr h="566928">
-                <a:tc>
-                  <a:txBody>
-                    <a:bodyPr/>
-                    <a:lstStyle/>
-                    <a:p>
-                      <a:r>
-                        <a:rPr sz="1800" b="1">
-                          <a:solidFill>
-                            <a:srgbClr val="FFFFFF"/>
-                          </a:solidFill>
-                        </a:rPr>
-                        <a:t>Who</a:t>
-                      </a:r>
-                    </a:p>
-                  </a:txBody>
-                  <a:tcPr>
-                    <a:solidFill>
-                      <a:srgbClr val="111827"/>
-                    </a:solidFill>
-                  </a:tcPr>
-                </a:tc>
-                <a:tc>
-                  <a:txBody>
-                    <a:bodyPr/>
-                    <a:lstStyle/>
-                    <a:p>
-                      <a:r>
-                        <a:rPr sz="1800" b="1">
-                          <a:solidFill>
-                            <a:srgbClr val="FFFFFF"/>
-                          </a:solidFill>
-                        </a:rPr>
-                        <a:t>How GymBuddy helps</a:t>
-                      </a:r>
-                    </a:p>
-                  </a:txBody>
-                  <a:tcPr>
-                    <a:solidFill>
-                      <a:srgbClr val="111827"/>
-                    </a:solidFill>
-                  </a:tcPr>
-                </a:tc>
-              </a:tr>
-              <a:tr h="566928">
-                <a:tc>
-                  <a:txBody>
-                    <a:bodyPr/>
-                    <a:lstStyle/>
-                    <a:p>
-                      <a:r>
-                        <a:rPr sz="1800" b="0">
-                          <a:solidFill>
-                            <a:srgbClr val="0F172A"/>
-                          </a:solidFill>
-                        </a:rPr>
-                        <a:t>Individual gym-goers</a:t>
-                      </a:r>
-                    </a:p>
-                  </a:txBody>
-                  <a:tcPr>
-                    <a:solidFill>
-                      <a:srgbClr val="F1F5F9"/>
-                    </a:solidFill>
-                  </a:tcPr>
-                </a:tc>
-                <a:tc>
-                  <a:txBody>
-                    <a:bodyPr/>
-                    <a:lstStyle/>
-                    <a:p>
-                      <a:r>
-                        <a:rPr sz="1800" b="0">
-                          <a:solidFill>
-                            <a:srgbClr val="0F172A"/>
-                          </a:solidFill>
-                        </a:rPr>
-                        <a:t>Keep a simple training history and see weekly progress</a:t>
-                      </a:r>
-                    </a:p>
-                  </a:txBody>
-                  <a:tcPr>
-                    <a:solidFill>
-                      <a:srgbClr val="F1F5F9"/>
-                    </a:solidFill>
-                  </a:tcPr>
-                </a:tc>
-              </a:tr>
-              <a:tr h="566928">
-                <a:tc>
-                  <a:txBody>
-                    <a:bodyPr/>
-                    <a:lstStyle/>
-                    <a:p>
-                      <a:r>
-                        <a:rPr sz="1800" b="0">
-                          <a:solidFill>
-                            <a:srgbClr val="0F172A"/>
-                          </a:solidFill>
-                        </a:rPr>
-                        <a:t>Friends and training groups</a:t>
-                      </a:r>
-                    </a:p>
-                  </a:txBody>
-                  <a:tcPr>
-                    <a:solidFill>
-                      <a:srgbClr val="FFFFFF"/>
-                    </a:solidFill>
-                  </a:tcPr>
-                </a:tc>
-                <a:tc>
-                  <a:txBody>
-                    <a:bodyPr/>
-                    <a:lstStyle/>
-                    <a:p>
-                      <a:r>
-                        <a:rPr sz="1800" b="0">
-                          <a:solidFill>
-                            <a:srgbClr val="0F172A"/>
-                          </a:solidFill>
-                        </a:rPr>
-                        <a:t>Plan shared sessions and see who joined</a:t>
-                      </a:r>
-                    </a:p>
-                  </a:txBody>
-                  <a:tcPr>
-                    <a:solidFill>
-                      <a:srgbClr val="FFFFFF"/>
-                    </a:solidFill>
-                  </a:tcPr>
-                </a:tc>
-              </a:tr>
-              <a:tr h="566928">
-                <a:tc>
-                  <a:txBody>
-                    <a:bodyPr/>
-                    <a:lstStyle/>
-                    <a:p>
-                      <a:r>
-                        <a:rPr sz="1800" b="0">
-                          <a:solidFill>
-                            <a:srgbClr val="0F172A"/>
-                          </a:solidFill>
-                        </a:rPr>
-                        <a:t>Newcomers to a gym</a:t>
-                      </a:r>
-                    </a:p>
-                  </a:txBody>
-                  <a:tcPr>
-                    <a:solidFill>
-                      <a:srgbClr val="F1F5F9"/>
-                    </a:solidFill>
-                  </a:tcPr>
-                </a:tc>
-                <a:tc>
-                  <a:txBody>
-                    <a:bodyPr/>
-                    <a:lstStyle/>
-                    <a:p>
-                      <a:r>
-                        <a:rPr sz="1800" b="0">
-                          <a:solidFill>
-                            <a:srgbClr val="0F172A"/>
-                          </a:solidFill>
-                        </a:rPr>
-                        <a:t>Find a partner instead of training alone</a:t>
-                      </a:r>
-                    </a:p>
-                  </a:txBody>
-                  <a:tcPr>
-                    <a:solidFill>
-                      <a:srgbClr val="F1F5F9"/>
-                    </a:solidFill>
-                  </a:tcPr>
-                </a:tc>
-              </a:tr>
-              <a:tr h="566928">
-                <a:tc>
-                  <a:txBody>
-                    <a:bodyPr/>
-                    <a:lstStyle/>
-                    <a:p>
-                      <a:r>
-                        <a:rPr sz="1800" b="0">
-                          <a:solidFill>
-                            <a:srgbClr val="0F172A"/>
-                          </a:solidFill>
-                        </a:rPr>
-                        <a:t>University sports clubs</a:t>
-                      </a:r>
-                    </a:p>
-                  </a:txBody>
-                  <a:tcPr>
-                    <a:solidFill>
-                      <a:srgbClr val="FFFFFF"/>
-                    </a:solidFill>
-                  </a:tcPr>
-                </a:tc>
-                <a:tc>
-                  <a:txBody>
-                    <a:bodyPr/>
-                    <a:lstStyle/>
-                    <a:p>
-                      <a:r>
-                        <a:rPr sz="1800" b="0">
-                          <a:solidFill>
-                            <a:srgbClr val="0F172A"/>
-                          </a:solidFill>
-                        </a:rPr>
-                        <a:t>Organise open sessions for students and staff</a:t>
-                      </a:r>
-                    </a:p>
-                  </a:txBody>
-                  <a:tcPr>
-                    <a:solidFill>
-                      <a:srgbClr val="FFFFFF"/>
-                    </a:solidFill>
-                  </a:tcPr>
-                </a:tc>
-              </a:tr>
-              <a:tr h="566928">
-                <a:tc>
-                  <a:txBody>
-                    <a:bodyPr/>
-                    <a:lstStyle/>
-                    <a:p>
-                      <a:r>
-                        <a:rPr sz="1800" b="0">
-                          <a:solidFill>
-                            <a:srgbClr val="0F172A"/>
-                          </a:solidFill>
-                        </a:rPr>
-                        <a:t>Workplace wellness programmes</a:t>
-                      </a:r>
-                    </a:p>
-                  </a:txBody>
-                  <a:tcPr>
-                    <a:solidFill>
-                      <a:srgbClr val="F1F5F9"/>
-                    </a:solidFill>
-                  </a:tcPr>
-                </a:tc>
-                <a:tc>
-                  <a:txBody>
-                    <a:bodyPr/>
-                    <a:lstStyle/>
-                    <a:p>
-                      <a:r>
-                        <a:rPr sz="1800" b="0">
-                          <a:solidFill>
-                            <a:srgbClr val="0F172A"/>
-                          </a:solidFill>
-                        </a:rPr>
-                        <a:t>Let colleagues arrange group workouts</a:t>
-                      </a:r>
-                    </a:p>
-                  </a:txBody>
-                  <a:tcPr>
-                    <a:solidFill>
-                      <a:srgbClr val="F1F5F9"/>
-                    </a:solidFill>
-                  </a:tcPr>
-                </a:tc>
-              </a:tr>
-              <a:tr h="566928">
-                <a:tc>
-                  <a:txBody>
-                    <a:bodyPr/>
-                    <a:lstStyle/>
-                    <a:p>
-                      <a:r>
-                        <a:rPr sz="1800" b="0">
-                          <a:solidFill>
-                            <a:srgbClr val="0F172A"/>
-                          </a:solidFill>
-                        </a:rPr>
-                        <a:t>Small gyms and fitness studios</a:t>
-                      </a:r>
-                    </a:p>
-                  </a:txBody>
-                  <a:tcPr>
-                    <a:solidFill>
-                      <a:srgbClr val="FFFFFF"/>
-                    </a:solidFill>
-                  </a:tcPr>
-                </a:tc>
-                <a:tc>
-                  <a:txBody>
-                    <a:bodyPr/>
-                    <a:lstStyle/>
-                    <a:p>
-                      <a:r>
-                        <a:rPr sz="1800" b="0">
-                          <a:solidFill>
-                            <a:srgbClr val="0F172A"/>
-                          </a:solidFill>
-                        </a:rPr>
-                        <a:t>Give members a free way to meet training partners</a:t>
-                      </a:r>
-                    </a:p>
-                  </a:txBody>
-                  <a:tcPr>
-                    <a:solidFill>
-                      <a:srgbClr val="FFFFFF"/>
-                    </a:solidFill>
-                  </a:tcPr>
-                </a:tc>
-              </a:tr>
-            </a:tbl>
-          </a:graphicData>
-        </a:graphic>
-      </p:graphicFrame>
-      <p:sp>
-        <p:nvSpPr>
-          <p:cNvPr id="5" name="TextBox 4"/>
-          <p:cNvSpPr txBox="1"/>
-          <p:nvPr/>
-        </p:nvSpPr>
-        <p:spPr>
-          <a:xfrm>
-            <a:off x="640080" y="5806440"/>
-            <a:ext cx="10881360" cy="731520"/>
-          </a:xfrm>
-          <a:prstGeom prst="rect">
-            <a:avLst/>
-          </a:prstGeom>
-          <a:noFill/>
-        </p:spPr>
-        <p:txBody>
-          <a:bodyPr wrap="square">
-            <a:spAutoFit/>
-          </a:bodyPr>
-          <a:lstStyle/>
-          <a:p>
-            <a:pPr algn="l"/>
-            <a:r>
-              <a:rPr sz="1600" b="0">
-                <a:solidFill>
-                  <a:srgbClr val="64748B"/>
-                </a:solidFill>
-              </a:rPr>
-              <a:t>People who track their training see progress, and people who train with a partner skip fewer sessions.</a:t>
-            </a:r>
-          </a:p>
-        </p:txBody>
-      </p:sp>
-    </p:spTree>
-  </p:cSld>
-  <p:clrMapOvr>
-    <a:masterClrMapping/>
-  </p:clrMapOvr>
-</p:sld>
-</file>
-
-<file path=ppt/slides/slide4.xml><?xml version="1.0" encoding="utf-8"?>
-<p:sld xmlns:a="http://schemas.openxmlformats.org/drawingml/2006/main" xmlns:p="http://schemas.openxmlformats.org/presentationml/2006/main" xmlns:r="http://schemas.openxmlformats.org/officeDocument/2006/relationships">
-  <p:cSld>
-    <p:spTree>
-      <p:nvGrpSpPr>
-        <p:cNvPr id="1" name=""/>
-        <p:cNvGrpSpPr/>
-        <p:nvPr/>
-      </p:nvGrpSpPr>
-      <p:grpSpPr/>
-      <p:sp>
-        <p:nvSpPr>
-          <p:cNvPr id="2" name="Rectangle 1"/>
-          <p:cNvSpPr/>
-          <p:nvPr/>
-        </p:nvSpPr>
-        <p:spPr>
-          <a:xfrm>
-            <a:off x="0" y="0"/>
-            <a:ext cx="12191695" cy="1097280"/>
-          </a:xfrm>
-          <a:prstGeom prst="rect">
-            <a:avLst/>
-          </a:prstGeom>
-          <a:solidFill>
-            <a:srgbClr val="111827"/>
-          </a:solidFill>
-          <a:ln>
-            <a:noFill/>
-          </a:ln>
-          <a:effectLst/>
-        </p:spPr>
-        <p:style>
-          <a:lnRef idx="1">
-            <a:schemeClr val="accent1"/>
-          </a:lnRef>
-          <a:fillRef idx="3">
-            <a:schemeClr val="accent1"/>
-          </a:fillRef>
-          <a:effectRef idx="2">
-            <a:schemeClr val="accent1"/>
-          </a:effectRef>
-          <a:fontRef idx="minor">
-            <a:schemeClr val="lt1"/>
-          </a:fontRef>
-        </p:style>
-        <p:txBody>
-          <a:bodyPr rtlCol="0" anchor="ctr" wrap="square" lIns="457200" rIns="457200" tIns="73152" bIns="73152"/>
-          <a:lstStyle/>
-          <a:p>
-            <a:pPr algn="ctr"/>
-            <a:r>
-              <a:rPr sz="3200" b="1">
-                <a:solidFill>
-                  <a:srgbClr val="FFFFFF"/>
-                </a:solidFill>
-              </a:rPr>
-              <a:t>The problem</a:t>
-            </a:r>
-          </a:p>
-          <a:p>
-            <a:pPr algn="l"/>
-            <a:r>
-              <a:rPr sz="1500" b="0">
-                <a:solidFill>
-                  <a:srgbClr val="FDBA74"/>
-                </a:solidFill>
-              </a:rPr>
-              <a:t>One sentence: who has what problem, and why it matters</a:t>
-            </a:r>
-          </a:p>
-        </p:txBody>
-      </p:sp>
-      <p:sp>
-        <p:nvSpPr>
-          <p:cNvPr id="3" name="Rectangle 2"/>
-          <p:cNvSpPr/>
-          <p:nvPr/>
-        </p:nvSpPr>
-        <p:spPr>
-          <a:xfrm>
-            <a:off x="0" y="1097280"/>
-            <a:ext cx="12191695" cy="64008"/>
-          </a:xfrm>
-          <a:prstGeom prst="rect">
-            <a:avLst/>
-          </a:prstGeom>
-          <a:solidFill>
-            <a:srgbClr val="F97316"/>
-          </a:solidFill>
-          <a:ln>
-            <a:noFill/>
-          </a:ln>
-          <a:effectLst/>
-        </p:spPr>
-        <p:style>
-          <a:lnRef idx="1">
-            <a:schemeClr val="accent1"/>
-          </a:lnRef>
-          <a:fillRef idx="3">
-            <a:schemeClr val="accent1"/>
-          </a:fillRef>
-          <a:effectRef idx="2">
-            <a:schemeClr val="accent1"/>
-          </a:effectRef>
-          <a:fontRef idx="minor">
-            <a:schemeClr val="lt1"/>
-          </a:fontRef>
-        </p:style>
-        <p:txBody>
-          <a:bodyPr rtlCol="0" anchor="ctr"/>
-          <a:lstStyle/>
-          <a:p>
-            <a:pPr algn="ctr"/>
-          </a:p>
-        </p:txBody>
-      </p:sp>
-      <p:sp>
-        <p:nvSpPr>
           <p:cNvPr id="4" name="Rounded Rectangle 3"/>
           <p:cNvSpPr/>
           <p:nvPr/>
@@ -7077,7 +5656,7 @@
 </p:sld>
 </file>
 
-<file path=ppt/slides/slide5.xml><?xml version="1.0" encoding="utf-8"?>
+<file path=ppt/slides/slide4.xml><?xml version="1.0" encoding="utf-8"?>
 <p:sld xmlns:a="http://schemas.openxmlformats.org/drawingml/2006/main" xmlns:p="http://schemas.openxmlformats.org/presentationml/2006/main" xmlns:r="http://schemas.openxmlformats.org/officeDocument/2006/relationships">
   <p:cSld>
     <p:spTree>
@@ -7653,7 +6232,7 @@
 </p:sld>
 </file>
 
-<file path=ppt/slides/slide6.xml><?xml version="1.0" encoding="utf-8"?>
+<file path=ppt/slides/slide5.xml><?xml version="1.0" encoding="utf-8"?>
 <p:sld xmlns:a="http://schemas.openxmlformats.org/drawingml/2006/main" xmlns:p="http://schemas.openxmlformats.org/presentationml/2006/main" xmlns:r="http://schemas.openxmlformats.org/officeDocument/2006/relationships">
   <p:cSld>
     <p:spTree>
@@ -7836,7 +6415,7 @@
 </p:sld>
 </file>
 
-<file path=ppt/slides/slide7.xml><?xml version="1.0" encoding="utf-8"?>
+<file path=ppt/slides/slide6.xml><?xml version="1.0" encoding="utf-8"?>
 <p:sld xmlns:a="http://schemas.openxmlformats.org/drawingml/2006/main" xmlns:p="http://schemas.openxmlformats.org/presentationml/2006/main" xmlns:r="http://schemas.openxmlformats.org/officeDocument/2006/relationships">
   <p:cSld>
     <p:spTree>
@@ -8197,7 +6776,7 @@
 </p:sld>
 </file>
 
-<file path=ppt/slides/slide8.xml><?xml version="1.0" encoding="utf-8"?>
+<file path=ppt/slides/slide7.xml><?xml version="1.0" encoding="utf-8"?>
 <p:sld xmlns:a="http://schemas.openxmlformats.org/drawingml/2006/main" xmlns:p="http://schemas.openxmlformats.org/presentationml/2006/main" xmlns:r="http://schemas.openxmlformats.org/officeDocument/2006/relationships">
   <p:cSld>
     <p:spTree>
@@ -8891,7 +7470,7 @@
 </p:sld>
 </file>
 
-<file path=ppt/slides/slide9.xml><?xml version="1.0" encoding="utf-8"?>
+<file path=ppt/slides/slide8.xml><?xml version="1.0" encoding="utf-8"?>
 <p:sld xmlns:a="http://schemas.openxmlformats.org/drawingml/2006/main" xmlns:p="http://schemas.openxmlformats.org/presentationml/2006/main" xmlns:r="http://schemas.openxmlformats.org/officeDocument/2006/relationships">
   <p:cSld>
     <p:spTree>
@@ -9291,6 +7870,517 @@
                 </a:solidFill>
               </a:rPr>
               <a:t> the PR says “Closes #issue”, so the issue moves to Done on merge.</a:t>
+            </a:r>
+          </a:p>
+        </p:txBody>
+      </p:sp>
+    </p:spTree>
+  </p:cSld>
+  <p:clrMapOvr>
+    <a:masterClrMapping/>
+  </p:clrMapOvr>
+</p:sld>
+</file>
+
+<file path=ppt/slides/slide9.xml><?xml version="1.0" encoding="utf-8"?>
+<p:sld xmlns:a="http://schemas.openxmlformats.org/drawingml/2006/main" xmlns:p="http://schemas.openxmlformats.org/presentationml/2006/main" xmlns:r="http://schemas.openxmlformats.org/officeDocument/2006/relationships">
+  <p:cSld>
+    <p:spTree>
+      <p:nvGrpSpPr>
+        <p:cNvPr id="1" name=""/>
+        <p:cNvGrpSpPr/>
+        <p:nvPr/>
+      </p:nvGrpSpPr>
+      <p:grpSpPr/>
+      <p:sp>
+        <p:nvSpPr>
+          <p:cNvPr id="2" name="Rectangle 1"/>
+          <p:cNvSpPr/>
+          <p:nvPr/>
+        </p:nvSpPr>
+        <p:spPr>
+          <a:xfrm>
+            <a:off x="0" y="0"/>
+            <a:ext cx="12191695" cy="1097280"/>
+          </a:xfrm>
+          <a:prstGeom prst="rect">
+            <a:avLst/>
+          </a:prstGeom>
+          <a:solidFill>
+            <a:srgbClr val="111827"/>
+          </a:solidFill>
+          <a:ln>
+            <a:noFill/>
+          </a:ln>
+          <a:effectLst/>
+        </p:spPr>
+        <p:style>
+          <a:lnRef idx="1">
+            <a:schemeClr val="accent1"/>
+          </a:lnRef>
+          <a:fillRef idx="3">
+            <a:schemeClr val="accent1"/>
+          </a:fillRef>
+          <a:effectRef idx="2">
+            <a:schemeClr val="accent1"/>
+          </a:effectRef>
+          <a:fontRef idx="minor">
+            <a:schemeClr val="lt1"/>
+          </a:fontRef>
+        </p:style>
+        <p:txBody>
+          <a:bodyPr rtlCol="0" anchor="ctr" wrap="square" lIns="457200" rIns="457200" tIns="73152" bIns="73152"/>
+          <a:lstStyle/>
+          <a:p>
+            <a:pPr algn="ctr"/>
+            <a:r>
+              <a:rPr sz="3200" b="1">
+                <a:solidFill>
+                  <a:srgbClr val="FFFFFF"/>
+                </a:solidFill>
+              </a:rPr>
+              <a:t>Sprint 1 backlog</a:t>
+            </a:r>
+          </a:p>
+          <a:p>
+            <a:pPr algn="l"/>
+            <a:r>
+              <a:rPr sz="1500" b="0">
+                <a:solidFill>
+                  <a:srgbClr val="FDBA74"/>
+                </a:solidFill>
+              </a:rPr>
+              <a:t>Each story has acceptance criteria and an assignee</a:t>
+            </a:r>
+          </a:p>
+        </p:txBody>
+      </p:sp>
+      <p:sp>
+        <p:nvSpPr>
+          <p:cNvPr id="3" name="Rectangle 2"/>
+          <p:cNvSpPr/>
+          <p:nvPr/>
+        </p:nvSpPr>
+        <p:spPr>
+          <a:xfrm>
+            <a:off x="0" y="1097280"/>
+            <a:ext cx="12191695" cy="64008"/>
+          </a:xfrm>
+          <a:prstGeom prst="rect">
+            <a:avLst/>
+          </a:prstGeom>
+          <a:solidFill>
+            <a:srgbClr val="F97316"/>
+          </a:solidFill>
+          <a:ln>
+            <a:noFill/>
+          </a:ln>
+          <a:effectLst/>
+        </p:spPr>
+        <p:style>
+          <a:lnRef idx="1">
+            <a:schemeClr val="accent1"/>
+          </a:lnRef>
+          <a:fillRef idx="3">
+            <a:schemeClr val="accent1"/>
+          </a:fillRef>
+          <a:effectRef idx="2">
+            <a:schemeClr val="accent1"/>
+          </a:effectRef>
+          <a:fontRef idx="minor">
+            <a:schemeClr val="lt1"/>
+          </a:fontRef>
+        </p:style>
+        <p:txBody>
+          <a:bodyPr rtlCol="0" anchor="ctr"/>
+          <a:lstStyle/>
+          <a:p>
+            <a:pPr algn="ctr"/>
+          </a:p>
+        </p:txBody>
+      </p:sp>
+      <p:graphicFrame>
+        <p:nvGraphicFramePr>
+          <p:cNvPr id="4" name="Table 3"/>
+          <p:cNvGraphicFramePr>
+            <a:graphicFrameLocks noGrp="1"/>
+          </p:cNvGraphicFramePr>
+          <p:nvPr/>
+        </p:nvGraphicFramePr>
+        <p:xfrm>
+          <a:off x="640080" y="1645920"/>
+          <a:ext cx="10881360" cy="3657600"/>
+        </p:xfrm>
+        <a:graphic>
+          <a:graphicData uri="http://schemas.openxmlformats.org/drawingml/2006/table">
+            <a:tbl>
+              <a:tblPr firstRow="1" bandRow="1">
+                <a:tableStyleId>{5C22544A-7EE6-4342-B048-85BDC9FD1C3A}</a:tableStyleId>
+              </a:tblPr>
+              <a:tblGrid>
+                <a:gridCol w="6035040"/>
+                <a:gridCol w="3566160"/>
+                <a:gridCol w="1280160"/>
+              </a:tblGrid>
+              <a:tr h="731520">
+                <a:tc>
+                  <a:txBody>
+                    <a:bodyPr/>
+                    <a:lstStyle/>
+                    <a:p>
+                      <a:r>
+                        <a:rPr sz="1600" b="1">
+                          <a:solidFill>
+                            <a:srgbClr val="FFFFFF"/>
+                          </a:solidFill>
+                        </a:rPr>
+                        <a:t>User story</a:t>
+                      </a:r>
+                    </a:p>
+                  </a:txBody>
+                  <a:tcPr>
+                    <a:solidFill>
+                      <a:srgbClr val="111827"/>
+                    </a:solidFill>
+                  </a:tcPr>
+                </a:tc>
+                <a:tc>
+                  <a:txBody>
+                    <a:bodyPr/>
+                    <a:lstStyle/>
+                    <a:p>
+                      <a:r>
+                        <a:rPr sz="1600" b="1">
+                          <a:solidFill>
+                            <a:srgbClr val="FFFFFF"/>
+                          </a:solidFill>
+                        </a:rPr>
+                        <a:t>Labels</a:t>
+                      </a:r>
+                    </a:p>
+                  </a:txBody>
+                  <a:tcPr>
+                    <a:solidFill>
+                      <a:srgbClr val="111827"/>
+                    </a:solidFill>
+                  </a:tcPr>
+                </a:tc>
+                <a:tc>
+                  <a:txBody>
+                    <a:bodyPr/>
+                    <a:lstStyle/>
+                    <a:p>
+                      <a:r>
+                        <a:rPr sz="1600" b="1">
+                          <a:solidFill>
+                            <a:srgbClr val="FFFFFF"/>
+                          </a:solidFill>
+                        </a:rPr>
+                        <a:t>Assignee</a:t>
+                      </a:r>
+                    </a:p>
+                  </a:txBody>
+                  <a:tcPr>
+                    <a:solidFill>
+                      <a:srgbClr val="111827"/>
+                    </a:solidFill>
+                  </a:tcPr>
+                </a:tc>
+              </a:tr>
+              <a:tr h="731520">
+                <a:tc>
+                  <a:txBody>
+                    <a:bodyPr/>
+                    <a:lstStyle/>
+                    <a:p>
+                      <a:r>
+                        <a:rPr sz="1600" b="0">
+                          <a:solidFill>
+                            <a:srgbClr val="0F172A"/>
+                          </a:solidFill>
+                        </a:rPr>
+                        <a:t>As a gym-goer, I want to register and log in with email and password</a:t>
+                      </a:r>
+                    </a:p>
+                  </a:txBody>
+                  <a:tcPr>
+                    <a:solidFill>
+                      <a:srgbClr val="F1F5F9"/>
+                    </a:solidFill>
+                  </a:tcPr>
+                </a:tc>
+                <a:tc>
+                  <a:txBody>
+                    <a:bodyPr/>
+                    <a:lstStyle/>
+                    <a:p>
+                      <a:r>
+                        <a:rPr sz="1600" b="0">
+                          <a:solidFill>
+                            <a:srgbClr val="0F172A"/>
+                          </a:solidFill>
+                        </a:rPr>
+                        <a:t>user-story · android · firebase</a:t>
+                      </a:r>
+                    </a:p>
+                  </a:txBody>
+                  <a:tcPr>
+                    <a:solidFill>
+                      <a:srgbClr val="F1F5F9"/>
+                    </a:solidFill>
+                  </a:tcPr>
+                </a:tc>
+                <a:tc>
+                  <a:txBody>
+                    <a:bodyPr/>
+                    <a:lstStyle/>
+                    <a:p>
+                      <a:r>
+                        <a:rPr sz="1600" b="0">
+                          <a:solidFill>
+                            <a:srgbClr val="0F172A"/>
+                          </a:solidFill>
+                        </a:rPr>
+                        <a:t>Ozodbek</a:t>
+                      </a:r>
+                    </a:p>
+                  </a:txBody>
+                  <a:tcPr>
+                    <a:solidFill>
+                      <a:srgbClr val="F1F5F9"/>
+                    </a:solidFill>
+                  </a:tcPr>
+                </a:tc>
+              </a:tr>
+              <a:tr h="731520">
+                <a:tc>
+                  <a:txBody>
+                    <a:bodyPr/>
+                    <a:lstStyle/>
+                    <a:p>
+                      <a:r>
+                        <a:rPr sz="1600" b="0">
+                          <a:solidFill>
+                            <a:srgbClr val="0F172A"/>
+                          </a:solidFill>
+                        </a:rPr>
+                        <a:t>As a gym-goer, I want to see a list of my workouts</a:t>
+                      </a:r>
+                    </a:p>
+                  </a:txBody>
+                  <a:tcPr>
+                    <a:solidFill>
+                      <a:srgbClr val="FFFFFF"/>
+                    </a:solidFill>
+                  </a:tcPr>
+                </a:tc>
+                <a:tc>
+                  <a:txBody>
+                    <a:bodyPr/>
+                    <a:lstStyle/>
+                    <a:p>
+                      <a:r>
+                        <a:rPr sz="1600" b="0">
+                          <a:solidFill>
+                            <a:srgbClr val="0F172A"/>
+                          </a:solidFill>
+                        </a:rPr>
+                        <a:t>user-story · android · ui</a:t>
+                      </a:r>
+                    </a:p>
+                  </a:txBody>
+                  <a:tcPr>
+                    <a:solidFill>
+                      <a:srgbClr val="FFFFFF"/>
+                    </a:solidFill>
+                  </a:tcPr>
+                </a:tc>
+                <a:tc>
+                  <a:txBody>
+                    <a:bodyPr/>
+                    <a:lstStyle/>
+                    <a:p>
+                      <a:r>
+                        <a:rPr sz="1600" b="0">
+                          <a:solidFill>
+                            <a:srgbClr val="0F172A"/>
+                          </a:solidFill>
+                        </a:rPr>
+                        <a:t>Elturan</a:t>
+                      </a:r>
+                    </a:p>
+                  </a:txBody>
+                  <a:tcPr>
+                    <a:solidFill>
+                      <a:srgbClr val="FFFFFF"/>
+                    </a:solidFill>
+                  </a:tcPr>
+                </a:tc>
+              </a:tr>
+              <a:tr h="731520">
+                <a:tc>
+                  <a:txBody>
+                    <a:bodyPr/>
+                    <a:lstStyle/>
+                    <a:p>
+                      <a:r>
+                        <a:rPr sz="1600" b="0">
+                          <a:solidFill>
+                            <a:srgbClr val="0F172A"/>
+                          </a:solidFill>
+                        </a:rPr>
+                        <a:t>As a gym-goer, I want to add a workout</a:t>
+                      </a:r>
+                    </a:p>
+                  </a:txBody>
+                  <a:tcPr>
+                    <a:solidFill>
+                      <a:srgbClr val="F1F5F9"/>
+                    </a:solidFill>
+                  </a:tcPr>
+                </a:tc>
+                <a:tc>
+                  <a:txBody>
+                    <a:bodyPr/>
+                    <a:lstStyle/>
+                    <a:p>
+                      <a:r>
+                        <a:rPr sz="1600" b="0">
+                          <a:solidFill>
+                            <a:srgbClr val="0F172A"/>
+                          </a:solidFill>
+                        </a:rPr>
+                        <a:t>user-story · android · firebase</a:t>
+                      </a:r>
+                    </a:p>
+                  </a:txBody>
+                  <a:tcPr>
+                    <a:solidFill>
+                      <a:srgbClr val="F1F5F9"/>
+                    </a:solidFill>
+                  </a:tcPr>
+                </a:tc>
+                <a:tc>
+                  <a:txBody>
+                    <a:bodyPr/>
+                    <a:lstStyle/>
+                    <a:p>
+                      <a:r>
+                        <a:rPr sz="1600" b="0">
+                          <a:solidFill>
+                            <a:srgbClr val="0F172A"/>
+                          </a:solidFill>
+                        </a:rPr>
+                        <a:t>Aida</a:t>
+                      </a:r>
+                    </a:p>
+                  </a:txBody>
+                  <a:tcPr>
+                    <a:solidFill>
+                      <a:srgbClr val="F1F5F9"/>
+                    </a:solidFill>
+                  </a:tcPr>
+                </a:tc>
+              </a:tr>
+              <a:tr h="731520">
+                <a:tc>
+                  <a:txBody>
+                    <a:bodyPr/>
+                    <a:lstStyle/>
+                    <a:p>
+                      <a:r>
+                        <a:rPr sz="1600" b="0">
+                          <a:solidFill>
+                            <a:srgbClr val="0F172A"/>
+                          </a:solidFill>
+                        </a:rPr>
+                        <a:t>As a gym-goer, I want to edit or delete a workout</a:t>
+                      </a:r>
+                    </a:p>
+                  </a:txBody>
+                  <a:tcPr>
+                    <a:solidFill>
+                      <a:srgbClr val="FFFFFF"/>
+                    </a:solidFill>
+                  </a:tcPr>
+                </a:tc>
+                <a:tc>
+                  <a:txBody>
+                    <a:bodyPr/>
+                    <a:lstStyle/>
+                    <a:p>
+                      <a:r>
+                        <a:rPr sz="1600" b="0">
+                          <a:solidFill>
+                            <a:srgbClr val="0F172A"/>
+                          </a:solidFill>
+                        </a:rPr>
+                        <a:t>user-story · android · firebase</a:t>
+                      </a:r>
+                    </a:p>
+                  </a:txBody>
+                  <a:tcPr>
+                    <a:solidFill>
+                      <a:srgbClr val="FFFFFF"/>
+                    </a:solidFill>
+                  </a:tcPr>
+                </a:tc>
+                <a:tc>
+                  <a:txBody>
+                    <a:bodyPr/>
+                    <a:lstStyle/>
+                    <a:p>
+                      <a:r>
+                        <a:rPr sz="1600" b="0">
+                          <a:solidFill>
+                            <a:srgbClr val="0F172A"/>
+                          </a:solidFill>
+                        </a:rPr>
+                        <a:t>Elturan</a:t>
+                      </a:r>
+                    </a:p>
+                  </a:txBody>
+                  <a:tcPr>
+                    <a:solidFill>
+                      <a:srgbClr val="FFFFFF"/>
+                    </a:solidFill>
+                  </a:tcPr>
+                </a:tc>
+              </a:tr>
+            </a:tbl>
+          </a:graphicData>
+        </a:graphic>
+      </p:graphicFrame>
+      <p:sp>
+        <p:nvSpPr>
+          <p:cNvPr id="5" name="TextBox 4"/>
+          <p:cNvSpPr txBox="1"/>
+          <p:nvPr/>
+        </p:nvSpPr>
+        <p:spPr>
+          <a:xfrm>
+            <a:off x="640080" y="5486400"/>
+            <a:ext cx="10881360" cy="914400"/>
+          </a:xfrm>
+          <a:prstGeom prst="rect">
+            <a:avLst/>
+          </a:prstGeom>
+          <a:noFill/>
+        </p:spPr>
+        <p:txBody>
+          <a:bodyPr wrap="square">
+            <a:spAutoFit/>
+          </a:bodyPr>
+          <a:lstStyle/>
+          <a:p>
+            <a:pPr algn="l"/>
+            <a:r>
+              <a:rPr sz="1700" b="0">
+                <a:solidFill>
+                  <a:srgbClr val="64748B"/>
+                </a:solidFill>
+              </a:rPr>
+              <a:t>Backlog: weekly stats Cloud Function, find a partner (sessions).</a:t>
             </a:r>
           </a:p>
         </p:txBody>

</xml_diff>

<commit_message>
docs: remove report pictures and the presentation update (#10)
</commit_message>
<xml_diff>
--- a/docs/presentation/GymBuddy_Lab1_Presentation.pptx
+++ b/docs/presentation/GymBuddy_Lab1_Presentation.pptx
@@ -18,8 +18,6 @@
     <p:sldId id="266" r:id="rId17"/>
     <p:sldId id="267" r:id="rId18"/>
     <p:sldId id="268" r:id="rId19"/>
-    <p:sldId id="269" r:id="rId20"/>
-    <p:sldId id="270" r:id="rId21"/>
   </p:sldIdLst>
   <p:sldSz cx="12191695" cy="6858000" type="screen4x3"/>
   <p:notesSz cx="6858000" cy="9144000"/>
@@ -3376,517 +3374,6 @@
                   <a:srgbClr val="FFFFFF"/>
                 </a:solidFill>
               </a:rPr>
-              <a:t>Sprint 1 backlog</a:t>
-            </a:r>
-          </a:p>
-          <a:p>
-            <a:pPr algn="l"/>
-            <a:r>
-              <a:rPr sz="1500" b="0">
-                <a:solidFill>
-                  <a:srgbClr val="FDBA74"/>
-                </a:solidFill>
-              </a:rPr>
-              <a:t>Each story has acceptance criteria and an assignee</a:t>
-            </a:r>
-          </a:p>
-        </p:txBody>
-      </p:sp>
-      <p:sp>
-        <p:nvSpPr>
-          <p:cNvPr id="3" name="Rectangle 2"/>
-          <p:cNvSpPr/>
-          <p:nvPr/>
-        </p:nvSpPr>
-        <p:spPr>
-          <a:xfrm>
-            <a:off x="0" y="1097280"/>
-            <a:ext cx="12191695" cy="64008"/>
-          </a:xfrm>
-          <a:prstGeom prst="rect">
-            <a:avLst/>
-          </a:prstGeom>
-          <a:solidFill>
-            <a:srgbClr val="F97316"/>
-          </a:solidFill>
-          <a:ln>
-            <a:noFill/>
-          </a:ln>
-          <a:effectLst/>
-        </p:spPr>
-        <p:style>
-          <a:lnRef idx="1">
-            <a:schemeClr val="accent1"/>
-          </a:lnRef>
-          <a:fillRef idx="3">
-            <a:schemeClr val="accent1"/>
-          </a:fillRef>
-          <a:effectRef idx="2">
-            <a:schemeClr val="accent1"/>
-          </a:effectRef>
-          <a:fontRef idx="minor">
-            <a:schemeClr val="lt1"/>
-          </a:fontRef>
-        </p:style>
-        <p:txBody>
-          <a:bodyPr rtlCol="0" anchor="ctr"/>
-          <a:lstStyle/>
-          <a:p>
-            <a:pPr algn="ctr"/>
-          </a:p>
-        </p:txBody>
-      </p:sp>
-      <p:graphicFrame>
-        <p:nvGraphicFramePr>
-          <p:cNvPr id="4" name="Table 3"/>
-          <p:cNvGraphicFramePr>
-            <a:graphicFrameLocks noGrp="1"/>
-          </p:cNvGraphicFramePr>
-          <p:nvPr/>
-        </p:nvGraphicFramePr>
-        <p:xfrm>
-          <a:off x="640080" y="1645920"/>
-          <a:ext cx="10881360" cy="3657600"/>
-        </p:xfrm>
-        <a:graphic>
-          <a:graphicData uri="http://schemas.openxmlformats.org/drawingml/2006/table">
-            <a:tbl>
-              <a:tblPr firstRow="1" bandRow="1">
-                <a:tableStyleId>{5C22544A-7EE6-4342-B048-85BDC9FD1C3A}</a:tableStyleId>
-              </a:tblPr>
-              <a:tblGrid>
-                <a:gridCol w="6035040"/>
-                <a:gridCol w="3566160"/>
-                <a:gridCol w="1280160"/>
-              </a:tblGrid>
-              <a:tr h="731520">
-                <a:tc>
-                  <a:txBody>
-                    <a:bodyPr/>
-                    <a:lstStyle/>
-                    <a:p>
-                      <a:r>
-                        <a:rPr sz="1600" b="1">
-                          <a:solidFill>
-                            <a:srgbClr val="FFFFFF"/>
-                          </a:solidFill>
-                        </a:rPr>
-                        <a:t>User story</a:t>
-                      </a:r>
-                    </a:p>
-                  </a:txBody>
-                  <a:tcPr>
-                    <a:solidFill>
-                      <a:srgbClr val="111827"/>
-                    </a:solidFill>
-                  </a:tcPr>
-                </a:tc>
-                <a:tc>
-                  <a:txBody>
-                    <a:bodyPr/>
-                    <a:lstStyle/>
-                    <a:p>
-                      <a:r>
-                        <a:rPr sz="1600" b="1">
-                          <a:solidFill>
-                            <a:srgbClr val="FFFFFF"/>
-                          </a:solidFill>
-                        </a:rPr>
-                        <a:t>Labels</a:t>
-                      </a:r>
-                    </a:p>
-                  </a:txBody>
-                  <a:tcPr>
-                    <a:solidFill>
-                      <a:srgbClr val="111827"/>
-                    </a:solidFill>
-                  </a:tcPr>
-                </a:tc>
-                <a:tc>
-                  <a:txBody>
-                    <a:bodyPr/>
-                    <a:lstStyle/>
-                    <a:p>
-                      <a:r>
-                        <a:rPr sz="1600" b="1">
-                          <a:solidFill>
-                            <a:srgbClr val="FFFFFF"/>
-                          </a:solidFill>
-                        </a:rPr>
-                        <a:t>Assignee</a:t>
-                      </a:r>
-                    </a:p>
-                  </a:txBody>
-                  <a:tcPr>
-                    <a:solidFill>
-                      <a:srgbClr val="111827"/>
-                    </a:solidFill>
-                  </a:tcPr>
-                </a:tc>
-              </a:tr>
-              <a:tr h="731520">
-                <a:tc>
-                  <a:txBody>
-                    <a:bodyPr/>
-                    <a:lstStyle/>
-                    <a:p>
-                      <a:r>
-                        <a:rPr sz="1600" b="0">
-                          <a:solidFill>
-                            <a:srgbClr val="0F172A"/>
-                          </a:solidFill>
-                        </a:rPr>
-                        <a:t>As a gym-goer, I want to register and log in with email and password</a:t>
-                      </a:r>
-                    </a:p>
-                  </a:txBody>
-                  <a:tcPr>
-                    <a:solidFill>
-                      <a:srgbClr val="F1F5F9"/>
-                    </a:solidFill>
-                  </a:tcPr>
-                </a:tc>
-                <a:tc>
-                  <a:txBody>
-                    <a:bodyPr/>
-                    <a:lstStyle/>
-                    <a:p>
-                      <a:r>
-                        <a:rPr sz="1600" b="0">
-                          <a:solidFill>
-                            <a:srgbClr val="0F172A"/>
-                          </a:solidFill>
-                        </a:rPr>
-                        <a:t>user-story · android · firebase</a:t>
-                      </a:r>
-                    </a:p>
-                  </a:txBody>
-                  <a:tcPr>
-                    <a:solidFill>
-                      <a:srgbClr val="F1F5F9"/>
-                    </a:solidFill>
-                  </a:tcPr>
-                </a:tc>
-                <a:tc>
-                  <a:txBody>
-                    <a:bodyPr/>
-                    <a:lstStyle/>
-                    <a:p>
-                      <a:r>
-                        <a:rPr sz="1600" b="0">
-                          <a:solidFill>
-                            <a:srgbClr val="0F172A"/>
-                          </a:solidFill>
-                        </a:rPr>
-                        <a:t>Ozodbek</a:t>
-                      </a:r>
-                    </a:p>
-                  </a:txBody>
-                  <a:tcPr>
-                    <a:solidFill>
-                      <a:srgbClr val="F1F5F9"/>
-                    </a:solidFill>
-                  </a:tcPr>
-                </a:tc>
-              </a:tr>
-              <a:tr h="731520">
-                <a:tc>
-                  <a:txBody>
-                    <a:bodyPr/>
-                    <a:lstStyle/>
-                    <a:p>
-                      <a:r>
-                        <a:rPr sz="1600" b="0">
-                          <a:solidFill>
-                            <a:srgbClr val="0F172A"/>
-                          </a:solidFill>
-                        </a:rPr>
-                        <a:t>As a gym-goer, I want to see a list of my workouts</a:t>
-                      </a:r>
-                    </a:p>
-                  </a:txBody>
-                  <a:tcPr>
-                    <a:solidFill>
-                      <a:srgbClr val="FFFFFF"/>
-                    </a:solidFill>
-                  </a:tcPr>
-                </a:tc>
-                <a:tc>
-                  <a:txBody>
-                    <a:bodyPr/>
-                    <a:lstStyle/>
-                    <a:p>
-                      <a:r>
-                        <a:rPr sz="1600" b="0">
-                          <a:solidFill>
-                            <a:srgbClr val="0F172A"/>
-                          </a:solidFill>
-                        </a:rPr>
-                        <a:t>user-story · android · ui</a:t>
-                      </a:r>
-                    </a:p>
-                  </a:txBody>
-                  <a:tcPr>
-                    <a:solidFill>
-                      <a:srgbClr val="FFFFFF"/>
-                    </a:solidFill>
-                  </a:tcPr>
-                </a:tc>
-                <a:tc>
-                  <a:txBody>
-                    <a:bodyPr/>
-                    <a:lstStyle/>
-                    <a:p>
-                      <a:r>
-                        <a:rPr sz="1600" b="0">
-                          <a:solidFill>
-                            <a:srgbClr val="0F172A"/>
-                          </a:solidFill>
-                        </a:rPr>
-                        <a:t>Elturan</a:t>
-                      </a:r>
-                    </a:p>
-                  </a:txBody>
-                  <a:tcPr>
-                    <a:solidFill>
-                      <a:srgbClr val="FFFFFF"/>
-                    </a:solidFill>
-                  </a:tcPr>
-                </a:tc>
-              </a:tr>
-              <a:tr h="731520">
-                <a:tc>
-                  <a:txBody>
-                    <a:bodyPr/>
-                    <a:lstStyle/>
-                    <a:p>
-                      <a:r>
-                        <a:rPr sz="1600" b="0">
-                          <a:solidFill>
-                            <a:srgbClr val="0F172A"/>
-                          </a:solidFill>
-                        </a:rPr>
-                        <a:t>As a gym-goer, I want to add a workout</a:t>
-                      </a:r>
-                    </a:p>
-                  </a:txBody>
-                  <a:tcPr>
-                    <a:solidFill>
-                      <a:srgbClr val="F1F5F9"/>
-                    </a:solidFill>
-                  </a:tcPr>
-                </a:tc>
-                <a:tc>
-                  <a:txBody>
-                    <a:bodyPr/>
-                    <a:lstStyle/>
-                    <a:p>
-                      <a:r>
-                        <a:rPr sz="1600" b="0">
-                          <a:solidFill>
-                            <a:srgbClr val="0F172A"/>
-                          </a:solidFill>
-                        </a:rPr>
-                        <a:t>user-story · android · firebase</a:t>
-                      </a:r>
-                    </a:p>
-                  </a:txBody>
-                  <a:tcPr>
-                    <a:solidFill>
-                      <a:srgbClr val="F1F5F9"/>
-                    </a:solidFill>
-                  </a:tcPr>
-                </a:tc>
-                <a:tc>
-                  <a:txBody>
-                    <a:bodyPr/>
-                    <a:lstStyle/>
-                    <a:p>
-                      <a:r>
-                        <a:rPr sz="1600" b="0">
-                          <a:solidFill>
-                            <a:srgbClr val="0F172A"/>
-                          </a:solidFill>
-                        </a:rPr>
-                        <a:t>Aida</a:t>
-                      </a:r>
-                    </a:p>
-                  </a:txBody>
-                  <a:tcPr>
-                    <a:solidFill>
-                      <a:srgbClr val="F1F5F9"/>
-                    </a:solidFill>
-                  </a:tcPr>
-                </a:tc>
-              </a:tr>
-              <a:tr h="731520">
-                <a:tc>
-                  <a:txBody>
-                    <a:bodyPr/>
-                    <a:lstStyle/>
-                    <a:p>
-                      <a:r>
-                        <a:rPr sz="1600" b="0">
-                          <a:solidFill>
-                            <a:srgbClr val="0F172A"/>
-                          </a:solidFill>
-                        </a:rPr>
-                        <a:t>As a gym-goer, I want to edit or delete a workout</a:t>
-                      </a:r>
-                    </a:p>
-                  </a:txBody>
-                  <a:tcPr>
-                    <a:solidFill>
-                      <a:srgbClr val="FFFFFF"/>
-                    </a:solidFill>
-                  </a:tcPr>
-                </a:tc>
-                <a:tc>
-                  <a:txBody>
-                    <a:bodyPr/>
-                    <a:lstStyle/>
-                    <a:p>
-                      <a:r>
-                        <a:rPr sz="1600" b="0">
-                          <a:solidFill>
-                            <a:srgbClr val="0F172A"/>
-                          </a:solidFill>
-                        </a:rPr>
-                        <a:t>user-story · android · firebase</a:t>
-                      </a:r>
-                    </a:p>
-                  </a:txBody>
-                  <a:tcPr>
-                    <a:solidFill>
-                      <a:srgbClr val="FFFFFF"/>
-                    </a:solidFill>
-                  </a:tcPr>
-                </a:tc>
-                <a:tc>
-                  <a:txBody>
-                    <a:bodyPr/>
-                    <a:lstStyle/>
-                    <a:p>
-                      <a:r>
-                        <a:rPr sz="1600" b="0">
-                          <a:solidFill>
-                            <a:srgbClr val="0F172A"/>
-                          </a:solidFill>
-                        </a:rPr>
-                        <a:t>Elturan</a:t>
-                      </a:r>
-                    </a:p>
-                  </a:txBody>
-                  <a:tcPr>
-                    <a:solidFill>
-                      <a:srgbClr val="FFFFFF"/>
-                    </a:solidFill>
-                  </a:tcPr>
-                </a:tc>
-              </a:tr>
-            </a:tbl>
-          </a:graphicData>
-        </a:graphic>
-      </p:graphicFrame>
-      <p:sp>
-        <p:nvSpPr>
-          <p:cNvPr id="5" name="TextBox 4"/>
-          <p:cNvSpPr txBox="1"/>
-          <p:nvPr/>
-        </p:nvSpPr>
-        <p:spPr>
-          <a:xfrm>
-            <a:off x="640080" y="5486400"/>
-            <a:ext cx="10881360" cy="914400"/>
-          </a:xfrm>
-          <a:prstGeom prst="rect">
-            <a:avLst/>
-          </a:prstGeom>
-          <a:noFill/>
-        </p:spPr>
-        <p:txBody>
-          <a:bodyPr wrap="square">
-            <a:spAutoFit/>
-          </a:bodyPr>
-          <a:lstStyle/>
-          <a:p>
-            <a:pPr algn="l"/>
-            <a:r>
-              <a:rPr sz="1700" b="0">
-                <a:solidFill>
-                  <a:srgbClr val="64748B"/>
-                </a:solidFill>
-              </a:rPr>
-              <a:t>Backlog: weekly stats Cloud Function, find a partner (sessions).</a:t>
-            </a:r>
-          </a:p>
-        </p:txBody>
-      </p:sp>
-    </p:spTree>
-  </p:cSld>
-  <p:clrMapOvr>
-    <a:masterClrMapping/>
-  </p:clrMapOvr>
-</p:sld>
-</file>
-
-<file path=ppt/slides/slide11.xml><?xml version="1.0" encoding="utf-8"?>
-<p:sld xmlns:a="http://schemas.openxmlformats.org/drawingml/2006/main" xmlns:p="http://schemas.openxmlformats.org/presentationml/2006/main" xmlns:r="http://schemas.openxmlformats.org/officeDocument/2006/relationships">
-  <p:cSld>
-    <p:spTree>
-      <p:nvGrpSpPr>
-        <p:cNvPr id="1" name=""/>
-        <p:cNvGrpSpPr/>
-        <p:nvPr/>
-      </p:nvGrpSpPr>
-      <p:grpSpPr/>
-      <p:sp>
-        <p:nvSpPr>
-          <p:cNvPr id="2" name="Rectangle 1"/>
-          <p:cNvSpPr/>
-          <p:nvPr/>
-        </p:nvSpPr>
-        <p:spPr>
-          <a:xfrm>
-            <a:off x="0" y="0"/>
-            <a:ext cx="12191695" cy="1097280"/>
-          </a:xfrm>
-          <a:prstGeom prst="rect">
-            <a:avLst/>
-          </a:prstGeom>
-          <a:solidFill>
-            <a:srgbClr val="111827"/>
-          </a:solidFill>
-          <a:ln>
-            <a:noFill/>
-          </a:ln>
-          <a:effectLst/>
-        </p:spPr>
-        <p:style>
-          <a:lnRef idx="1">
-            <a:schemeClr val="accent1"/>
-          </a:lnRef>
-          <a:fillRef idx="3">
-            <a:schemeClr val="accent1"/>
-          </a:fillRef>
-          <a:effectRef idx="2">
-            <a:schemeClr val="accent1"/>
-          </a:effectRef>
-          <a:fontRef idx="minor">
-            <a:schemeClr val="lt1"/>
-          </a:fontRef>
-        </p:style>
-        <p:txBody>
-          <a:bodyPr rtlCol="0" anchor="ctr" wrap="square" lIns="457200" rIns="457200" tIns="73152" bIns="73152"/>
-          <a:lstStyle/>
-          <a:p>
-            <a:pPr algn="ctr"/>
-            <a:r>
-              <a:rPr sz="3200" b="1">
-                <a:solidFill>
-                  <a:srgbClr val="FFFFFF"/>
-                </a:solidFill>
-              </a:rPr>
               <a:t>Team and roles</a:t>
             </a:r>
           </a:p>
@@ -4274,7 +3761,7 @@
 </p:sld>
 </file>
 
-<file path=ppt/slides/slide12.xml><?xml version="1.0" encoding="utf-8"?>
+<file path=ppt/slides/slide11.xml><?xml version="1.0" encoding="utf-8"?>
 <p:sld xmlns:a="http://schemas.openxmlformats.org/drawingml/2006/main" xmlns:p="http://schemas.openxmlformats.org/presentationml/2006/main" xmlns:r="http://schemas.openxmlformats.org/officeDocument/2006/relationships">
   <p:cSld>
     <p:spTree>
@@ -4858,7 +4345,7 @@
 </p:sld>
 </file>
 
-<file path=ppt/slides/slide13.xml><?xml version="1.0" encoding="utf-8"?>
+<file path=ppt/slides/slide12.xml><?xml version="1.0" encoding="utf-8"?>
 <p:sld xmlns:a="http://schemas.openxmlformats.org/drawingml/2006/main" xmlns:p="http://schemas.openxmlformats.org/presentationml/2006/main" xmlns:r="http://schemas.openxmlformats.org/officeDocument/2006/relationships">
   <p:cSld>
     <p:spTree>
@@ -5231,7 +4718,7 @@
 </p:sld>
 </file>
 
-<file path=ppt/slides/slide14.xml><?xml version="1.0" encoding="utf-8"?>
+<file path=ppt/slides/slide13.xml><?xml version="1.0" encoding="utf-8"?>
 <p:sld xmlns:a="http://schemas.openxmlformats.org/drawingml/2006/main" xmlns:p="http://schemas.openxmlformats.org/presentationml/2006/main" xmlns:r="http://schemas.openxmlformats.org/officeDocument/2006/relationships">
   <p:cSld>
     <p:spTree>
@@ -5288,7 +4775,7 @@
                   <a:srgbClr val="FFFFFF"/>
                 </a:solidFill>
               </a:rPr>
-              <a:t>Where we are now</a:t>
+              <a:t>What's next</a:t>
             </a:r>
           </a:p>
           <a:p>
@@ -5299,7 +4786,7 @@
                   <a:srgbClr val="FDBA74"/>
                 </a:solidFill>
               </a:rPr>
-              <a:t>Lab 1 checklist: done and still to do</a:t>
+              <a:t>Lab 1 delivers the walking skeleton</a:t>
             </a:r>
           </a:p>
         </p:txBody>
@@ -5348,296 +4835,187 @@
           </a:p>
         </p:txBody>
       </p:sp>
-      <p:graphicFrame>
-        <p:nvGraphicFramePr>
-          <p:cNvPr id="4" name="Table 3"/>
-          <p:cNvGraphicFramePr>
-            <a:graphicFrameLocks noGrp="1"/>
-          </p:cNvGraphicFramePr>
+      <p:sp>
+        <p:nvSpPr>
+          <p:cNvPr id="4" name="TextBox 3"/>
+          <p:cNvSpPr txBox="1"/>
           <p:nvPr/>
-        </p:nvGraphicFramePr>
-        <p:xfrm>
-          <a:off x="640080" y="1645920"/>
-          <a:ext cx="10881360" cy="4663440"/>
-        </p:xfrm>
-        <a:graphic>
-          <a:graphicData uri="http://schemas.openxmlformats.org/drawingml/2006/table">
-            <a:tbl>
-              <a:tblPr firstRow="1" bandRow="1">
-                <a:tableStyleId>{5C22544A-7EE6-4342-B048-85BDC9FD1C3A}</a:tableStyleId>
-              </a:tblPr>
-              <a:tblGrid>
-                <a:gridCol w="5440680"/>
-                <a:gridCol w="5440680"/>
-              </a:tblGrid>
-              <a:tr h="777240">
-                <a:tc>
-                  <a:txBody>
-                    <a:bodyPr/>
-                    <a:lstStyle/>
-                    <a:p>
-                      <a:r>
-                        <a:rPr sz="1500" b="1">
-                          <a:solidFill>
-                            <a:srgbClr val="FFFFFF"/>
-                          </a:solidFill>
-                        </a:rPr>
-                        <a:t>Done</a:t>
-                      </a:r>
-                    </a:p>
-                  </a:txBody>
-                  <a:tcPr>
-                    <a:solidFill>
-                      <a:srgbClr val="111827"/>
-                    </a:solidFill>
-                  </a:tcPr>
-                </a:tc>
-                <a:tc>
-                  <a:txBody>
-                    <a:bodyPr/>
-                    <a:lstStyle/>
-                    <a:p>
-                      <a:r>
-                        <a:rPr sz="1500" b="1">
-                          <a:solidFill>
-                            <a:srgbClr val="FFFFFF"/>
-                          </a:solidFill>
-                        </a:rPr>
-                        <a:t>Still to do</a:t>
-                      </a:r>
-                    </a:p>
-                  </a:txBody>
-                  <a:tcPr>
-                    <a:solidFill>
-                      <a:srgbClr val="111827"/>
-                    </a:solidFill>
-                  </a:tcPr>
-                </a:tc>
-              </a:tr>
-              <a:tr h="777240">
-                <a:tc>
-                  <a:txBody>
-                    <a:bodyPr/>
-                    <a:lstStyle/>
-                    <a:p>
-                      <a:r>
-                        <a:rPr sz="1500" b="0">
-                          <a:solidFill>
-                            <a:srgbClr val="0F172A"/>
-                          </a:solidFill>
-                        </a:rPr>
-                        <a:t>Problem statement, MVP, data model and architecture in the README</a:t>
-                      </a:r>
-                    </a:p>
-                  </a:txBody>
-                  <a:tcPr>
-                    <a:solidFill>
-                      <a:srgbClr val="F1F5F9"/>
-                    </a:solidFill>
-                  </a:tcPr>
-                </a:tc>
-                <a:tc>
-                  <a:txBody>
-                    <a:bodyPr/>
-                    <a:lstStyle/>
-                    <a:p>
-                      <a:r>
-                        <a:rPr sz="1500" b="0">
-                          <a:solidFill>
-                            <a:srgbClr val="0F172A"/>
-                          </a:solidFill>
-                        </a:rPr>
-                        <a:t>Sprint board with 5 columns and issues in the right columns</a:t>
-                      </a:r>
-                    </a:p>
-                  </a:txBody>
-                  <a:tcPr>
-                    <a:solidFill>
-                      <a:srgbClr val="F1F5F9"/>
-                    </a:solidFill>
-                  </a:tcPr>
-                </a:tc>
-              </a:tr>
-              <a:tr h="777240">
-                <a:tc>
-                  <a:txBody>
-                    <a:bodyPr/>
-                    <a:lstStyle/>
-                    <a:p>
-                      <a:r>
-                        <a:rPr sz="1500" b="0">
-                          <a:solidFill>
-                            <a:srgbClr val="0F172A"/>
-                          </a:solidFill>
-                        </a:rPr>
-                        <a:t>Public repo, first push to main, PR template</a:t>
-                      </a:r>
-                    </a:p>
-                  </a:txBody>
-                  <a:tcPr>
-                    <a:solidFill>
-                      <a:srgbClr val="FFFFFF"/>
-                    </a:solidFill>
-                  </a:tcPr>
-                </a:tc>
-                <a:tc>
-                  <a:txBody>
-                    <a:bodyPr/>
-                    <a:lstStyle/>
-                    <a:p>
-                      <a:r>
-                        <a:rPr sz="1500" b="0">
-                          <a:solidFill>
-                            <a:srgbClr val="0F172A"/>
-                          </a:solidFill>
-                        </a:rPr>
-                        <a:t>Ruleset protecting main (PR required, no force push)</a:t>
-                      </a:r>
-                    </a:p>
-                  </a:txBody>
-                  <a:tcPr>
-                    <a:solidFill>
-                      <a:srgbClr val="FFFFFF"/>
-                    </a:solidFill>
-                  </a:tcPr>
-                </a:tc>
-              </a:tr>
-              <a:tr h="777240">
-                <a:tc>
-                  <a:txBody>
-                    <a:bodyPr/>
-                    <a:lstStyle/>
-                    <a:p>
-                      <a:r>
-                        <a:rPr sz="1500" b="0">
-                          <a:solidFill>
-                            <a:srgbClr val="0F172A"/>
-                          </a:solidFill>
-                        </a:rPr>
-                        <a:t>Labels and 6 issues with user story and acceptance criteria</a:t>
-                      </a:r>
-                    </a:p>
-                  </a:txBody>
-                  <a:tcPr>
-                    <a:solidFill>
-                      <a:srgbClr val="F1F5F9"/>
-                    </a:solidFill>
-                  </a:tcPr>
-                </a:tc>
-                <a:tc>
-                  <a:txBody>
-                    <a:bodyPr/>
-                    <a:lstStyle/>
-                    <a:p>
-                      <a:r>
-                        <a:rPr sz="1500" b="0">
-                          <a:solidFill>
-                            <a:srgbClr val="0F172A"/>
-                          </a:solidFill>
-                        </a:rPr>
-                        <a:t>Assignees on every Sprint 1 issue (teammates must accept their invitations)</a:t>
-                      </a:r>
-                    </a:p>
-                  </a:txBody>
-                  <a:tcPr>
-                    <a:solidFill>
-                      <a:srgbClr val="F1F5F9"/>
-                    </a:solidFill>
-                  </a:tcPr>
-                </a:tc>
-              </a:tr>
-              <a:tr h="777240">
-                <a:tc>
-                  <a:txBody>
-                    <a:bodyPr/>
-                    <a:lstStyle/>
-                    <a:p>
-                      <a:r>
-                        <a:rPr sz="1500" b="0">
-                          <a:solidFill>
-                            <a:srgbClr val="0F172A"/>
-                          </a:solidFill>
-                        </a:rPr>
-                        <a:t>Authentication code: repository, validator, ViewModel, screens, navigation</a:t>
-                      </a:r>
-                    </a:p>
-                  </a:txBody>
-                  <a:tcPr>
-                    <a:solidFill>
-                      <a:srgbClr val="FFFFFF"/>
-                    </a:solidFill>
-                  </a:tcPr>
-                </a:tc>
-                <a:tc>
-                  <a:txBody>
-                    <a:bodyPr/>
-                    <a:lstStyle/>
-                    <a:p>
-                      <a:r>
-                        <a:rPr sz="1500" b="0">
-                          <a:solidFill>
-                            <a:srgbClr val="0F172A"/>
-                          </a:solidFill>
-                        </a:rPr>
-                        <a:t>Firebase project, google-services.json, Email/Password sign-in, test on the emulator</a:t>
-                      </a:r>
-                    </a:p>
-                  </a:txBody>
-                  <a:tcPr>
-                    <a:solidFill>
-                      <a:srgbClr val="FFFFFF"/>
-                    </a:solidFill>
-                  </a:tcPr>
-                </a:tc>
-              </a:tr>
-              <a:tr h="777240">
-                <a:tc>
-                  <a:txBody>
-                    <a:bodyPr/>
-                    <a:lstStyle/>
-                    <a:p>
-                      <a:r>
-                        <a:rPr sz="1500" b="0">
-                          <a:solidFill>
-                            <a:srgbClr val="0F172A"/>
-                          </a:solidFill>
-                        </a:rPr>
-                        <a:t>PR #7 merged (project overview)</a:t>
-                      </a:r>
-                    </a:p>
-                  </a:txBody>
-                  <a:tcPr>
-                    <a:solidFill>
-                      <a:srgbClr val="F1F5F9"/>
-                    </a:solidFill>
-                  </a:tcPr>
-                </a:tc>
-                <a:tc>
-                  <a:txBody>
-                    <a:bodyPr/>
-                    <a:lstStyle/>
-                    <a:p>
-                      <a:r>
-                        <a:rPr sz="1500" b="0">
-                          <a:solidFill>
-                            <a:srgbClr val="0F172A"/>
-                          </a:solidFill>
-                        </a:rPr>
-                        <a:t>At least two merged PRs, each with a teammate review; Retro – Lab 1 issue</a:t>
-                      </a:r>
-                    </a:p>
-                  </a:txBody>
-                  <a:tcPr>
-                    <a:solidFill>
-                      <a:srgbClr val="F1F5F9"/>
-                    </a:solidFill>
-                  </a:tcPr>
-                </a:tc>
-              </a:tr>
-            </a:tbl>
-          </a:graphicData>
-        </a:graphic>
-      </p:graphicFrame>
+        </p:nvSpPr>
+        <p:spPr>
+          <a:xfrm>
+            <a:off x="640080" y="1645920"/>
+            <a:ext cx="10881360" cy="3657600"/>
+          </a:xfrm>
+          <a:prstGeom prst="rect">
+            <a:avLst/>
+          </a:prstGeom>
+          <a:noFill/>
+        </p:spPr>
+        <p:txBody>
+          <a:bodyPr wrap="square">
+            <a:spAutoFit/>
+          </a:bodyPr>
+          <a:lstStyle/>
+          <a:p>
+            <a:pPr algn="l">
+              <a:spcAft>
+                <a:spcPts val="1000"/>
+              </a:spcAft>
+            </a:pPr>
+            <a:r>
+              <a:rPr sz="2200" b="1">
+                <a:solidFill>
+                  <a:srgbClr val="F97316"/>
+                </a:solidFill>
+              </a:rPr>
+              <a:t>•  </a:t>
+            </a:r>
+            <a:r>
+              <a:rPr sz="2200" b="1">
+                <a:solidFill>
+                  <a:srgbClr val="0F172A"/>
+                </a:solidFill>
+              </a:rPr>
+              <a:t>Lab 1:</a:t>
+            </a:r>
+            <a:r>
+              <a:rPr sz="2200" b="0">
+                <a:solidFill>
+                  <a:srgbClr val="64748B"/>
+                </a:solidFill>
+              </a:rPr>
+              <a:t> repo, board, Firebase project, register / login / logout / auto-login.</a:t>
+            </a:r>
+          </a:p>
+          <a:p>
+            <a:pPr algn="l">
+              <a:spcAft>
+                <a:spcPts val="1000"/>
+              </a:spcAft>
+            </a:pPr>
+            <a:r>
+              <a:rPr sz="2200" b="1">
+                <a:solidFill>
+                  <a:srgbClr val="F97316"/>
+                </a:solidFill>
+              </a:rPr>
+              <a:t>•  </a:t>
+            </a:r>
+            <a:r>
+              <a:rPr sz="2200" b="1">
+                <a:solidFill>
+                  <a:srgbClr val="0F172A"/>
+                </a:solidFill>
+              </a:rPr>
+              <a:t>Lab 2:</a:t>
+            </a:r>
+            <a:r>
+              <a:rPr sz="2200" b="0">
+                <a:solidFill>
+                  <a:srgbClr val="64748B"/>
+                </a:solidFill>
+              </a:rPr>
+              <a:t> workouts in Firestore – list, add, edit, delete – and Security Rules.</a:t>
+            </a:r>
+          </a:p>
+          <a:p>
+            <a:pPr algn="l">
+              <a:spcAft>
+                <a:spcPts val="1000"/>
+              </a:spcAft>
+            </a:pPr>
+            <a:r>
+              <a:rPr sz="2200" b="1">
+                <a:solidFill>
+                  <a:srgbClr val="F97316"/>
+                </a:solidFill>
+              </a:rPr>
+              <a:t>•  </a:t>
+            </a:r>
+            <a:r>
+              <a:rPr sz="2200" b="1">
+                <a:solidFill>
+                  <a:srgbClr val="0F172A"/>
+                </a:solidFill>
+              </a:rPr>
+              <a:t>Lab 3:</a:t>
+            </a:r>
+            <a:r>
+              <a:rPr sz="2200" b="0">
+                <a:solidFill>
+                  <a:srgbClr val="64748B"/>
+                </a:solidFill>
+              </a:rPr>
+              <a:t> Cloud Function for weekly stats, unit tests for the validator.</a:t>
+            </a:r>
+          </a:p>
+          <a:p>
+            <a:pPr algn="l">
+              <a:spcAft>
+                <a:spcPts val="1000"/>
+              </a:spcAft>
+            </a:pPr>
+            <a:r>
+              <a:rPr sz="2200" b="1">
+                <a:solidFill>
+                  <a:srgbClr val="F97316"/>
+                </a:solidFill>
+              </a:rPr>
+              <a:t>•  </a:t>
+            </a:r>
+            <a:r>
+              <a:rPr sz="2200" b="1">
+                <a:solidFill>
+                  <a:srgbClr val="0F172A"/>
+                </a:solidFill>
+              </a:rPr>
+              <a:t>Retro – Lab 1:</a:t>
+            </a:r>
+            <a:r>
+              <a:rPr sz="2200" b="0">
+                <a:solidFill>
+                  <a:srgbClr val="64748B"/>
+                </a:solidFill>
+              </a:rPr>
+              <a:t> one issue, every member comments: went well / did not go well / we will change.</a:t>
+            </a:r>
+          </a:p>
+        </p:txBody>
+      </p:sp>
+      <p:sp>
+        <p:nvSpPr>
+          <p:cNvPr id="5" name="TextBox 4"/>
+          <p:cNvSpPr txBox="1"/>
+          <p:nvPr/>
+        </p:nvSpPr>
+        <p:spPr>
+          <a:xfrm>
+            <a:off x="640080" y="5486400"/>
+            <a:ext cx="10881360" cy="914400"/>
+          </a:xfrm>
+          <a:prstGeom prst="rect">
+            <a:avLst/>
+          </a:prstGeom>
+          <a:noFill/>
+        </p:spPr>
+        <p:txBody>
+          <a:bodyPr wrap="none">
+            <a:spAutoFit/>
+          </a:bodyPr>
+          <a:lstStyle/>
+          <a:p>
+            <a:pPr algn="l"/>
+            <a:r>
+              <a:rPr sz="3000" b="1">
+                <a:solidFill>
+                  <a:srgbClr val="C2410C"/>
+                </a:solidFill>
+              </a:rPr>
+              <a:t>Thank you – questions?</a:t>
+            </a:r>
+          </a:p>
+        </p:txBody>
+      </p:sp>
     </p:spTree>
   </p:cSld>
   <p:clrMapOvr>
@@ -5646,7 +5024,7 @@
 </p:sld>
 </file>
 
-<file path=ppt/slides/slide15.xml><?xml version="1.0" encoding="utf-8"?>
+<file path=ppt/slides/slide2.xml><?xml version="1.0" encoding="utf-8"?>
 <p:sld xmlns:a="http://schemas.openxmlformats.org/drawingml/2006/main" xmlns:p="http://schemas.openxmlformats.org/presentationml/2006/main" xmlns:r="http://schemas.openxmlformats.org/officeDocument/2006/relationships">
   <p:cSld>
     <p:spTree>
@@ -5703,7 +5081,7 @@
                   <a:srgbClr val="FFFFFF"/>
                 </a:solidFill>
               </a:rPr>
-              <a:t>What's next</a:t>
+              <a:t>What is GymBuddy?</a:t>
             </a:r>
           </a:p>
           <a:p>
@@ -5714,7 +5092,7 @@
                   <a:srgbClr val="FDBA74"/>
                 </a:solidFill>
               </a:rPr>
-              <a:t>Lab 1 delivers the walking skeleton</a:t>
+              <a:t>An Android app backed by the cloud</a:t>
             </a:r>
           </a:p>
         </p:txBody>
@@ -5771,8 +5149,8 @@
         </p:nvSpPr>
         <p:spPr>
           <a:xfrm>
-            <a:off x="640080" y="1645920"/>
-            <a:ext cx="10881360" cy="3657600"/>
+            <a:off x="640080" y="1554480"/>
+            <a:ext cx="6583680" cy="4572000"/>
           </a:xfrm>
           <a:prstGeom prst="rect">
             <a:avLst/>
@@ -5804,7 +5182,7 @@
                   <a:srgbClr val="0F172A"/>
                 </a:solidFill>
               </a:rPr>
-              <a:t>Lab 1:</a:t>
+              <a:t>Gym + Buddy:</a:t>
             </a:r>
             <a:r>
               <a:rPr sz="2200" b="0">
@@ -5812,7 +5190,7 @@
                   <a:srgbClr val="64748B"/>
                 </a:solidFill>
               </a:rPr>
-              <a:t> repo, board, Firebase project, register / login / logout / auto-login.</a:t>
+              <a:t> your workout log and your training partner finder in one app.</a:t>
             </a:r>
           </a:p>
           <a:p>
@@ -5835,7 +5213,7 @@
                   <a:srgbClr val="0F172A"/>
                 </a:solidFill>
               </a:rPr>
-              <a:t>Lab 2:</a:t>
+              <a:t>Log:</a:t>
             </a:r>
             <a:r>
               <a:rPr sz="2200" b="0">
@@ -5843,7 +5221,7 @@
                   <a:srgbClr val="64748B"/>
                 </a:solidFill>
               </a:rPr>
-              <a:t> workouts in Firestore – list, add, edit, delete – and Security Rules.</a:t>
+              <a:t> record each workout (type, duration, notes) and see your history and weekly progress.</a:t>
             </a:r>
           </a:p>
           <a:p>
@@ -5866,7 +5244,7 @@
                   <a:srgbClr val="0F172A"/>
                 </a:solidFill>
               </a:rPr>
-              <a:t>Lab 3:</a:t>
+              <a:t>Find:</a:t>
             </a:r>
             <a:r>
               <a:rPr sz="2200" b="0">
@@ -5874,7 +5252,7 @@
                   <a:srgbClr val="64748B"/>
                 </a:solidFill>
               </a:rPr>
-              <a:t> Cloud Function for weekly stats, unit tests for the validator.</a:t>
+              <a:t> post or join open training sessions, so you never have to train alone.</a:t>
             </a:r>
           </a:p>
           <a:p>
@@ -5897,7 +5275,7 @@
                   <a:srgbClr val="0F172A"/>
                 </a:solidFill>
               </a:rPr>
-              <a:t>Retro – Lab 1:</a:t>
+              <a:t>Cloud:</a:t>
             </a:r>
             <a:r>
               <a:rPr sz="2200" b="0">
@@ -5905,41 +5283,74 @@
                   <a:srgbClr val="64748B"/>
                 </a:solidFill>
               </a:rPr>
-              <a:t> one issue, every member comments: went well / did not go well / we will change.</a:t>
-            </a:r>
-          </a:p>
-        </p:txBody>
-      </p:sp>
-      <p:sp>
-        <p:nvSpPr>
-          <p:cNvPr id="5" name="TextBox 4"/>
-          <p:cNvSpPr txBox="1"/>
+              <a:t> everything is stored in Firebase, so your data follows you to any phone.</a:t>
+            </a:r>
+          </a:p>
+        </p:txBody>
+      </p:sp>
+      <p:sp>
+        <p:nvSpPr>
+          <p:cNvPr id="5" name="Rounded Rectangle 4"/>
+          <p:cNvSpPr/>
           <p:nvPr/>
         </p:nvSpPr>
         <p:spPr>
           <a:xfrm>
-            <a:off x="640080" y="5486400"/>
-            <a:ext cx="10881360" cy="914400"/>
+            <a:off x="7589520" y="1737360"/>
+            <a:ext cx="4023360" cy="4206240"/>
           </a:xfrm>
-          <a:prstGeom prst="rect">
+          <a:prstGeom prst="roundRect">
             <a:avLst/>
           </a:prstGeom>
-          <a:noFill/>
+          <a:solidFill>
+            <a:srgbClr val="F1F5F9"/>
+          </a:solidFill>
+          <a:ln>
+            <a:noFill/>
+          </a:ln>
+          <a:effectLst/>
         </p:spPr>
-        <p:txBody>
-          <a:bodyPr wrap="none">
-            <a:spAutoFit/>
-          </a:bodyPr>
-          <a:lstStyle/>
-          <a:p>
-            <a:pPr algn="l"/>
-            <a:r>
-              <a:rPr sz="3000" b="1">
+        <p:style>
+          <a:lnRef idx="1">
+            <a:schemeClr val="accent1"/>
+          </a:lnRef>
+          <a:fillRef idx="3">
+            <a:schemeClr val="accent1"/>
+          </a:fillRef>
+          <a:effectRef idx="2">
+            <a:schemeClr val="accent1"/>
+          </a:effectRef>
+          <a:fontRef idx="minor">
+            <a:schemeClr val="lt1"/>
+          </a:fontRef>
+        </p:style>
+        <p:txBody>
+          <a:bodyPr rtlCol="0" anchor="ctr" wrap="square" lIns="274320" rIns="274320" tIns="73152" bIns="73152"/>
+          <a:lstStyle/>
+          <a:p>
+            <a:pPr algn="ctr"/>
+            <a:r>
+              <a:rPr sz="2200" b="1">
                 <a:solidFill>
                   <a:srgbClr val="C2410C"/>
                 </a:solidFill>
               </a:rPr>
-              <a:t>Thank you – questions?</a:t>
+              <a:t>Why the name?</a:t>
+            </a:r>
+          </a:p>
+          <a:p>
+            <a:pPr algn="l">
+              <a:spcBef>
+                <a:spcPts val="1000"/>
+              </a:spcBef>
+            </a:pPr>
+            <a:r>
+              <a:rPr sz="1800" b="0">
+                <a:solidFill>
+                  <a:srgbClr val="0F172A"/>
+                </a:solidFill>
+              </a:rPr>
+              <a:t>“Buddy” is the gym word for a training partner. People who train with a partner skip fewer sessions – so the name says what the app is for: staying consistent, together.</a:t>
             </a:r>
           </a:p>
         </p:txBody>
@@ -5952,7 +5363,7 @@
 </p:sld>
 </file>
 
-<file path=ppt/slides/slide2.xml><?xml version="1.0" encoding="utf-8"?>
+<file path=ppt/slides/slide3.xml><?xml version="1.0" encoding="utf-8"?>
 <p:sld xmlns:a="http://schemas.openxmlformats.org/drawingml/2006/main" xmlns:p="http://schemas.openxmlformats.org/presentationml/2006/main" xmlns:r="http://schemas.openxmlformats.org/officeDocument/2006/relationships">
   <p:cSld>
     <p:spTree>
@@ -6009,7 +5420,7 @@
                   <a:srgbClr val="FFFFFF"/>
                 </a:solidFill>
               </a:rPr>
-              <a:t>What is GymBuddy?</a:t>
+              <a:t>The problem</a:t>
             </a:r>
           </a:p>
           <a:p>
@@ -6020,7 +5431,7 @@
                   <a:srgbClr val="FDBA74"/>
                 </a:solidFill>
               </a:rPr>
-              <a:t>An Android app backed by the cloud</a:t>
+              <a:t>One sentence: who has what problem, and why it matters</a:t>
             </a:r>
           </a:p>
         </p:txBody>
@@ -6071,838 +5482,6 @@
       </p:sp>
       <p:sp>
         <p:nvSpPr>
-          <p:cNvPr id="4" name="TextBox 3"/>
-          <p:cNvSpPr txBox="1"/>
-          <p:nvPr/>
-        </p:nvSpPr>
-        <p:spPr>
-          <a:xfrm>
-            <a:off x="640080" y="1554480"/>
-            <a:ext cx="6583680" cy="4572000"/>
-          </a:xfrm>
-          <a:prstGeom prst="rect">
-            <a:avLst/>
-          </a:prstGeom>
-          <a:noFill/>
-        </p:spPr>
-        <p:txBody>
-          <a:bodyPr wrap="square">
-            <a:spAutoFit/>
-          </a:bodyPr>
-          <a:lstStyle/>
-          <a:p>
-            <a:pPr algn="l">
-              <a:spcAft>
-                <a:spcPts val="1000"/>
-              </a:spcAft>
-            </a:pPr>
-            <a:r>
-              <a:rPr sz="2200" b="1">
-                <a:solidFill>
-                  <a:srgbClr val="F97316"/>
-                </a:solidFill>
-              </a:rPr>
-              <a:t>•  </a:t>
-            </a:r>
-            <a:r>
-              <a:rPr sz="2200" b="1">
-                <a:solidFill>
-                  <a:srgbClr val="0F172A"/>
-                </a:solidFill>
-              </a:rPr>
-              <a:t>Gym + Buddy:</a:t>
-            </a:r>
-            <a:r>
-              <a:rPr sz="2200" b="0">
-                <a:solidFill>
-                  <a:srgbClr val="64748B"/>
-                </a:solidFill>
-              </a:rPr>
-              <a:t> your workout log and your training partner finder in one app.</a:t>
-            </a:r>
-          </a:p>
-          <a:p>
-            <a:pPr algn="l">
-              <a:spcAft>
-                <a:spcPts val="1000"/>
-              </a:spcAft>
-            </a:pPr>
-            <a:r>
-              <a:rPr sz="2200" b="1">
-                <a:solidFill>
-                  <a:srgbClr val="F97316"/>
-                </a:solidFill>
-              </a:rPr>
-              <a:t>•  </a:t>
-            </a:r>
-            <a:r>
-              <a:rPr sz="2200" b="1">
-                <a:solidFill>
-                  <a:srgbClr val="0F172A"/>
-                </a:solidFill>
-              </a:rPr>
-              <a:t>Log:</a:t>
-            </a:r>
-            <a:r>
-              <a:rPr sz="2200" b="0">
-                <a:solidFill>
-                  <a:srgbClr val="64748B"/>
-                </a:solidFill>
-              </a:rPr>
-              <a:t> record each workout (type, duration, notes) and see your history and weekly progress.</a:t>
-            </a:r>
-          </a:p>
-          <a:p>
-            <a:pPr algn="l">
-              <a:spcAft>
-                <a:spcPts val="1000"/>
-              </a:spcAft>
-            </a:pPr>
-            <a:r>
-              <a:rPr sz="2200" b="1">
-                <a:solidFill>
-                  <a:srgbClr val="F97316"/>
-                </a:solidFill>
-              </a:rPr>
-              <a:t>•  </a:t>
-            </a:r>
-            <a:r>
-              <a:rPr sz="2200" b="1">
-                <a:solidFill>
-                  <a:srgbClr val="0F172A"/>
-                </a:solidFill>
-              </a:rPr>
-              <a:t>Find:</a:t>
-            </a:r>
-            <a:r>
-              <a:rPr sz="2200" b="0">
-                <a:solidFill>
-                  <a:srgbClr val="64748B"/>
-                </a:solidFill>
-              </a:rPr>
-              <a:t> post or join open training sessions, so you never have to train alone.</a:t>
-            </a:r>
-          </a:p>
-          <a:p>
-            <a:pPr algn="l">
-              <a:spcAft>
-                <a:spcPts val="1000"/>
-              </a:spcAft>
-            </a:pPr>
-            <a:r>
-              <a:rPr sz="2200" b="1">
-                <a:solidFill>
-                  <a:srgbClr val="F97316"/>
-                </a:solidFill>
-              </a:rPr>
-              <a:t>•  </a:t>
-            </a:r>
-            <a:r>
-              <a:rPr sz="2200" b="1">
-                <a:solidFill>
-                  <a:srgbClr val="0F172A"/>
-                </a:solidFill>
-              </a:rPr>
-              <a:t>Cloud:</a:t>
-            </a:r>
-            <a:r>
-              <a:rPr sz="2200" b="0">
-                <a:solidFill>
-                  <a:srgbClr val="64748B"/>
-                </a:solidFill>
-              </a:rPr>
-              <a:t> everything is stored in Firebase, so your data follows you to any phone.</a:t>
-            </a:r>
-          </a:p>
-        </p:txBody>
-      </p:sp>
-      <p:sp>
-        <p:nvSpPr>
-          <p:cNvPr id="5" name="Rounded Rectangle 4"/>
-          <p:cNvSpPr/>
-          <p:nvPr/>
-        </p:nvSpPr>
-        <p:spPr>
-          <a:xfrm>
-            <a:off x="7589520" y="1737360"/>
-            <a:ext cx="4023360" cy="4206240"/>
-          </a:xfrm>
-          <a:prstGeom prst="roundRect">
-            <a:avLst/>
-          </a:prstGeom>
-          <a:solidFill>
-            <a:srgbClr val="F1F5F9"/>
-          </a:solidFill>
-          <a:ln>
-            <a:noFill/>
-          </a:ln>
-          <a:effectLst/>
-        </p:spPr>
-        <p:style>
-          <a:lnRef idx="1">
-            <a:schemeClr val="accent1"/>
-          </a:lnRef>
-          <a:fillRef idx="3">
-            <a:schemeClr val="accent1"/>
-          </a:fillRef>
-          <a:effectRef idx="2">
-            <a:schemeClr val="accent1"/>
-          </a:effectRef>
-          <a:fontRef idx="minor">
-            <a:schemeClr val="lt1"/>
-          </a:fontRef>
-        </p:style>
-        <p:txBody>
-          <a:bodyPr rtlCol="0" anchor="ctr" wrap="square" lIns="274320" rIns="274320" tIns="73152" bIns="73152"/>
-          <a:lstStyle/>
-          <a:p>
-            <a:pPr algn="ctr"/>
-            <a:r>
-              <a:rPr sz="2200" b="1">
-                <a:solidFill>
-                  <a:srgbClr val="C2410C"/>
-                </a:solidFill>
-              </a:rPr>
-              <a:t>Why the name?</a:t>
-            </a:r>
-          </a:p>
-          <a:p>
-            <a:pPr algn="l">
-              <a:spcBef>
-                <a:spcPts val="1000"/>
-              </a:spcBef>
-            </a:pPr>
-            <a:r>
-              <a:rPr sz="1800" b="0">
-                <a:solidFill>
-                  <a:srgbClr val="0F172A"/>
-                </a:solidFill>
-              </a:rPr>
-              <a:t>“Buddy” is the gym word for a training partner. People who train with a partner skip fewer sessions – so the name says what the app is for: staying consistent, together.</a:t>
-            </a:r>
-          </a:p>
-        </p:txBody>
-      </p:sp>
-    </p:spTree>
-  </p:cSld>
-  <p:clrMapOvr>
-    <a:masterClrMapping/>
-  </p:clrMapOvr>
-</p:sld>
-</file>
-
-<file path=ppt/slides/slide3.xml><?xml version="1.0" encoding="utf-8"?>
-<p:sld xmlns:a="http://schemas.openxmlformats.org/drawingml/2006/main" xmlns:p="http://schemas.openxmlformats.org/presentationml/2006/main" xmlns:r="http://schemas.openxmlformats.org/officeDocument/2006/relationships">
-  <p:cSld>
-    <p:spTree>
-      <p:nvGrpSpPr>
-        <p:cNvPr id="1" name=""/>
-        <p:cNvGrpSpPr/>
-        <p:nvPr/>
-      </p:nvGrpSpPr>
-      <p:grpSpPr/>
-      <p:sp>
-        <p:nvSpPr>
-          <p:cNvPr id="2" name="Rectangle 1"/>
-          <p:cNvSpPr/>
-          <p:nvPr/>
-        </p:nvSpPr>
-        <p:spPr>
-          <a:xfrm>
-            <a:off x="0" y="0"/>
-            <a:ext cx="12191695" cy="1097280"/>
-          </a:xfrm>
-          <a:prstGeom prst="rect">
-            <a:avLst/>
-          </a:prstGeom>
-          <a:solidFill>
-            <a:srgbClr val="111827"/>
-          </a:solidFill>
-          <a:ln>
-            <a:noFill/>
-          </a:ln>
-          <a:effectLst/>
-        </p:spPr>
-        <p:style>
-          <a:lnRef idx="1">
-            <a:schemeClr val="accent1"/>
-          </a:lnRef>
-          <a:fillRef idx="3">
-            <a:schemeClr val="accent1"/>
-          </a:fillRef>
-          <a:effectRef idx="2">
-            <a:schemeClr val="accent1"/>
-          </a:effectRef>
-          <a:fontRef idx="minor">
-            <a:schemeClr val="lt1"/>
-          </a:fontRef>
-        </p:style>
-        <p:txBody>
-          <a:bodyPr rtlCol="0" anchor="ctr" wrap="square" lIns="457200" rIns="457200" tIns="73152" bIns="73152"/>
-          <a:lstStyle/>
-          <a:p>
-            <a:pPr algn="ctr"/>
-            <a:r>
-              <a:rPr sz="3200" b="1">
-                <a:solidFill>
-                  <a:srgbClr val="FFFFFF"/>
-                </a:solidFill>
-              </a:rPr>
-              <a:t>Where GymBuddy can be used</a:t>
-            </a:r>
-          </a:p>
-          <a:p>
-            <a:pPr algn="l"/>
-            <a:r>
-              <a:rPr sz="1500" b="0">
-                <a:solidFill>
-                  <a:srgbClr val="FDBA74"/>
-                </a:solidFill>
-              </a:rPr>
-              <a:t>The same app helps different groups</a:t>
-            </a:r>
-          </a:p>
-        </p:txBody>
-      </p:sp>
-      <p:sp>
-        <p:nvSpPr>
-          <p:cNvPr id="3" name="Rectangle 2"/>
-          <p:cNvSpPr/>
-          <p:nvPr/>
-        </p:nvSpPr>
-        <p:spPr>
-          <a:xfrm>
-            <a:off x="0" y="1097280"/>
-            <a:ext cx="12191695" cy="64008"/>
-          </a:xfrm>
-          <a:prstGeom prst="rect">
-            <a:avLst/>
-          </a:prstGeom>
-          <a:solidFill>
-            <a:srgbClr val="F97316"/>
-          </a:solidFill>
-          <a:ln>
-            <a:noFill/>
-          </a:ln>
-          <a:effectLst/>
-        </p:spPr>
-        <p:style>
-          <a:lnRef idx="1">
-            <a:schemeClr val="accent1"/>
-          </a:lnRef>
-          <a:fillRef idx="3">
-            <a:schemeClr val="accent1"/>
-          </a:fillRef>
-          <a:effectRef idx="2">
-            <a:schemeClr val="accent1"/>
-          </a:effectRef>
-          <a:fontRef idx="minor">
-            <a:schemeClr val="lt1"/>
-          </a:fontRef>
-        </p:style>
-        <p:txBody>
-          <a:bodyPr rtlCol="0" anchor="ctr"/>
-          <a:lstStyle/>
-          <a:p>
-            <a:pPr algn="ctr"/>
-          </a:p>
-        </p:txBody>
-      </p:sp>
-      <p:graphicFrame>
-        <p:nvGraphicFramePr>
-          <p:cNvPr id="4" name="Table 3"/>
-          <p:cNvGraphicFramePr>
-            <a:graphicFrameLocks noGrp="1"/>
-          </p:cNvGraphicFramePr>
-          <p:nvPr/>
-        </p:nvGraphicFramePr>
-        <p:xfrm>
-          <a:off x="640080" y="1645920"/>
-          <a:ext cx="10881360" cy="3968496"/>
-        </p:xfrm>
-        <a:graphic>
-          <a:graphicData uri="http://schemas.openxmlformats.org/drawingml/2006/table">
-            <a:tbl>
-              <a:tblPr firstRow="1" bandRow="1">
-                <a:tableStyleId>{5C22544A-7EE6-4342-B048-85BDC9FD1C3A}</a:tableStyleId>
-              </a:tblPr>
-              <a:tblGrid>
-                <a:gridCol w="4023360"/>
-                <a:gridCol w="6858000"/>
-              </a:tblGrid>
-              <a:tr h="566928">
-                <a:tc>
-                  <a:txBody>
-                    <a:bodyPr/>
-                    <a:lstStyle/>
-                    <a:p>
-                      <a:r>
-                        <a:rPr sz="1800" b="1">
-                          <a:solidFill>
-                            <a:srgbClr val="FFFFFF"/>
-                          </a:solidFill>
-                        </a:rPr>
-                        <a:t>Who</a:t>
-                      </a:r>
-                    </a:p>
-                  </a:txBody>
-                  <a:tcPr>
-                    <a:solidFill>
-                      <a:srgbClr val="111827"/>
-                    </a:solidFill>
-                  </a:tcPr>
-                </a:tc>
-                <a:tc>
-                  <a:txBody>
-                    <a:bodyPr/>
-                    <a:lstStyle/>
-                    <a:p>
-                      <a:r>
-                        <a:rPr sz="1800" b="1">
-                          <a:solidFill>
-                            <a:srgbClr val="FFFFFF"/>
-                          </a:solidFill>
-                        </a:rPr>
-                        <a:t>How GymBuddy helps</a:t>
-                      </a:r>
-                    </a:p>
-                  </a:txBody>
-                  <a:tcPr>
-                    <a:solidFill>
-                      <a:srgbClr val="111827"/>
-                    </a:solidFill>
-                  </a:tcPr>
-                </a:tc>
-              </a:tr>
-              <a:tr h="566928">
-                <a:tc>
-                  <a:txBody>
-                    <a:bodyPr/>
-                    <a:lstStyle/>
-                    <a:p>
-                      <a:r>
-                        <a:rPr sz="1800" b="0">
-                          <a:solidFill>
-                            <a:srgbClr val="0F172A"/>
-                          </a:solidFill>
-                        </a:rPr>
-                        <a:t>Individual gym-goers</a:t>
-                      </a:r>
-                    </a:p>
-                  </a:txBody>
-                  <a:tcPr>
-                    <a:solidFill>
-                      <a:srgbClr val="F1F5F9"/>
-                    </a:solidFill>
-                  </a:tcPr>
-                </a:tc>
-                <a:tc>
-                  <a:txBody>
-                    <a:bodyPr/>
-                    <a:lstStyle/>
-                    <a:p>
-                      <a:r>
-                        <a:rPr sz="1800" b="0">
-                          <a:solidFill>
-                            <a:srgbClr val="0F172A"/>
-                          </a:solidFill>
-                        </a:rPr>
-                        <a:t>Keep a simple training history and see weekly progress</a:t>
-                      </a:r>
-                    </a:p>
-                  </a:txBody>
-                  <a:tcPr>
-                    <a:solidFill>
-                      <a:srgbClr val="F1F5F9"/>
-                    </a:solidFill>
-                  </a:tcPr>
-                </a:tc>
-              </a:tr>
-              <a:tr h="566928">
-                <a:tc>
-                  <a:txBody>
-                    <a:bodyPr/>
-                    <a:lstStyle/>
-                    <a:p>
-                      <a:r>
-                        <a:rPr sz="1800" b="0">
-                          <a:solidFill>
-                            <a:srgbClr val="0F172A"/>
-                          </a:solidFill>
-                        </a:rPr>
-                        <a:t>Friends and training groups</a:t>
-                      </a:r>
-                    </a:p>
-                  </a:txBody>
-                  <a:tcPr>
-                    <a:solidFill>
-                      <a:srgbClr val="FFFFFF"/>
-                    </a:solidFill>
-                  </a:tcPr>
-                </a:tc>
-                <a:tc>
-                  <a:txBody>
-                    <a:bodyPr/>
-                    <a:lstStyle/>
-                    <a:p>
-                      <a:r>
-                        <a:rPr sz="1800" b="0">
-                          <a:solidFill>
-                            <a:srgbClr val="0F172A"/>
-                          </a:solidFill>
-                        </a:rPr>
-                        <a:t>Plan shared sessions and see who joined</a:t>
-                      </a:r>
-                    </a:p>
-                  </a:txBody>
-                  <a:tcPr>
-                    <a:solidFill>
-                      <a:srgbClr val="FFFFFF"/>
-                    </a:solidFill>
-                  </a:tcPr>
-                </a:tc>
-              </a:tr>
-              <a:tr h="566928">
-                <a:tc>
-                  <a:txBody>
-                    <a:bodyPr/>
-                    <a:lstStyle/>
-                    <a:p>
-                      <a:r>
-                        <a:rPr sz="1800" b="0">
-                          <a:solidFill>
-                            <a:srgbClr val="0F172A"/>
-                          </a:solidFill>
-                        </a:rPr>
-                        <a:t>Newcomers to a gym</a:t>
-                      </a:r>
-                    </a:p>
-                  </a:txBody>
-                  <a:tcPr>
-                    <a:solidFill>
-                      <a:srgbClr val="F1F5F9"/>
-                    </a:solidFill>
-                  </a:tcPr>
-                </a:tc>
-                <a:tc>
-                  <a:txBody>
-                    <a:bodyPr/>
-                    <a:lstStyle/>
-                    <a:p>
-                      <a:r>
-                        <a:rPr sz="1800" b="0">
-                          <a:solidFill>
-                            <a:srgbClr val="0F172A"/>
-                          </a:solidFill>
-                        </a:rPr>
-                        <a:t>Find a partner instead of training alone</a:t>
-                      </a:r>
-                    </a:p>
-                  </a:txBody>
-                  <a:tcPr>
-                    <a:solidFill>
-                      <a:srgbClr val="F1F5F9"/>
-                    </a:solidFill>
-                  </a:tcPr>
-                </a:tc>
-              </a:tr>
-              <a:tr h="566928">
-                <a:tc>
-                  <a:txBody>
-                    <a:bodyPr/>
-                    <a:lstStyle/>
-                    <a:p>
-                      <a:r>
-                        <a:rPr sz="1800" b="0">
-                          <a:solidFill>
-                            <a:srgbClr val="0F172A"/>
-                          </a:solidFill>
-                        </a:rPr>
-                        <a:t>University sports clubs</a:t>
-                      </a:r>
-                    </a:p>
-                  </a:txBody>
-                  <a:tcPr>
-                    <a:solidFill>
-                      <a:srgbClr val="FFFFFF"/>
-                    </a:solidFill>
-                  </a:tcPr>
-                </a:tc>
-                <a:tc>
-                  <a:txBody>
-                    <a:bodyPr/>
-                    <a:lstStyle/>
-                    <a:p>
-                      <a:r>
-                        <a:rPr sz="1800" b="0">
-                          <a:solidFill>
-                            <a:srgbClr val="0F172A"/>
-                          </a:solidFill>
-                        </a:rPr>
-                        <a:t>Organise open sessions for students and staff</a:t>
-                      </a:r>
-                    </a:p>
-                  </a:txBody>
-                  <a:tcPr>
-                    <a:solidFill>
-                      <a:srgbClr val="FFFFFF"/>
-                    </a:solidFill>
-                  </a:tcPr>
-                </a:tc>
-              </a:tr>
-              <a:tr h="566928">
-                <a:tc>
-                  <a:txBody>
-                    <a:bodyPr/>
-                    <a:lstStyle/>
-                    <a:p>
-                      <a:r>
-                        <a:rPr sz="1800" b="0">
-                          <a:solidFill>
-                            <a:srgbClr val="0F172A"/>
-                          </a:solidFill>
-                        </a:rPr>
-                        <a:t>Workplace wellness programmes</a:t>
-                      </a:r>
-                    </a:p>
-                  </a:txBody>
-                  <a:tcPr>
-                    <a:solidFill>
-                      <a:srgbClr val="F1F5F9"/>
-                    </a:solidFill>
-                  </a:tcPr>
-                </a:tc>
-                <a:tc>
-                  <a:txBody>
-                    <a:bodyPr/>
-                    <a:lstStyle/>
-                    <a:p>
-                      <a:r>
-                        <a:rPr sz="1800" b="0">
-                          <a:solidFill>
-                            <a:srgbClr val="0F172A"/>
-                          </a:solidFill>
-                        </a:rPr>
-                        <a:t>Let colleagues arrange group workouts</a:t>
-                      </a:r>
-                    </a:p>
-                  </a:txBody>
-                  <a:tcPr>
-                    <a:solidFill>
-                      <a:srgbClr val="F1F5F9"/>
-                    </a:solidFill>
-                  </a:tcPr>
-                </a:tc>
-              </a:tr>
-              <a:tr h="566928">
-                <a:tc>
-                  <a:txBody>
-                    <a:bodyPr/>
-                    <a:lstStyle/>
-                    <a:p>
-                      <a:r>
-                        <a:rPr sz="1800" b="0">
-                          <a:solidFill>
-                            <a:srgbClr val="0F172A"/>
-                          </a:solidFill>
-                        </a:rPr>
-                        <a:t>Small gyms and fitness studios</a:t>
-                      </a:r>
-                    </a:p>
-                  </a:txBody>
-                  <a:tcPr>
-                    <a:solidFill>
-                      <a:srgbClr val="FFFFFF"/>
-                    </a:solidFill>
-                  </a:tcPr>
-                </a:tc>
-                <a:tc>
-                  <a:txBody>
-                    <a:bodyPr/>
-                    <a:lstStyle/>
-                    <a:p>
-                      <a:r>
-                        <a:rPr sz="1800" b="0">
-                          <a:solidFill>
-                            <a:srgbClr val="0F172A"/>
-                          </a:solidFill>
-                        </a:rPr>
-                        <a:t>Give members a free way to meet training partners</a:t>
-                      </a:r>
-                    </a:p>
-                  </a:txBody>
-                  <a:tcPr>
-                    <a:solidFill>
-                      <a:srgbClr val="FFFFFF"/>
-                    </a:solidFill>
-                  </a:tcPr>
-                </a:tc>
-              </a:tr>
-            </a:tbl>
-          </a:graphicData>
-        </a:graphic>
-      </p:graphicFrame>
-      <p:sp>
-        <p:nvSpPr>
-          <p:cNvPr id="5" name="TextBox 4"/>
-          <p:cNvSpPr txBox="1"/>
-          <p:nvPr/>
-        </p:nvSpPr>
-        <p:spPr>
-          <a:xfrm>
-            <a:off x="640080" y="5806440"/>
-            <a:ext cx="10881360" cy="731520"/>
-          </a:xfrm>
-          <a:prstGeom prst="rect">
-            <a:avLst/>
-          </a:prstGeom>
-          <a:noFill/>
-        </p:spPr>
-        <p:txBody>
-          <a:bodyPr wrap="square">
-            <a:spAutoFit/>
-          </a:bodyPr>
-          <a:lstStyle/>
-          <a:p>
-            <a:pPr algn="l"/>
-            <a:r>
-              <a:rPr sz="1600" b="0">
-                <a:solidFill>
-                  <a:srgbClr val="64748B"/>
-                </a:solidFill>
-              </a:rPr>
-              <a:t>People who track their training see progress, and people who train with a partner skip fewer sessions.</a:t>
-            </a:r>
-          </a:p>
-        </p:txBody>
-      </p:sp>
-    </p:spTree>
-  </p:cSld>
-  <p:clrMapOvr>
-    <a:masterClrMapping/>
-  </p:clrMapOvr>
-</p:sld>
-</file>
-
-<file path=ppt/slides/slide4.xml><?xml version="1.0" encoding="utf-8"?>
-<p:sld xmlns:a="http://schemas.openxmlformats.org/drawingml/2006/main" xmlns:p="http://schemas.openxmlformats.org/presentationml/2006/main" xmlns:r="http://schemas.openxmlformats.org/officeDocument/2006/relationships">
-  <p:cSld>
-    <p:spTree>
-      <p:nvGrpSpPr>
-        <p:cNvPr id="1" name=""/>
-        <p:cNvGrpSpPr/>
-        <p:nvPr/>
-      </p:nvGrpSpPr>
-      <p:grpSpPr/>
-      <p:sp>
-        <p:nvSpPr>
-          <p:cNvPr id="2" name="Rectangle 1"/>
-          <p:cNvSpPr/>
-          <p:nvPr/>
-        </p:nvSpPr>
-        <p:spPr>
-          <a:xfrm>
-            <a:off x="0" y="0"/>
-            <a:ext cx="12191695" cy="1097280"/>
-          </a:xfrm>
-          <a:prstGeom prst="rect">
-            <a:avLst/>
-          </a:prstGeom>
-          <a:solidFill>
-            <a:srgbClr val="111827"/>
-          </a:solidFill>
-          <a:ln>
-            <a:noFill/>
-          </a:ln>
-          <a:effectLst/>
-        </p:spPr>
-        <p:style>
-          <a:lnRef idx="1">
-            <a:schemeClr val="accent1"/>
-          </a:lnRef>
-          <a:fillRef idx="3">
-            <a:schemeClr val="accent1"/>
-          </a:fillRef>
-          <a:effectRef idx="2">
-            <a:schemeClr val="accent1"/>
-          </a:effectRef>
-          <a:fontRef idx="minor">
-            <a:schemeClr val="lt1"/>
-          </a:fontRef>
-        </p:style>
-        <p:txBody>
-          <a:bodyPr rtlCol="0" anchor="ctr" wrap="square" lIns="457200" rIns="457200" tIns="73152" bIns="73152"/>
-          <a:lstStyle/>
-          <a:p>
-            <a:pPr algn="ctr"/>
-            <a:r>
-              <a:rPr sz="3200" b="1">
-                <a:solidFill>
-                  <a:srgbClr val="FFFFFF"/>
-                </a:solidFill>
-              </a:rPr>
-              <a:t>The problem</a:t>
-            </a:r>
-          </a:p>
-          <a:p>
-            <a:pPr algn="l"/>
-            <a:r>
-              <a:rPr sz="1500" b="0">
-                <a:solidFill>
-                  <a:srgbClr val="FDBA74"/>
-                </a:solidFill>
-              </a:rPr>
-              <a:t>One sentence: who has what problem, and why it matters</a:t>
-            </a:r>
-          </a:p>
-        </p:txBody>
-      </p:sp>
-      <p:sp>
-        <p:nvSpPr>
-          <p:cNvPr id="3" name="Rectangle 2"/>
-          <p:cNvSpPr/>
-          <p:nvPr/>
-        </p:nvSpPr>
-        <p:spPr>
-          <a:xfrm>
-            <a:off x="0" y="1097280"/>
-            <a:ext cx="12191695" cy="64008"/>
-          </a:xfrm>
-          <a:prstGeom prst="rect">
-            <a:avLst/>
-          </a:prstGeom>
-          <a:solidFill>
-            <a:srgbClr val="F97316"/>
-          </a:solidFill>
-          <a:ln>
-            <a:noFill/>
-          </a:ln>
-          <a:effectLst/>
-        </p:spPr>
-        <p:style>
-          <a:lnRef idx="1">
-            <a:schemeClr val="accent1"/>
-          </a:lnRef>
-          <a:fillRef idx="3">
-            <a:schemeClr val="accent1"/>
-          </a:fillRef>
-          <a:effectRef idx="2">
-            <a:schemeClr val="accent1"/>
-          </a:effectRef>
-          <a:fontRef idx="minor">
-            <a:schemeClr val="lt1"/>
-          </a:fontRef>
-        </p:style>
-        <p:txBody>
-          <a:bodyPr rtlCol="0" anchor="ctr"/>
-          <a:lstStyle/>
-          <a:p>
-            <a:pPr algn="ctr"/>
-          </a:p>
-        </p:txBody>
-      </p:sp>
-      <p:sp>
-        <p:nvSpPr>
           <p:cNvPr id="4" name="Rounded Rectangle 3"/>
           <p:cNvSpPr/>
           <p:nvPr/>
@@ -7077,7 +5656,7 @@
 </p:sld>
 </file>
 
-<file path=ppt/slides/slide5.xml><?xml version="1.0" encoding="utf-8"?>
+<file path=ppt/slides/slide4.xml><?xml version="1.0" encoding="utf-8"?>
 <p:sld xmlns:a="http://schemas.openxmlformats.org/drawingml/2006/main" xmlns:p="http://schemas.openxmlformats.org/presentationml/2006/main" xmlns:r="http://schemas.openxmlformats.org/officeDocument/2006/relationships">
   <p:cSld>
     <p:spTree>
@@ -7653,7 +6232,7 @@
 </p:sld>
 </file>
 
-<file path=ppt/slides/slide6.xml><?xml version="1.0" encoding="utf-8"?>
+<file path=ppt/slides/slide5.xml><?xml version="1.0" encoding="utf-8"?>
 <p:sld xmlns:a="http://schemas.openxmlformats.org/drawingml/2006/main" xmlns:p="http://schemas.openxmlformats.org/presentationml/2006/main" xmlns:r="http://schemas.openxmlformats.org/officeDocument/2006/relationships">
   <p:cSld>
     <p:spTree>
@@ -7836,7 +6415,7 @@
 </p:sld>
 </file>
 
-<file path=ppt/slides/slide7.xml><?xml version="1.0" encoding="utf-8"?>
+<file path=ppt/slides/slide6.xml><?xml version="1.0" encoding="utf-8"?>
 <p:sld xmlns:a="http://schemas.openxmlformats.org/drawingml/2006/main" xmlns:p="http://schemas.openxmlformats.org/presentationml/2006/main" xmlns:r="http://schemas.openxmlformats.org/officeDocument/2006/relationships">
   <p:cSld>
     <p:spTree>
@@ -8197,7 +6776,7 @@
 </p:sld>
 </file>
 
-<file path=ppt/slides/slide8.xml><?xml version="1.0" encoding="utf-8"?>
+<file path=ppt/slides/slide7.xml><?xml version="1.0" encoding="utf-8"?>
 <p:sld xmlns:a="http://schemas.openxmlformats.org/drawingml/2006/main" xmlns:p="http://schemas.openxmlformats.org/presentationml/2006/main" xmlns:r="http://schemas.openxmlformats.org/officeDocument/2006/relationships">
   <p:cSld>
     <p:spTree>
@@ -8891,7 +7470,7 @@
 </p:sld>
 </file>
 
-<file path=ppt/slides/slide9.xml><?xml version="1.0" encoding="utf-8"?>
+<file path=ppt/slides/slide8.xml><?xml version="1.0" encoding="utf-8"?>
 <p:sld xmlns:a="http://schemas.openxmlformats.org/drawingml/2006/main" xmlns:p="http://schemas.openxmlformats.org/presentationml/2006/main" xmlns:r="http://schemas.openxmlformats.org/officeDocument/2006/relationships">
   <p:cSld>
     <p:spTree>
@@ -9291,6 +7870,517 @@
                 </a:solidFill>
               </a:rPr>
               <a:t> the PR says “Closes #issue”, so the issue moves to Done on merge.</a:t>
+            </a:r>
+          </a:p>
+        </p:txBody>
+      </p:sp>
+    </p:spTree>
+  </p:cSld>
+  <p:clrMapOvr>
+    <a:masterClrMapping/>
+  </p:clrMapOvr>
+</p:sld>
+</file>
+
+<file path=ppt/slides/slide9.xml><?xml version="1.0" encoding="utf-8"?>
+<p:sld xmlns:a="http://schemas.openxmlformats.org/drawingml/2006/main" xmlns:p="http://schemas.openxmlformats.org/presentationml/2006/main" xmlns:r="http://schemas.openxmlformats.org/officeDocument/2006/relationships">
+  <p:cSld>
+    <p:spTree>
+      <p:nvGrpSpPr>
+        <p:cNvPr id="1" name=""/>
+        <p:cNvGrpSpPr/>
+        <p:nvPr/>
+      </p:nvGrpSpPr>
+      <p:grpSpPr/>
+      <p:sp>
+        <p:nvSpPr>
+          <p:cNvPr id="2" name="Rectangle 1"/>
+          <p:cNvSpPr/>
+          <p:nvPr/>
+        </p:nvSpPr>
+        <p:spPr>
+          <a:xfrm>
+            <a:off x="0" y="0"/>
+            <a:ext cx="12191695" cy="1097280"/>
+          </a:xfrm>
+          <a:prstGeom prst="rect">
+            <a:avLst/>
+          </a:prstGeom>
+          <a:solidFill>
+            <a:srgbClr val="111827"/>
+          </a:solidFill>
+          <a:ln>
+            <a:noFill/>
+          </a:ln>
+          <a:effectLst/>
+        </p:spPr>
+        <p:style>
+          <a:lnRef idx="1">
+            <a:schemeClr val="accent1"/>
+          </a:lnRef>
+          <a:fillRef idx="3">
+            <a:schemeClr val="accent1"/>
+          </a:fillRef>
+          <a:effectRef idx="2">
+            <a:schemeClr val="accent1"/>
+          </a:effectRef>
+          <a:fontRef idx="minor">
+            <a:schemeClr val="lt1"/>
+          </a:fontRef>
+        </p:style>
+        <p:txBody>
+          <a:bodyPr rtlCol="0" anchor="ctr" wrap="square" lIns="457200" rIns="457200" tIns="73152" bIns="73152"/>
+          <a:lstStyle/>
+          <a:p>
+            <a:pPr algn="ctr"/>
+            <a:r>
+              <a:rPr sz="3200" b="1">
+                <a:solidFill>
+                  <a:srgbClr val="FFFFFF"/>
+                </a:solidFill>
+              </a:rPr>
+              <a:t>Sprint 1 backlog</a:t>
+            </a:r>
+          </a:p>
+          <a:p>
+            <a:pPr algn="l"/>
+            <a:r>
+              <a:rPr sz="1500" b="0">
+                <a:solidFill>
+                  <a:srgbClr val="FDBA74"/>
+                </a:solidFill>
+              </a:rPr>
+              <a:t>Each story has acceptance criteria and an assignee</a:t>
+            </a:r>
+          </a:p>
+        </p:txBody>
+      </p:sp>
+      <p:sp>
+        <p:nvSpPr>
+          <p:cNvPr id="3" name="Rectangle 2"/>
+          <p:cNvSpPr/>
+          <p:nvPr/>
+        </p:nvSpPr>
+        <p:spPr>
+          <a:xfrm>
+            <a:off x="0" y="1097280"/>
+            <a:ext cx="12191695" cy="64008"/>
+          </a:xfrm>
+          <a:prstGeom prst="rect">
+            <a:avLst/>
+          </a:prstGeom>
+          <a:solidFill>
+            <a:srgbClr val="F97316"/>
+          </a:solidFill>
+          <a:ln>
+            <a:noFill/>
+          </a:ln>
+          <a:effectLst/>
+        </p:spPr>
+        <p:style>
+          <a:lnRef idx="1">
+            <a:schemeClr val="accent1"/>
+          </a:lnRef>
+          <a:fillRef idx="3">
+            <a:schemeClr val="accent1"/>
+          </a:fillRef>
+          <a:effectRef idx="2">
+            <a:schemeClr val="accent1"/>
+          </a:effectRef>
+          <a:fontRef idx="minor">
+            <a:schemeClr val="lt1"/>
+          </a:fontRef>
+        </p:style>
+        <p:txBody>
+          <a:bodyPr rtlCol="0" anchor="ctr"/>
+          <a:lstStyle/>
+          <a:p>
+            <a:pPr algn="ctr"/>
+          </a:p>
+        </p:txBody>
+      </p:sp>
+      <p:graphicFrame>
+        <p:nvGraphicFramePr>
+          <p:cNvPr id="4" name="Table 3"/>
+          <p:cNvGraphicFramePr>
+            <a:graphicFrameLocks noGrp="1"/>
+          </p:cNvGraphicFramePr>
+          <p:nvPr/>
+        </p:nvGraphicFramePr>
+        <p:xfrm>
+          <a:off x="640080" y="1645920"/>
+          <a:ext cx="10881360" cy="3657600"/>
+        </p:xfrm>
+        <a:graphic>
+          <a:graphicData uri="http://schemas.openxmlformats.org/drawingml/2006/table">
+            <a:tbl>
+              <a:tblPr firstRow="1" bandRow="1">
+                <a:tableStyleId>{5C22544A-7EE6-4342-B048-85BDC9FD1C3A}</a:tableStyleId>
+              </a:tblPr>
+              <a:tblGrid>
+                <a:gridCol w="6035040"/>
+                <a:gridCol w="3566160"/>
+                <a:gridCol w="1280160"/>
+              </a:tblGrid>
+              <a:tr h="731520">
+                <a:tc>
+                  <a:txBody>
+                    <a:bodyPr/>
+                    <a:lstStyle/>
+                    <a:p>
+                      <a:r>
+                        <a:rPr sz="1600" b="1">
+                          <a:solidFill>
+                            <a:srgbClr val="FFFFFF"/>
+                          </a:solidFill>
+                        </a:rPr>
+                        <a:t>User story</a:t>
+                      </a:r>
+                    </a:p>
+                  </a:txBody>
+                  <a:tcPr>
+                    <a:solidFill>
+                      <a:srgbClr val="111827"/>
+                    </a:solidFill>
+                  </a:tcPr>
+                </a:tc>
+                <a:tc>
+                  <a:txBody>
+                    <a:bodyPr/>
+                    <a:lstStyle/>
+                    <a:p>
+                      <a:r>
+                        <a:rPr sz="1600" b="1">
+                          <a:solidFill>
+                            <a:srgbClr val="FFFFFF"/>
+                          </a:solidFill>
+                        </a:rPr>
+                        <a:t>Labels</a:t>
+                      </a:r>
+                    </a:p>
+                  </a:txBody>
+                  <a:tcPr>
+                    <a:solidFill>
+                      <a:srgbClr val="111827"/>
+                    </a:solidFill>
+                  </a:tcPr>
+                </a:tc>
+                <a:tc>
+                  <a:txBody>
+                    <a:bodyPr/>
+                    <a:lstStyle/>
+                    <a:p>
+                      <a:r>
+                        <a:rPr sz="1600" b="1">
+                          <a:solidFill>
+                            <a:srgbClr val="FFFFFF"/>
+                          </a:solidFill>
+                        </a:rPr>
+                        <a:t>Assignee</a:t>
+                      </a:r>
+                    </a:p>
+                  </a:txBody>
+                  <a:tcPr>
+                    <a:solidFill>
+                      <a:srgbClr val="111827"/>
+                    </a:solidFill>
+                  </a:tcPr>
+                </a:tc>
+              </a:tr>
+              <a:tr h="731520">
+                <a:tc>
+                  <a:txBody>
+                    <a:bodyPr/>
+                    <a:lstStyle/>
+                    <a:p>
+                      <a:r>
+                        <a:rPr sz="1600" b="0">
+                          <a:solidFill>
+                            <a:srgbClr val="0F172A"/>
+                          </a:solidFill>
+                        </a:rPr>
+                        <a:t>As a gym-goer, I want to register and log in with email and password</a:t>
+                      </a:r>
+                    </a:p>
+                  </a:txBody>
+                  <a:tcPr>
+                    <a:solidFill>
+                      <a:srgbClr val="F1F5F9"/>
+                    </a:solidFill>
+                  </a:tcPr>
+                </a:tc>
+                <a:tc>
+                  <a:txBody>
+                    <a:bodyPr/>
+                    <a:lstStyle/>
+                    <a:p>
+                      <a:r>
+                        <a:rPr sz="1600" b="0">
+                          <a:solidFill>
+                            <a:srgbClr val="0F172A"/>
+                          </a:solidFill>
+                        </a:rPr>
+                        <a:t>user-story · android · firebase</a:t>
+                      </a:r>
+                    </a:p>
+                  </a:txBody>
+                  <a:tcPr>
+                    <a:solidFill>
+                      <a:srgbClr val="F1F5F9"/>
+                    </a:solidFill>
+                  </a:tcPr>
+                </a:tc>
+                <a:tc>
+                  <a:txBody>
+                    <a:bodyPr/>
+                    <a:lstStyle/>
+                    <a:p>
+                      <a:r>
+                        <a:rPr sz="1600" b="0">
+                          <a:solidFill>
+                            <a:srgbClr val="0F172A"/>
+                          </a:solidFill>
+                        </a:rPr>
+                        <a:t>Ozodbek</a:t>
+                      </a:r>
+                    </a:p>
+                  </a:txBody>
+                  <a:tcPr>
+                    <a:solidFill>
+                      <a:srgbClr val="F1F5F9"/>
+                    </a:solidFill>
+                  </a:tcPr>
+                </a:tc>
+              </a:tr>
+              <a:tr h="731520">
+                <a:tc>
+                  <a:txBody>
+                    <a:bodyPr/>
+                    <a:lstStyle/>
+                    <a:p>
+                      <a:r>
+                        <a:rPr sz="1600" b="0">
+                          <a:solidFill>
+                            <a:srgbClr val="0F172A"/>
+                          </a:solidFill>
+                        </a:rPr>
+                        <a:t>As a gym-goer, I want to see a list of my workouts</a:t>
+                      </a:r>
+                    </a:p>
+                  </a:txBody>
+                  <a:tcPr>
+                    <a:solidFill>
+                      <a:srgbClr val="FFFFFF"/>
+                    </a:solidFill>
+                  </a:tcPr>
+                </a:tc>
+                <a:tc>
+                  <a:txBody>
+                    <a:bodyPr/>
+                    <a:lstStyle/>
+                    <a:p>
+                      <a:r>
+                        <a:rPr sz="1600" b="0">
+                          <a:solidFill>
+                            <a:srgbClr val="0F172A"/>
+                          </a:solidFill>
+                        </a:rPr>
+                        <a:t>user-story · android · ui</a:t>
+                      </a:r>
+                    </a:p>
+                  </a:txBody>
+                  <a:tcPr>
+                    <a:solidFill>
+                      <a:srgbClr val="FFFFFF"/>
+                    </a:solidFill>
+                  </a:tcPr>
+                </a:tc>
+                <a:tc>
+                  <a:txBody>
+                    <a:bodyPr/>
+                    <a:lstStyle/>
+                    <a:p>
+                      <a:r>
+                        <a:rPr sz="1600" b="0">
+                          <a:solidFill>
+                            <a:srgbClr val="0F172A"/>
+                          </a:solidFill>
+                        </a:rPr>
+                        <a:t>Elturan</a:t>
+                      </a:r>
+                    </a:p>
+                  </a:txBody>
+                  <a:tcPr>
+                    <a:solidFill>
+                      <a:srgbClr val="FFFFFF"/>
+                    </a:solidFill>
+                  </a:tcPr>
+                </a:tc>
+              </a:tr>
+              <a:tr h="731520">
+                <a:tc>
+                  <a:txBody>
+                    <a:bodyPr/>
+                    <a:lstStyle/>
+                    <a:p>
+                      <a:r>
+                        <a:rPr sz="1600" b="0">
+                          <a:solidFill>
+                            <a:srgbClr val="0F172A"/>
+                          </a:solidFill>
+                        </a:rPr>
+                        <a:t>As a gym-goer, I want to add a workout</a:t>
+                      </a:r>
+                    </a:p>
+                  </a:txBody>
+                  <a:tcPr>
+                    <a:solidFill>
+                      <a:srgbClr val="F1F5F9"/>
+                    </a:solidFill>
+                  </a:tcPr>
+                </a:tc>
+                <a:tc>
+                  <a:txBody>
+                    <a:bodyPr/>
+                    <a:lstStyle/>
+                    <a:p>
+                      <a:r>
+                        <a:rPr sz="1600" b="0">
+                          <a:solidFill>
+                            <a:srgbClr val="0F172A"/>
+                          </a:solidFill>
+                        </a:rPr>
+                        <a:t>user-story · android · firebase</a:t>
+                      </a:r>
+                    </a:p>
+                  </a:txBody>
+                  <a:tcPr>
+                    <a:solidFill>
+                      <a:srgbClr val="F1F5F9"/>
+                    </a:solidFill>
+                  </a:tcPr>
+                </a:tc>
+                <a:tc>
+                  <a:txBody>
+                    <a:bodyPr/>
+                    <a:lstStyle/>
+                    <a:p>
+                      <a:r>
+                        <a:rPr sz="1600" b="0">
+                          <a:solidFill>
+                            <a:srgbClr val="0F172A"/>
+                          </a:solidFill>
+                        </a:rPr>
+                        <a:t>Aida</a:t>
+                      </a:r>
+                    </a:p>
+                  </a:txBody>
+                  <a:tcPr>
+                    <a:solidFill>
+                      <a:srgbClr val="F1F5F9"/>
+                    </a:solidFill>
+                  </a:tcPr>
+                </a:tc>
+              </a:tr>
+              <a:tr h="731520">
+                <a:tc>
+                  <a:txBody>
+                    <a:bodyPr/>
+                    <a:lstStyle/>
+                    <a:p>
+                      <a:r>
+                        <a:rPr sz="1600" b="0">
+                          <a:solidFill>
+                            <a:srgbClr val="0F172A"/>
+                          </a:solidFill>
+                        </a:rPr>
+                        <a:t>As a gym-goer, I want to edit or delete a workout</a:t>
+                      </a:r>
+                    </a:p>
+                  </a:txBody>
+                  <a:tcPr>
+                    <a:solidFill>
+                      <a:srgbClr val="FFFFFF"/>
+                    </a:solidFill>
+                  </a:tcPr>
+                </a:tc>
+                <a:tc>
+                  <a:txBody>
+                    <a:bodyPr/>
+                    <a:lstStyle/>
+                    <a:p>
+                      <a:r>
+                        <a:rPr sz="1600" b="0">
+                          <a:solidFill>
+                            <a:srgbClr val="0F172A"/>
+                          </a:solidFill>
+                        </a:rPr>
+                        <a:t>user-story · android · firebase</a:t>
+                      </a:r>
+                    </a:p>
+                  </a:txBody>
+                  <a:tcPr>
+                    <a:solidFill>
+                      <a:srgbClr val="FFFFFF"/>
+                    </a:solidFill>
+                  </a:tcPr>
+                </a:tc>
+                <a:tc>
+                  <a:txBody>
+                    <a:bodyPr/>
+                    <a:lstStyle/>
+                    <a:p>
+                      <a:r>
+                        <a:rPr sz="1600" b="0">
+                          <a:solidFill>
+                            <a:srgbClr val="0F172A"/>
+                          </a:solidFill>
+                        </a:rPr>
+                        <a:t>Elturan</a:t>
+                      </a:r>
+                    </a:p>
+                  </a:txBody>
+                  <a:tcPr>
+                    <a:solidFill>
+                      <a:srgbClr val="FFFFFF"/>
+                    </a:solidFill>
+                  </a:tcPr>
+                </a:tc>
+              </a:tr>
+            </a:tbl>
+          </a:graphicData>
+        </a:graphic>
+      </p:graphicFrame>
+      <p:sp>
+        <p:nvSpPr>
+          <p:cNvPr id="5" name="TextBox 4"/>
+          <p:cNvSpPr txBox="1"/>
+          <p:nvPr/>
+        </p:nvSpPr>
+        <p:spPr>
+          <a:xfrm>
+            <a:off x="640080" y="5486400"/>
+            <a:ext cx="10881360" cy="914400"/>
+          </a:xfrm>
+          <a:prstGeom prst="rect">
+            <a:avLst/>
+          </a:prstGeom>
+          <a:noFill/>
+        </p:spPr>
+        <p:txBody>
+          <a:bodyPr wrap="square">
+            <a:spAutoFit/>
+          </a:bodyPr>
+          <a:lstStyle/>
+          <a:p>
+            <a:pPr algn="l"/>
+            <a:r>
+              <a:rPr sz="1700" b="0">
+                <a:solidFill>
+                  <a:srgbClr val="64748B"/>
+                </a:solidFill>
+              </a:rPr>
+              <a:t>Backlog: weekly stats Cloud Function, find a partner (sessions).</a:t>
             </a:r>
           </a:p>
         </p:txBody>

</xml_diff>